<commit_message>
Switch brand charts to stacked 100% bars (Medium top, Heavy bottom) with notes
Co-Authored-By: Claude Opus 5.5 <noreply@anthropic.com>
Claude-Session: https://claude.ai/code/session_01Cx9kswyecF7JAB1Rr5vVcV
</commit_message>
<xml_diff>
--- a/nedp_deck/Slide_2025_Medium_Heavy_Funnel.pptx
+++ b/nedp_deck/Slide_2025_Medium_Heavy_Funnel.pptx
@@ -4826,57 +4826,14 @@
       </p:sp>
       <p:sp>
         <p:nvSpPr>
-          <p:cNvPr id="29" name="Chevron 28"/>
+          <p:cNvPr id="29" name="Rectangle 28"/>
           <p:cNvSpPr/>
           <p:nvPr/>
         </p:nvSpPr>
         <p:spPr>
           <a:xfrm>
-            <a:off x="7905750" y="4000500"/>
-            <a:ext cx="171450" cy="342900"/>
-          </a:xfrm>
-          <a:prstGeom prst="chevron">
-            <a:avLst/>
-          </a:prstGeom>
-          <a:solidFill>
-            <a:srgbClr val="1E9E57"/>
-          </a:solidFill>
-          <a:ln>
-            <a:noFill/>
-          </a:ln>
-        </p:spPr>
-        <p:style>
-          <a:lnRef idx="1">
-            <a:schemeClr val="accent1"/>
-          </a:lnRef>
-          <a:fillRef idx="3">
-            <a:schemeClr val="accent1"/>
-          </a:fillRef>
-          <a:effectRef idx="2">
-            <a:schemeClr val="accent1"/>
-          </a:effectRef>
-          <a:fontRef idx="minor">
-            <a:schemeClr val="lt1"/>
-          </a:fontRef>
-        </p:style>
-        <p:txBody>
-          <a:bodyPr rtlCol="0" anchor="ctr"/>
-          <a:lstStyle/>
-          <a:p>
-            <a:pPr algn="ctr"/>
-          </a:p>
-        </p:txBody>
-      </p:sp>
-      <p:sp>
-        <p:nvSpPr>
-          <p:cNvPr id="30" name="Rectangle 29"/>
-          <p:cNvSpPr/>
-          <p:nvPr/>
-        </p:nvSpPr>
-        <p:spPr>
-          <a:xfrm>
             <a:off x="4305300" y="2038350"/>
-            <a:ext cx="3562350" cy="247650"/>
+            <a:ext cx="7543800" cy="247650"/>
           </a:xfrm>
           <a:prstGeom prst="rect">
             <a:avLst/>
@@ -4916,21 +4873,21 @@
                 </a:solidFill>
                 <a:latin typeface="Neue Haas Grotesk Text Pro"/>
               </a:rPr>
-              <a:t>Medium class (25–45 tm): who fills it</a:t>
-            </a:r>
-          </a:p>
-        </p:txBody>
-      </p:sp>
-      <p:sp>
-        <p:nvSpPr>
-          <p:cNvPr id="31" name="Rectangle 30"/>
+              <a:t>Medium &amp; Heavy 2025: who holds the market</a:t>
+            </a:r>
+          </a:p>
+        </p:txBody>
+      </p:sp>
+      <p:sp>
+        <p:nvSpPr>
+          <p:cNvPr id="30" name="Rectangle 29"/>
           <p:cNvSpPr/>
           <p:nvPr/>
         </p:nvSpPr>
         <p:spPr>
           <a:xfrm>
             <a:off x="4305300" y="2286000"/>
-            <a:ext cx="3562350" cy="3924300"/>
+            <a:ext cx="7543800" cy="3924300"/>
           </a:xfrm>
           <a:prstGeom prst="rect">
             <a:avLst/>
@@ -4966,14 +4923,14 @@
       </p:sp>
       <p:sp>
         <p:nvSpPr>
-          <p:cNvPr id="32" name="TextBox 31"/>
+          <p:cNvPr id="31" name="TextBox 30"/>
           <p:cNvSpPr txBox="1"/>
           <p:nvPr/>
         </p:nvSpPr>
         <p:spPr>
           <a:xfrm>
-            <a:off x="4419600" y="2362200"/>
-            <a:ext cx="3333750" cy="323850"/>
+            <a:off x="4438650" y="2381250"/>
+            <a:ext cx="4953000" cy="190500"/>
           </a:xfrm>
           <a:prstGeom prst="rect">
             <a:avLst/>
@@ -4994,7 +4951,7 @@
                 </a:solidFill>
                 <a:latin typeface="Neue Haas Grotesk Text Pro"/>
               </a:rPr>
-              <a:t>Medium class market, 2025, </a:t>
+              <a:t>Medium class (25–45 tm), 2025, </a:t>
             </a:r>
             <a:r>
               <a:rPr sz="1200" b="0">
@@ -5003,21 +4960,21 @@
                 </a:solidFill>
                 <a:latin typeface="Neue Haas Grotesk Text Pro"/>
               </a:rPr>
-              <a:t>n of units by brand</a:t>
-            </a:r>
-          </a:p>
-        </p:txBody>
-      </p:sp>
-      <p:sp>
-        <p:nvSpPr>
-          <p:cNvPr id="33" name="TextBox 32"/>
+              <a:t>share of units by brand</a:t>
+            </a:r>
+          </a:p>
+        </p:txBody>
+      </p:sp>
+      <p:sp>
+        <p:nvSpPr>
+          <p:cNvPr id="32" name="TextBox 31"/>
           <p:cNvSpPr txBox="1"/>
           <p:nvPr/>
         </p:nvSpPr>
         <p:spPr>
           <a:xfrm>
-            <a:off x="4419600" y="2571750"/>
-            <a:ext cx="3333750" cy="171450"/>
+            <a:off x="4438650" y="2571750"/>
+            <a:ext cx="4953000" cy="171450"/>
           </a:xfrm>
           <a:prstGeom prst="rect">
             <a:avLst/>
@@ -5032,27 +4989,27 @@
           <a:p>
             <a:pPr algn="l"/>
             <a:r>
-              <a:rPr sz="1000" b="0">
+              <a:rPr sz="1100" b="1">
                 <a:solidFill>
                   <a:srgbClr val="6B6B6B"/>
                 </a:solidFill>
                 <a:latin typeface="Neue Haas Grotesk Text Pro"/>
               </a:rPr>
-              <a:t>60 units · Rp 28,2 Bio · 25% of market value</a:t>
-            </a:r>
-          </a:p>
-        </p:txBody>
-      </p:sp>
-      <p:sp>
-        <p:nvSpPr>
-          <p:cNvPr id="34" name="Rectangle 33"/>
+              <a:t>60 units  ·  Rp 28,2 Bio  ·  25% of market value</a:t>
+            </a:r>
+          </a:p>
+        </p:txBody>
+      </p:sp>
+      <p:sp>
+        <p:nvSpPr>
+          <p:cNvPr id="33" name="Rectangle 32"/>
           <p:cNvSpPr/>
           <p:nvPr/>
         </p:nvSpPr>
         <p:spPr>
           <a:xfrm>
-            <a:off x="4419600" y="2819400"/>
-            <a:ext cx="1666875" cy="2190750"/>
+            <a:off x="4438650" y="2819400"/>
+            <a:ext cx="2381250" cy="438150"/>
           </a:xfrm>
           <a:prstGeom prst="rect">
             <a:avLst/>
@@ -5081,7 +5038,7 @@
           </a:fontRef>
         </p:style>
         <p:txBody>
-          <a:bodyPr rtlCol="0" anchor="t" wrap="square" lIns="57150" rIns="57150" tIns="47625" bIns="47625"/>
+          <a:bodyPr rtlCol="0" anchor="ctr" lIns="0" rIns="0"/>
           <a:lstStyle/>
           <a:p>
             <a:pPr algn="ctr"/>
@@ -5092,11 +5049,46 @@
                 </a:solidFill>
                 <a:latin typeface="Neue Haas Grotesk Text Pro"/>
               </a:rPr>
-              <a:t>~50%</a:t>
-            </a:r>
-          </a:p>
-        </p:txBody>
-      </p:sp>
+              <a:t>50%</a:t>
+            </a:r>
+          </a:p>
+        </p:txBody>
+      </p:sp>
+      <p:cxnSp>
+        <p:nvCxnSpPr>
+          <p:cNvPr id="34" name="Connector 33"/>
+          <p:cNvCxnSpPr/>
+          <p:nvPr/>
+        </p:nvCxnSpPr>
+        <p:spPr>
+          <a:xfrm>
+            <a:off x="5629275" y="3257550"/>
+            <a:ext cx="0" cy="133350"/>
+          </a:xfrm>
+          <a:prstGeom prst="line">
+            <a:avLst/>
+          </a:prstGeom>
+          <a:ln w="9525">
+            <a:solidFill>
+              <a:srgbClr val="7F7F7F"/>
+            </a:solidFill>
+          </a:ln>
+        </p:spPr>
+        <p:style>
+          <a:lnRef idx="2">
+            <a:schemeClr val="accent1"/>
+          </a:lnRef>
+          <a:fillRef idx="0">
+            <a:schemeClr val="accent1"/>
+          </a:fillRef>
+          <a:effectRef idx="1">
+            <a:schemeClr val="accent1"/>
+          </a:effectRef>
+          <a:fontRef idx="minor">
+            <a:schemeClr val="tx1"/>
+          </a:fontRef>
+        </p:style>
+      </p:cxnSp>
       <p:sp>
         <p:nvSpPr>
           <p:cNvPr id="35" name="TextBox 34"/>
@@ -5105,8 +5097,8 @@
         </p:nvSpPr>
         <p:spPr>
           <a:xfrm>
-            <a:off x="4467225" y="4629150"/>
-            <a:ext cx="1571625" cy="342900"/>
+            <a:off x="5191125" y="3409950"/>
+            <a:ext cx="876300" cy="323850"/>
           </a:xfrm>
           <a:prstGeom prst="rect">
             <a:avLst/>
@@ -5114,20 +5106,32 @@
           <a:noFill/>
         </p:spPr>
         <p:txBody>
-          <a:bodyPr wrap="square" anchor="b" lIns="0" rIns="0" tIns="0" bIns="0">
+          <a:bodyPr wrap="square" anchor="t" lIns="0" rIns="0" tIns="0" bIns="0">
             <a:spAutoFit/>
           </a:bodyPr>
           <a:lstStyle/>
           <a:p>
-            <a:pPr algn="l"/>
-            <a:r>
-              <a:rPr sz="1050" b="1">
-                <a:solidFill>
-                  <a:srgbClr val="FFFFFF"/>
-                </a:solidFill>
-                <a:latin typeface="Neue Haas Grotesk Text Pro"/>
-              </a:rPr>
-              <a:t>Sany Palfinger, 30</a:t>
+            <a:pPr algn="ctr"/>
+            <a:r>
+              <a:rPr sz="1000" b="1">
+                <a:solidFill>
+                  <a:srgbClr val="000000"/>
+                </a:solidFill>
+                <a:latin typeface="Neue Haas Grotesk Text Pro"/>
+              </a:rPr>
+              <a:t>Sany Palfinger</a:t>
+            </a:r>
+          </a:p>
+          <a:p>
+            <a:pPr algn="ctr"/>
+            <a:r>
+              <a:rPr sz="1000" b="0">
+                <a:solidFill>
+                  <a:srgbClr val="6B6B6B"/>
+                </a:solidFill>
+                <a:latin typeface="Neue Haas Grotesk Text Pro"/>
+              </a:rPr>
+              <a:t>30 units</a:t>
             </a:r>
           </a:p>
         </p:txBody>
@@ -5140,8 +5144,144 @@
         </p:nvSpPr>
         <p:spPr>
           <a:xfrm>
-            <a:off x="6086475" y="2819400"/>
-            <a:ext cx="1666875" cy="1022350"/>
+            <a:off x="6819900" y="2819400"/>
+            <a:ext cx="1111250" cy="438150"/>
+          </a:xfrm>
+          <a:prstGeom prst="rect">
+            <a:avLst/>
+          </a:prstGeom>
+          <a:solidFill>
+            <a:srgbClr val="6FCF97"/>
+          </a:solidFill>
+          <a:ln w="19050">
+            <a:solidFill>
+              <a:srgbClr val="FFFFFF"/>
+            </a:solidFill>
+          </a:ln>
+        </p:spPr>
+        <p:style>
+          <a:lnRef idx="1">
+            <a:schemeClr val="accent1"/>
+          </a:lnRef>
+          <a:fillRef idx="3">
+            <a:schemeClr val="accent1"/>
+          </a:fillRef>
+          <a:effectRef idx="2">
+            <a:schemeClr val="accent1"/>
+          </a:effectRef>
+          <a:fontRef idx="minor">
+            <a:schemeClr val="lt1"/>
+          </a:fontRef>
+        </p:style>
+        <p:txBody>
+          <a:bodyPr rtlCol="0" anchor="ctr" lIns="0" rIns="0"/>
+          <a:lstStyle/>
+          <a:p>
+            <a:pPr algn="ctr"/>
+            <a:r>
+              <a:rPr sz="1300" b="1">
+                <a:solidFill>
+                  <a:srgbClr val="000000"/>
+                </a:solidFill>
+                <a:latin typeface="Neue Haas Grotesk Text Pro"/>
+              </a:rPr>
+              <a:t>23%</a:t>
+            </a:r>
+          </a:p>
+        </p:txBody>
+      </p:sp>
+      <p:cxnSp>
+        <p:nvCxnSpPr>
+          <p:cNvPr id="37" name="Connector 36"/>
+          <p:cNvCxnSpPr/>
+          <p:nvPr/>
+        </p:nvCxnSpPr>
+        <p:spPr>
+          <a:xfrm>
+            <a:off x="7375525" y="3257550"/>
+            <a:ext cx="0" cy="133350"/>
+          </a:xfrm>
+          <a:prstGeom prst="line">
+            <a:avLst/>
+          </a:prstGeom>
+          <a:ln w="9525">
+            <a:solidFill>
+              <a:srgbClr val="7F7F7F"/>
+            </a:solidFill>
+          </a:ln>
+        </p:spPr>
+        <p:style>
+          <a:lnRef idx="2">
+            <a:schemeClr val="accent1"/>
+          </a:lnRef>
+          <a:fillRef idx="0">
+            <a:schemeClr val="accent1"/>
+          </a:fillRef>
+          <a:effectRef idx="1">
+            <a:schemeClr val="accent1"/>
+          </a:effectRef>
+          <a:fontRef idx="minor">
+            <a:schemeClr val="tx1"/>
+          </a:fontRef>
+        </p:style>
+      </p:cxnSp>
+      <p:sp>
+        <p:nvSpPr>
+          <p:cNvPr id="38" name="TextBox 37"/>
+          <p:cNvSpPr txBox="1"/>
+          <p:nvPr/>
+        </p:nvSpPr>
+        <p:spPr>
+          <a:xfrm>
+            <a:off x="6937375" y="3409950"/>
+            <a:ext cx="876300" cy="323850"/>
+          </a:xfrm>
+          <a:prstGeom prst="rect">
+            <a:avLst/>
+          </a:prstGeom>
+          <a:noFill/>
+        </p:spPr>
+        <p:txBody>
+          <a:bodyPr wrap="square" anchor="t" lIns="0" rIns="0" tIns="0" bIns="0">
+            <a:spAutoFit/>
+          </a:bodyPr>
+          <a:lstStyle/>
+          <a:p>
+            <a:pPr algn="ctr"/>
+            <a:r>
+              <a:rPr sz="1000" b="0">
+                <a:solidFill>
+                  <a:srgbClr val="000000"/>
+                </a:solidFill>
+                <a:latin typeface="Neue Haas Grotesk Text Pro"/>
+              </a:rPr>
+              <a:t>XCMG</a:t>
+            </a:r>
+          </a:p>
+          <a:p>
+            <a:pPr algn="ctr"/>
+            <a:r>
+              <a:rPr sz="1000" b="0">
+                <a:solidFill>
+                  <a:srgbClr val="6B6B6B"/>
+                </a:solidFill>
+                <a:latin typeface="Neue Haas Grotesk Text Pro"/>
+              </a:rPr>
+              <a:t>14 units</a:t>
+            </a:r>
+          </a:p>
+        </p:txBody>
+      </p:sp>
+      <p:sp>
+        <p:nvSpPr>
+          <p:cNvPr id="39" name="Rectangle 38"/>
+          <p:cNvSpPr/>
+          <p:nvPr/>
+        </p:nvSpPr>
+        <p:spPr>
+          <a:xfrm>
+            <a:off x="7931150" y="2819400"/>
+            <a:ext cx="396875" cy="438150"/>
           </a:xfrm>
           <a:prstGeom prst="rect">
             <a:avLst/>
@@ -5170,7 +5310,7 @@
           </a:fontRef>
         </p:style>
         <p:txBody>
-          <a:bodyPr rtlCol="0" anchor="t" wrap="square" lIns="57150" rIns="57150" tIns="47625" bIns="47625"/>
+          <a:bodyPr rtlCol="0" anchor="ctr" lIns="0" rIns="0"/>
           <a:lstStyle/>
           <a:p>
             <a:pPr algn="ctr"/>
@@ -5181,21 +5321,56 @@
                 </a:solidFill>
                 <a:latin typeface="Neue Haas Grotesk Text Pro"/>
               </a:rPr>
-              <a:t>~23%</a:t>
-            </a:r>
-          </a:p>
-        </p:txBody>
-      </p:sp>
-      <p:sp>
-        <p:nvSpPr>
-          <p:cNvPr id="37" name="TextBox 36"/>
+              <a:t>8%</a:t>
+            </a:r>
+          </a:p>
+        </p:txBody>
+      </p:sp>
+      <p:cxnSp>
+        <p:nvCxnSpPr>
+          <p:cNvPr id="40" name="Connector 39"/>
+          <p:cNvCxnSpPr/>
+          <p:nvPr/>
+        </p:nvCxnSpPr>
+        <p:spPr>
+          <a:xfrm>
+            <a:off x="8129588" y="3257550"/>
+            <a:ext cx="0" cy="133350"/>
+          </a:xfrm>
+          <a:prstGeom prst="line">
+            <a:avLst/>
+          </a:prstGeom>
+          <a:ln w="9525">
+            <a:solidFill>
+              <a:srgbClr val="7F7F7F"/>
+            </a:solidFill>
+          </a:ln>
+        </p:spPr>
+        <p:style>
+          <a:lnRef idx="2">
+            <a:schemeClr val="accent1"/>
+          </a:lnRef>
+          <a:fillRef idx="0">
+            <a:schemeClr val="accent1"/>
+          </a:fillRef>
+          <a:effectRef idx="1">
+            <a:schemeClr val="accent1"/>
+          </a:effectRef>
+          <a:fontRef idx="minor">
+            <a:schemeClr val="tx1"/>
+          </a:fontRef>
+        </p:style>
+      </p:cxnSp>
+      <p:sp>
+        <p:nvSpPr>
+          <p:cNvPr id="41" name="TextBox 40"/>
           <p:cNvSpPr txBox="1"/>
           <p:nvPr/>
         </p:nvSpPr>
         <p:spPr>
           <a:xfrm>
-            <a:off x="6134100" y="3460750"/>
-            <a:ext cx="1571625" cy="342900"/>
+            <a:off x="7691438" y="3409950"/>
+            <a:ext cx="876300" cy="323850"/>
           </a:xfrm>
           <a:prstGeom prst="rect">
             <a:avLst/>
@@ -5203,34 +5378,723 @@
           <a:noFill/>
         </p:spPr>
         <p:txBody>
-          <a:bodyPr wrap="square" anchor="b" lIns="0" rIns="0" tIns="0" bIns="0">
+          <a:bodyPr wrap="square" anchor="t" lIns="0" rIns="0" tIns="0" bIns="0">
             <a:spAutoFit/>
           </a:bodyPr>
           <a:lstStyle/>
           <a:p>
-            <a:pPr algn="l"/>
-            <a:r>
-              <a:rPr sz="1050" b="1">
-                <a:solidFill>
-                  <a:srgbClr val="FFFFFF"/>
-                </a:solidFill>
-                <a:latin typeface="Neue Haas Grotesk Text Pro"/>
-              </a:rPr>
-              <a:t>XCMG, 14</a:t>
-            </a:r>
-          </a:p>
-        </p:txBody>
-      </p:sp>
-      <p:sp>
-        <p:nvSpPr>
-          <p:cNvPr id="38" name="Rectangle 37"/>
+            <a:pPr algn="ctr"/>
+            <a:r>
+              <a:rPr sz="1000" b="0">
+                <a:solidFill>
+                  <a:srgbClr val="000000"/>
+                </a:solidFill>
+                <a:latin typeface="Neue Haas Grotesk Text Pro"/>
+              </a:rPr>
+              <a:t>Palfinger</a:t>
+            </a:r>
+          </a:p>
+          <a:p>
+            <a:pPr algn="ctr"/>
+            <a:r>
+              <a:rPr sz="1000" b="0">
+                <a:solidFill>
+                  <a:srgbClr val="6B6B6B"/>
+                </a:solidFill>
+                <a:latin typeface="Neue Haas Grotesk Text Pro"/>
+              </a:rPr>
+              <a:t>5 units</a:t>
+            </a:r>
+          </a:p>
+        </p:txBody>
+      </p:sp>
+      <p:sp>
+        <p:nvSpPr>
+          <p:cNvPr id="42" name="Rectangle 41"/>
           <p:cNvSpPr/>
           <p:nvPr/>
         </p:nvSpPr>
         <p:spPr>
           <a:xfrm>
-            <a:off x="6086475" y="3841750"/>
-            <a:ext cx="520898" cy="1168400"/>
+            <a:off x="8328025" y="2819400"/>
+            <a:ext cx="873125" cy="438150"/>
+          </a:xfrm>
+          <a:prstGeom prst="rect">
+            <a:avLst/>
+          </a:prstGeom>
+          <a:solidFill>
+            <a:srgbClr val="D9D9D9"/>
+          </a:solidFill>
+          <a:ln w="19050">
+            <a:solidFill>
+              <a:srgbClr val="FFFFFF"/>
+            </a:solidFill>
+          </a:ln>
+        </p:spPr>
+        <p:style>
+          <a:lnRef idx="1">
+            <a:schemeClr val="accent1"/>
+          </a:lnRef>
+          <a:fillRef idx="3">
+            <a:schemeClr val="accent1"/>
+          </a:fillRef>
+          <a:effectRef idx="2">
+            <a:schemeClr val="accent1"/>
+          </a:effectRef>
+          <a:fontRef idx="minor">
+            <a:schemeClr val="lt1"/>
+          </a:fontRef>
+        </p:style>
+        <p:txBody>
+          <a:bodyPr rtlCol="0" anchor="ctr" lIns="0" rIns="0"/>
+          <a:lstStyle/>
+          <a:p>
+            <a:pPr algn="ctr"/>
+            <a:r>
+              <a:rPr sz="1300" b="1">
+                <a:solidFill>
+                  <a:srgbClr val="000000"/>
+                </a:solidFill>
+                <a:latin typeface="Neue Haas Grotesk Text Pro"/>
+              </a:rPr>
+              <a:t>18%</a:t>
+            </a:r>
+          </a:p>
+        </p:txBody>
+      </p:sp>
+      <p:cxnSp>
+        <p:nvCxnSpPr>
+          <p:cNvPr id="43" name="Connector 42"/>
+          <p:cNvCxnSpPr/>
+          <p:nvPr/>
+        </p:nvCxnSpPr>
+        <p:spPr>
+          <a:xfrm>
+            <a:off x="8764588" y="3257550"/>
+            <a:ext cx="0" cy="133350"/>
+          </a:xfrm>
+          <a:prstGeom prst="line">
+            <a:avLst/>
+          </a:prstGeom>
+          <a:ln w="9525">
+            <a:solidFill>
+              <a:srgbClr val="7F7F7F"/>
+            </a:solidFill>
+          </a:ln>
+        </p:spPr>
+        <p:style>
+          <a:lnRef idx="2">
+            <a:schemeClr val="accent1"/>
+          </a:lnRef>
+          <a:fillRef idx="0">
+            <a:schemeClr val="accent1"/>
+          </a:fillRef>
+          <a:effectRef idx="1">
+            <a:schemeClr val="accent1"/>
+          </a:effectRef>
+          <a:fontRef idx="minor">
+            <a:schemeClr val="tx1"/>
+          </a:fontRef>
+        </p:style>
+      </p:cxnSp>
+      <p:sp>
+        <p:nvSpPr>
+          <p:cNvPr id="44" name="TextBox 43"/>
+          <p:cNvSpPr txBox="1"/>
+          <p:nvPr/>
+        </p:nvSpPr>
+        <p:spPr>
+          <a:xfrm>
+            <a:off x="8326438" y="3409950"/>
+            <a:ext cx="876300" cy="323850"/>
+          </a:xfrm>
+          <a:prstGeom prst="rect">
+            <a:avLst/>
+          </a:prstGeom>
+          <a:noFill/>
+        </p:spPr>
+        <p:txBody>
+          <a:bodyPr wrap="square" anchor="t" lIns="0" rIns="0" tIns="0" bIns="0">
+            <a:spAutoFit/>
+          </a:bodyPr>
+          <a:lstStyle/>
+          <a:p>
+            <a:pPr algn="ctr"/>
+            <a:r>
+              <a:rPr sz="1000" b="0">
+                <a:solidFill>
+                  <a:srgbClr val="000000"/>
+                </a:solidFill>
+                <a:latin typeface="Neue Haas Grotesk Text Pro"/>
+              </a:rPr>
+              <a:t>Others</a:t>
+            </a:r>
+          </a:p>
+          <a:p>
+            <a:pPr algn="ctr"/>
+            <a:r>
+              <a:rPr sz="1000" b="0">
+                <a:solidFill>
+                  <a:srgbClr val="6B6B6B"/>
+                </a:solidFill>
+                <a:latin typeface="Neue Haas Grotesk Text Pro"/>
+              </a:rPr>
+              <a:t>11 units</a:t>
+            </a:r>
+          </a:p>
+        </p:txBody>
+      </p:sp>
+      <p:sp>
+        <p:nvSpPr>
+          <p:cNvPr id="45" name="Rectangle 44"/>
+          <p:cNvSpPr/>
+          <p:nvPr/>
+        </p:nvSpPr>
+        <p:spPr>
+          <a:xfrm>
+            <a:off x="9448800" y="2381250"/>
+            <a:ext cx="2266950" cy="1676400"/>
+          </a:xfrm>
+          <a:prstGeom prst="rect">
+            <a:avLst/>
+          </a:prstGeom>
+          <a:solidFill>
+            <a:srgbClr val="F2F2F2"/>
+          </a:solidFill>
+          <a:ln w="6350">
+            <a:solidFill>
+              <a:srgbClr val="F2F2F2"/>
+            </a:solidFill>
+          </a:ln>
+        </p:spPr>
+        <p:style>
+          <a:lnRef idx="1">
+            <a:schemeClr val="accent1"/>
+          </a:lnRef>
+          <a:fillRef idx="3">
+            <a:schemeClr val="accent1"/>
+          </a:fillRef>
+          <a:effectRef idx="2">
+            <a:schemeClr val="accent1"/>
+          </a:effectRef>
+          <a:fontRef idx="minor">
+            <a:schemeClr val="lt1"/>
+          </a:fontRef>
+        </p:style>
+        <p:txBody>
+          <a:bodyPr rtlCol="0" anchor="ctr"/>
+          <a:lstStyle/>
+          <a:p>
+            <a:pPr algn="ctr"/>
+          </a:p>
+        </p:txBody>
+      </p:sp>
+      <p:sp>
+        <p:nvSpPr>
+          <p:cNvPr id="46" name="TextBox 45"/>
+          <p:cNvSpPr txBox="1"/>
+          <p:nvPr/>
+        </p:nvSpPr>
+        <p:spPr>
+          <a:xfrm>
+            <a:off x="9563100" y="2476500"/>
+            <a:ext cx="2038350" cy="1485900"/>
+          </a:xfrm>
+          <a:prstGeom prst="rect">
+            <a:avLst/>
+          </a:prstGeom>
+          <a:noFill/>
+        </p:spPr>
+        <p:txBody>
+          <a:bodyPr wrap="square" anchor="t" lIns="0" rIns="0" tIns="0" bIns="0">
+            <a:spAutoFit/>
+          </a:bodyPr>
+          <a:lstStyle/>
+          <a:p>
+            <a:pPr algn="l"/>
+            <a:r>
+              <a:rPr sz="1100" b="1">
+                <a:solidFill>
+                  <a:srgbClr val="1E9E57"/>
+                </a:solidFill>
+                <a:latin typeface="Neue Haas Grotesk Text Pro"/>
+              </a:rPr>
+              <a:t>Sany Palfinger</a:t>
+            </a:r>
+            <a:r>
+              <a:rPr sz="1100" b="0">
+                <a:solidFill>
+                  <a:srgbClr val="000000"/>
+                </a:solidFill>
+                <a:latin typeface="Neue Haas Grotesk Text Pro"/>
+              </a:rPr>
+              <a:t> leads with half of the class (30 units).</a:t>
+            </a:r>
+          </a:p>
+          <a:p>
+            <a:pPr algn="l"/>
+            <a:r>
+              <a:rPr sz="1100" b="0">
+                <a:solidFill>
+                  <a:srgbClr val="000000"/>
+                </a:solidFill>
+                <a:latin typeface="Neue Haas Grotesk Text Pro"/>
+              </a:rPr>
+              <a:t/>
+            </a:r>
+          </a:p>
+          <a:p>
+            <a:pPr algn="l"/>
+            <a:r>
+              <a:rPr sz="1100" b="1">
+                <a:solidFill>
+                  <a:srgbClr val="000000"/>
+                </a:solidFill>
+                <a:latin typeface="Neue Haas Grotesk Text Pro"/>
+              </a:rPr>
+              <a:t>XCMG</a:t>
+            </a:r>
+            <a:r>
+              <a:rPr sz="1100" b="0">
+                <a:solidFill>
+                  <a:srgbClr val="000000"/>
+                </a:solidFill>
+                <a:latin typeface="Neue Haas Grotesk Text Pro"/>
+              </a:rPr>
+              <a:t> is a distant #2 at 23%; Palfinger sells only 5 units here.</a:t>
+            </a:r>
+          </a:p>
+          <a:p>
+            <a:pPr algn="l"/>
+            <a:r>
+              <a:rPr sz="1100" b="0">
+                <a:solidFill>
+                  <a:srgbClr val="000000"/>
+                </a:solidFill>
+                <a:latin typeface="Neue Haas Grotesk Text Pro"/>
+              </a:rPr>
+              <a:t/>
+            </a:r>
+          </a:p>
+          <a:p>
+            <a:pPr algn="l"/>
+            <a:r>
+              <a:rPr sz="1100" b="1">
+                <a:solidFill>
+                  <a:srgbClr val="000000"/>
+                </a:solidFill>
+                <a:latin typeface="Neue Haas Grotesk Text Pro"/>
+              </a:rPr>
+              <a:t>So what: </a:t>
+            </a:r>
+            <a:r>
+              <a:rPr sz="1100" b="0">
+                <a:solidFill>
+                  <a:srgbClr val="000000"/>
+                </a:solidFill>
+                <a:latin typeface="Neue Haas Grotesk Text Pro"/>
+              </a:rPr>
+              <a:t>Medium is a one-leader market; to grow, we take units from Sany Palfinger.</a:t>
+            </a:r>
+          </a:p>
+        </p:txBody>
+      </p:sp>
+      <p:cxnSp>
+        <p:nvCxnSpPr>
+          <p:cNvPr id="47" name="Connector 46"/>
+          <p:cNvCxnSpPr/>
+          <p:nvPr/>
+        </p:nvCxnSpPr>
+        <p:spPr>
+          <a:xfrm>
+            <a:off x="4438650" y="4229100"/>
+            <a:ext cx="7277100" cy="0"/>
+          </a:xfrm>
+          <a:prstGeom prst="line">
+            <a:avLst/>
+          </a:prstGeom>
+          <a:ln w="9525">
+            <a:solidFill>
+              <a:srgbClr val="BFBFBF"/>
+            </a:solidFill>
+          </a:ln>
+        </p:spPr>
+        <p:style>
+          <a:lnRef idx="2">
+            <a:schemeClr val="accent1"/>
+          </a:lnRef>
+          <a:fillRef idx="0">
+            <a:schemeClr val="accent1"/>
+          </a:fillRef>
+          <a:effectRef idx="1">
+            <a:schemeClr val="accent1"/>
+          </a:effectRef>
+          <a:fontRef idx="minor">
+            <a:schemeClr val="tx1"/>
+          </a:fontRef>
+        </p:style>
+      </p:cxnSp>
+      <p:sp>
+        <p:nvSpPr>
+          <p:cNvPr id="48" name="TextBox 47"/>
+          <p:cNvSpPr txBox="1"/>
+          <p:nvPr/>
+        </p:nvSpPr>
+        <p:spPr>
+          <a:xfrm>
+            <a:off x="4438650" y="4324350"/>
+            <a:ext cx="4953000" cy="190500"/>
+          </a:xfrm>
+          <a:prstGeom prst="rect">
+            <a:avLst/>
+          </a:prstGeom>
+          <a:noFill/>
+        </p:spPr>
+        <p:txBody>
+          <a:bodyPr wrap="square" anchor="t" lIns="0" rIns="0" tIns="0" bIns="0">
+            <a:spAutoFit/>
+          </a:bodyPr>
+          <a:lstStyle/>
+          <a:p>
+            <a:pPr algn="l"/>
+            <a:r>
+              <a:rPr sz="1200" b="1">
+                <a:solidFill>
+                  <a:srgbClr val="000000"/>
+                </a:solidFill>
+                <a:latin typeface="Neue Haas Grotesk Text Pro"/>
+              </a:rPr>
+              <a:t>Heavy class (&gt; 45 tm), 2025, </a:t>
+            </a:r>
+            <a:r>
+              <a:rPr sz="1200" b="0">
+                <a:solidFill>
+                  <a:srgbClr val="000000"/>
+                </a:solidFill>
+                <a:latin typeface="Neue Haas Grotesk Text Pro"/>
+              </a:rPr>
+              <a:t>share of units by brand</a:t>
+            </a:r>
+          </a:p>
+        </p:txBody>
+      </p:sp>
+      <p:sp>
+        <p:nvSpPr>
+          <p:cNvPr id="49" name="TextBox 48"/>
+          <p:cNvSpPr txBox="1"/>
+          <p:nvPr/>
+        </p:nvSpPr>
+        <p:spPr>
+          <a:xfrm>
+            <a:off x="4438650" y="4514850"/>
+            <a:ext cx="4953000" cy="171450"/>
+          </a:xfrm>
+          <a:prstGeom prst="rect">
+            <a:avLst/>
+          </a:prstGeom>
+          <a:noFill/>
+        </p:spPr>
+        <p:txBody>
+          <a:bodyPr wrap="square" anchor="t" lIns="0" rIns="0" tIns="0" bIns="0">
+            <a:spAutoFit/>
+          </a:bodyPr>
+          <a:lstStyle/>
+          <a:p>
+            <a:pPr algn="l"/>
+            <a:r>
+              <a:rPr sz="1100" b="1">
+                <a:solidFill>
+                  <a:srgbClr val="6B6B6B"/>
+                </a:solidFill>
+                <a:latin typeface="Neue Haas Grotesk Text Pro"/>
+              </a:rPr>
+              <a:t>39 units  ·  Rp 47,2 Bio  ·  42% of market value</a:t>
+            </a:r>
+          </a:p>
+        </p:txBody>
+      </p:sp>
+      <p:sp>
+        <p:nvSpPr>
+          <p:cNvPr id="50" name="Rectangle 49"/>
+          <p:cNvSpPr/>
+          <p:nvPr/>
+        </p:nvSpPr>
+        <p:spPr>
+          <a:xfrm>
+            <a:off x="4438650" y="4762500"/>
+            <a:ext cx="2686538" cy="438150"/>
+          </a:xfrm>
+          <a:prstGeom prst="rect">
+            <a:avLst/>
+          </a:prstGeom>
+          <a:solidFill>
+            <a:srgbClr val="1E9E57"/>
+          </a:solidFill>
+          <a:ln w="19050">
+            <a:solidFill>
+              <a:srgbClr val="FFFFFF"/>
+            </a:solidFill>
+          </a:ln>
+        </p:spPr>
+        <p:style>
+          <a:lnRef idx="1">
+            <a:schemeClr val="accent1"/>
+          </a:lnRef>
+          <a:fillRef idx="3">
+            <a:schemeClr val="accent1"/>
+          </a:fillRef>
+          <a:effectRef idx="2">
+            <a:schemeClr val="accent1"/>
+          </a:effectRef>
+          <a:fontRef idx="minor">
+            <a:schemeClr val="lt1"/>
+          </a:fontRef>
+        </p:style>
+        <p:txBody>
+          <a:bodyPr rtlCol="0" anchor="ctr" lIns="0" rIns="0"/>
+          <a:lstStyle/>
+          <a:p>
+            <a:pPr algn="ctr"/>
+            <a:r>
+              <a:rPr sz="1300" b="1">
+                <a:solidFill>
+                  <a:srgbClr val="FFFFFF"/>
+                </a:solidFill>
+                <a:latin typeface="Neue Haas Grotesk Text Pro"/>
+              </a:rPr>
+              <a:t>56%</a:t>
+            </a:r>
+          </a:p>
+        </p:txBody>
+      </p:sp>
+      <p:cxnSp>
+        <p:nvCxnSpPr>
+          <p:cNvPr id="51" name="Connector 50"/>
+          <p:cNvCxnSpPr/>
+          <p:nvPr/>
+        </p:nvCxnSpPr>
+        <p:spPr>
+          <a:xfrm>
+            <a:off x="5781919" y="5200650"/>
+            <a:ext cx="0" cy="133350"/>
+          </a:xfrm>
+          <a:prstGeom prst="line">
+            <a:avLst/>
+          </a:prstGeom>
+          <a:ln w="9525">
+            <a:solidFill>
+              <a:srgbClr val="7F7F7F"/>
+            </a:solidFill>
+          </a:ln>
+        </p:spPr>
+        <p:style>
+          <a:lnRef idx="2">
+            <a:schemeClr val="accent1"/>
+          </a:lnRef>
+          <a:fillRef idx="0">
+            <a:schemeClr val="accent1"/>
+          </a:fillRef>
+          <a:effectRef idx="1">
+            <a:schemeClr val="accent1"/>
+          </a:effectRef>
+          <a:fontRef idx="minor">
+            <a:schemeClr val="tx1"/>
+          </a:fontRef>
+        </p:style>
+      </p:cxnSp>
+      <p:sp>
+        <p:nvSpPr>
+          <p:cNvPr id="52" name="TextBox 51"/>
+          <p:cNvSpPr txBox="1"/>
+          <p:nvPr/>
+        </p:nvSpPr>
+        <p:spPr>
+          <a:xfrm>
+            <a:off x="5343769" y="5353050"/>
+            <a:ext cx="876300" cy="323850"/>
+          </a:xfrm>
+          <a:prstGeom prst="rect">
+            <a:avLst/>
+          </a:prstGeom>
+          <a:noFill/>
+        </p:spPr>
+        <p:txBody>
+          <a:bodyPr wrap="square" anchor="t" lIns="0" rIns="0" tIns="0" bIns="0">
+            <a:spAutoFit/>
+          </a:bodyPr>
+          <a:lstStyle/>
+          <a:p>
+            <a:pPr algn="ctr"/>
+            <a:r>
+              <a:rPr sz="1000" b="1">
+                <a:solidFill>
+                  <a:srgbClr val="000000"/>
+                </a:solidFill>
+                <a:latin typeface="Neue Haas Grotesk Text Pro"/>
+              </a:rPr>
+              <a:t>Palfinger</a:t>
+            </a:r>
+          </a:p>
+          <a:p>
+            <a:pPr algn="ctr"/>
+            <a:r>
+              <a:rPr sz="1000" b="0">
+                <a:solidFill>
+                  <a:srgbClr val="6B6B6B"/>
+                </a:solidFill>
+                <a:latin typeface="Neue Haas Grotesk Text Pro"/>
+              </a:rPr>
+              <a:t>22 units</a:t>
+            </a:r>
+          </a:p>
+        </p:txBody>
+      </p:sp>
+      <p:sp>
+        <p:nvSpPr>
+          <p:cNvPr id="53" name="Rectangle 52"/>
+          <p:cNvSpPr/>
+          <p:nvPr/>
+        </p:nvSpPr>
+        <p:spPr>
+          <a:xfrm>
+            <a:off x="7125188" y="4762500"/>
+            <a:ext cx="854808" cy="438150"/>
+          </a:xfrm>
+          <a:prstGeom prst="rect">
+            <a:avLst/>
+          </a:prstGeom>
+          <a:solidFill>
+            <a:srgbClr val="9ADBB5"/>
+          </a:solidFill>
+          <a:ln w="19050">
+            <a:solidFill>
+              <a:srgbClr val="FFFFFF"/>
+            </a:solidFill>
+          </a:ln>
+        </p:spPr>
+        <p:style>
+          <a:lnRef idx="1">
+            <a:schemeClr val="accent1"/>
+          </a:lnRef>
+          <a:fillRef idx="3">
+            <a:schemeClr val="accent1"/>
+          </a:fillRef>
+          <a:effectRef idx="2">
+            <a:schemeClr val="accent1"/>
+          </a:effectRef>
+          <a:fontRef idx="minor">
+            <a:schemeClr val="lt1"/>
+          </a:fontRef>
+        </p:style>
+        <p:txBody>
+          <a:bodyPr rtlCol="0" anchor="ctr" lIns="0" rIns="0"/>
+          <a:lstStyle/>
+          <a:p>
+            <a:pPr algn="ctr"/>
+            <a:r>
+              <a:rPr sz="1300" b="1">
+                <a:solidFill>
+                  <a:srgbClr val="000000"/>
+                </a:solidFill>
+                <a:latin typeface="Neue Haas Grotesk Text Pro"/>
+              </a:rPr>
+              <a:t>18%</a:t>
+            </a:r>
+          </a:p>
+        </p:txBody>
+      </p:sp>
+      <p:cxnSp>
+        <p:nvCxnSpPr>
+          <p:cNvPr id="54" name="Connector 53"/>
+          <p:cNvCxnSpPr/>
+          <p:nvPr/>
+        </p:nvCxnSpPr>
+        <p:spPr>
+          <a:xfrm>
+            <a:off x="7552592" y="5200650"/>
+            <a:ext cx="0" cy="133350"/>
+          </a:xfrm>
+          <a:prstGeom prst="line">
+            <a:avLst/>
+          </a:prstGeom>
+          <a:ln w="9525">
+            <a:solidFill>
+              <a:srgbClr val="7F7F7F"/>
+            </a:solidFill>
+          </a:ln>
+        </p:spPr>
+        <p:style>
+          <a:lnRef idx="2">
+            <a:schemeClr val="accent1"/>
+          </a:lnRef>
+          <a:fillRef idx="0">
+            <a:schemeClr val="accent1"/>
+          </a:fillRef>
+          <a:effectRef idx="1">
+            <a:schemeClr val="accent1"/>
+          </a:effectRef>
+          <a:fontRef idx="minor">
+            <a:schemeClr val="tx1"/>
+          </a:fontRef>
+        </p:style>
+      </p:cxnSp>
+      <p:sp>
+        <p:nvSpPr>
+          <p:cNvPr id="55" name="TextBox 54"/>
+          <p:cNvSpPr txBox="1"/>
+          <p:nvPr/>
+        </p:nvSpPr>
+        <p:spPr>
+          <a:xfrm>
+            <a:off x="7114442" y="5353050"/>
+            <a:ext cx="876300" cy="323850"/>
+          </a:xfrm>
+          <a:prstGeom prst="rect">
+            <a:avLst/>
+          </a:prstGeom>
+          <a:noFill/>
+        </p:spPr>
+        <p:txBody>
+          <a:bodyPr wrap="square" anchor="t" lIns="0" rIns="0" tIns="0" bIns="0">
+            <a:spAutoFit/>
+          </a:bodyPr>
+          <a:lstStyle/>
+          <a:p>
+            <a:pPr algn="ctr"/>
+            <a:r>
+              <a:rPr sz="1000" b="0">
+                <a:solidFill>
+                  <a:srgbClr val="000000"/>
+                </a:solidFill>
+                <a:latin typeface="Neue Haas Grotesk Text Pro"/>
+              </a:rPr>
+              <a:t>Amco Veba</a:t>
+            </a:r>
+          </a:p>
+          <a:p>
+            <a:pPr algn="ctr"/>
+            <a:r>
+              <a:rPr sz="1000" b="0">
+                <a:solidFill>
+                  <a:srgbClr val="6B6B6B"/>
+                </a:solidFill>
+                <a:latin typeface="Neue Haas Grotesk Text Pro"/>
+              </a:rPr>
+              <a:t>7 units</a:t>
+            </a:r>
+          </a:p>
+        </p:txBody>
+      </p:sp>
+      <p:sp>
+        <p:nvSpPr>
+          <p:cNvPr id="56" name="Rectangle 55"/>
+          <p:cNvSpPr/>
+          <p:nvPr/>
+        </p:nvSpPr>
+        <p:spPr>
+          <a:xfrm>
+            <a:off x="7979996" y="4762500"/>
+            <a:ext cx="488462" cy="438150"/>
           </a:xfrm>
           <a:prstGeom prst="rect">
             <a:avLst/>
@@ -5259,7 +6123,7 @@
           </a:fontRef>
         </p:style>
         <p:txBody>
-          <a:bodyPr rtlCol="0" anchor="t" wrap="square" lIns="57150" rIns="57150" tIns="47625" bIns="47625"/>
+          <a:bodyPr rtlCol="0" anchor="ctr" lIns="0" rIns="0"/>
           <a:lstStyle/>
           <a:p>
             <a:pPr algn="ctr"/>
@@ -5270,21 +6134,56 @@
                 </a:solidFill>
                 <a:latin typeface="Neue Haas Grotesk Text Pro"/>
               </a:rPr>
-              <a:t>~8%</a:t>
-            </a:r>
-          </a:p>
-        </p:txBody>
-      </p:sp>
-      <p:sp>
-        <p:nvSpPr>
-          <p:cNvPr id="39" name="TextBox 38"/>
+              <a:t>10%</a:t>
+            </a:r>
+          </a:p>
+        </p:txBody>
+      </p:sp>
+      <p:cxnSp>
+        <p:nvCxnSpPr>
+          <p:cNvPr id="57" name="Connector 56"/>
+          <p:cNvCxnSpPr/>
+          <p:nvPr/>
+        </p:nvCxnSpPr>
+        <p:spPr>
+          <a:xfrm>
+            <a:off x="8224227" y="5200650"/>
+            <a:ext cx="0" cy="133350"/>
+          </a:xfrm>
+          <a:prstGeom prst="line">
+            <a:avLst/>
+          </a:prstGeom>
+          <a:ln w="9525">
+            <a:solidFill>
+              <a:srgbClr val="7F7F7F"/>
+            </a:solidFill>
+          </a:ln>
+        </p:spPr>
+        <p:style>
+          <a:lnRef idx="2">
+            <a:schemeClr val="accent1"/>
+          </a:lnRef>
+          <a:fillRef idx="0">
+            <a:schemeClr val="accent1"/>
+          </a:fillRef>
+          <a:effectRef idx="1">
+            <a:schemeClr val="accent1"/>
+          </a:effectRef>
+          <a:fontRef idx="minor">
+            <a:schemeClr val="tx1"/>
+          </a:fontRef>
+        </p:style>
+      </p:cxnSp>
+      <p:sp>
+        <p:nvSpPr>
+          <p:cNvPr id="58" name="TextBox 57"/>
           <p:cNvSpPr txBox="1"/>
           <p:nvPr/>
         </p:nvSpPr>
         <p:spPr>
           <a:xfrm>
-            <a:off x="6134100" y="4629150"/>
-            <a:ext cx="425648" cy="342900"/>
+            <a:off x="7786077" y="5353050"/>
+            <a:ext cx="876300" cy="323850"/>
           </a:xfrm>
           <a:prstGeom prst="rect">
             <a:avLst/>
@@ -5292,40 +6191,52 @@
           <a:noFill/>
         </p:spPr>
         <p:txBody>
-          <a:bodyPr wrap="square" anchor="b" lIns="0" rIns="0" tIns="0" bIns="0">
+          <a:bodyPr wrap="square" anchor="t" lIns="0" rIns="0" tIns="0" bIns="0">
             <a:spAutoFit/>
           </a:bodyPr>
           <a:lstStyle/>
           <a:p>
-            <a:pPr algn="l"/>
-            <a:r>
-              <a:rPr sz="850" b="1">
+            <a:pPr algn="ctr"/>
+            <a:r>
+              <a:rPr sz="1000" b="0">
                 <a:solidFill>
                   <a:srgbClr val="000000"/>
                 </a:solidFill>
                 <a:latin typeface="Neue Haas Grotesk Text Pro"/>
               </a:rPr>
-              <a:t>Palfinger, 5</a:t>
-            </a:r>
-          </a:p>
-        </p:txBody>
-      </p:sp>
-      <p:sp>
-        <p:nvSpPr>
-          <p:cNvPr id="40" name="Rectangle 39"/>
+              <a:t>XCMG</a:t>
+            </a:r>
+          </a:p>
+          <a:p>
+            <a:pPr algn="ctr"/>
+            <a:r>
+              <a:rPr sz="1000" b="0">
+                <a:solidFill>
+                  <a:srgbClr val="6B6B6B"/>
+                </a:solidFill>
+                <a:latin typeface="Neue Haas Grotesk Text Pro"/>
+              </a:rPr>
+              <a:t>4 units</a:t>
+            </a:r>
+          </a:p>
+        </p:txBody>
+      </p:sp>
+      <p:sp>
+        <p:nvSpPr>
+          <p:cNvPr id="59" name="Rectangle 58"/>
           <p:cNvSpPr/>
           <p:nvPr/>
         </p:nvSpPr>
         <p:spPr>
           <a:xfrm>
-            <a:off x="6607373" y="3841750"/>
-            <a:ext cx="1145977" cy="1168400"/>
+            <a:off x="8468458" y="4762500"/>
+            <a:ext cx="732692" cy="438150"/>
           </a:xfrm>
           <a:prstGeom prst="rect">
             <a:avLst/>
           </a:prstGeom>
           <a:solidFill>
-            <a:srgbClr val="C7EFD5"/>
+            <a:srgbClr val="D9D9D9"/>
           </a:solidFill>
           <a:ln w="19050">
             <a:solidFill>
@@ -5348,7 +6259,7 @@
           </a:fontRef>
         </p:style>
         <p:txBody>
-          <a:bodyPr rtlCol="0" anchor="t" wrap="square" lIns="57150" rIns="57150" tIns="47625" bIns="47625"/>
+          <a:bodyPr rtlCol="0" anchor="ctr" lIns="0" rIns="0"/>
           <a:lstStyle/>
           <a:p>
             <a:pPr algn="ctr"/>
@@ -5359,21 +6270,56 @@
                 </a:solidFill>
                 <a:latin typeface="Neue Haas Grotesk Text Pro"/>
               </a:rPr>
-              <a:t>~18%</a:t>
-            </a:r>
-          </a:p>
-        </p:txBody>
-      </p:sp>
-      <p:sp>
-        <p:nvSpPr>
-          <p:cNvPr id="41" name="TextBox 40"/>
+              <a:t>15%</a:t>
+            </a:r>
+          </a:p>
+        </p:txBody>
+      </p:sp>
+      <p:cxnSp>
+        <p:nvCxnSpPr>
+          <p:cNvPr id="60" name="Connector 59"/>
+          <p:cNvCxnSpPr/>
+          <p:nvPr/>
+        </p:nvCxnSpPr>
+        <p:spPr>
+          <a:xfrm>
+            <a:off x="8834804" y="5200650"/>
+            <a:ext cx="0" cy="133350"/>
+          </a:xfrm>
+          <a:prstGeom prst="line">
+            <a:avLst/>
+          </a:prstGeom>
+          <a:ln w="9525">
+            <a:solidFill>
+              <a:srgbClr val="7F7F7F"/>
+            </a:solidFill>
+          </a:ln>
+        </p:spPr>
+        <p:style>
+          <a:lnRef idx="2">
+            <a:schemeClr val="accent1"/>
+          </a:lnRef>
+          <a:fillRef idx="0">
+            <a:schemeClr val="accent1"/>
+          </a:fillRef>
+          <a:effectRef idx="1">
+            <a:schemeClr val="accent1"/>
+          </a:effectRef>
+          <a:fontRef idx="minor">
+            <a:schemeClr val="tx1"/>
+          </a:fontRef>
+        </p:style>
+      </p:cxnSp>
+      <p:sp>
+        <p:nvSpPr>
+          <p:cNvPr id="61" name="TextBox 60"/>
           <p:cNvSpPr txBox="1"/>
           <p:nvPr/>
         </p:nvSpPr>
         <p:spPr>
           <a:xfrm>
-            <a:off x="6654998" y="4629150"/>
-            <a:ext cx="1050727" cy="342900"/>
+            <a:off x="8396654" y="5353050"/>
+            <a:ext cx="876300" cy="323850"/>
           </a:xfrm>
           <a:prstGeom prst="rect">
             <a:avLst/>
@@ -5381,238 +6327,46 @@
           <a:noFill/>
         </p:spPr>
         <p:txBody>
-          <a:bodyPr wrap="square" anchor="b" lIns="0" rIns="0" tIns="0" bIns="0">
-            <a:spAutoFit/>
-          </a:bodyPr>
-          <a:lstStyle/>
-          <a:p>
-            <a:pPr algn="l"/>
-            <a:r>
-              <a:rPr sz="1050" b="1">
-                <a:solidFill>
-                  <a:srgbClr val="000000"/>
-                </a:solidFill>
-                <a:latin typeface="Neue Haas Grotesk Text Pro"/>
-              </a:rPr>
-              <a:t>Others, 11</a:t>
-            </a:r>
-          </a:p>
-        </p:txBody>
-      </p:sp>
-      <p:sp>
-        <p:nvSpPr>
-          <p:cNvPr id="42" name="TextBox 41"/>
-          <p:cNvSpPr txBox="1"/>
-          <p:nvPr/>
-        </p:nvSpPr>
-        <p:spPr>
-          <a:xfrm>
-            <a:off x="4419600" y="5124450"/>
-            <a:ext cx="3333750" cy="171450"/>
-          </a:xfrm>
-          <a:prstGeom prst="rect">
-            <a:avLst/>
-          </a:prstGeom>
-          <a:noFill/>
-        </p:spPr>
-        <p:txBody>
           <a:bodyPr wrap="square" anchor="t" lIns="0" rIns="0" tIns="0" bIns="0">
             <a:spAutoFit/>
           </a:bodyPr>
           <a:lstStyle/>
           <a:p>
-            <a:pPr algn="l"/>
-            <a:r>
-              <a:rPr sz="1100" b="1">
+            <a:pPr algn="ctr"/>
+            <a:r>
+              <a:rPr sz="1000" b="0">
                 <a:solidFill>
                   <a:srgbClr val="000000"/>
                 </a:solidFill>
                 <a:latin typeface="Neue Haas Grotesk Text Pro"/>
               </a:rPr>
-              <a:t>Triatra Medium market share, </a:t>
-            </a:r>
-            <a:r>
-              <a:rPr sz="1100" b="0">
-                <a:solidFill>
-                  <a:srgbClr val="000000"/>
-                </a:solidFill>
-                <a:latin typeface="Neue Haas Grotesk Text Pro"/>
-              </a:rPr>
-              <a:t>quantity of sales</a:t>
-            </a:r>
-          </a:p>
-        </p:txBody>
-      </p:sp>
-      <p:sp>
-        <p:nvSpPr>
-          <p:cNvPr id="43" name="Rectangle 42"/>
+              <a:t>Others</a:t>
+            </a:r>
+          </a:p>
+          <a:p>
+            <a:pPr algn="ctr"/>
+            <a:r>
+              <a:rPr sz="1000" b="0">
+                <a:solidFill>
+                  <a:srgbClr val="6B6B6B"/>
+                </a:solidFill>
+                <a:latin typeface="Neue Haas Grotesk Text Pro"/>
+              </a:rPr>
+              <a:t>6 units</a:t>
+            </a:r>
+          </a:p>
+        </p:txBody>
+      </p:sp>
+      <p:sp>
+        <p:nvSpPr>
+          <p:cNvPr id="62" name="Rectangle 61"/>
           <p:cNvSpPr/>
           <p:nvPr/>
         </p:nvSpPr>
         <p:spPr>
           <a:xfrm>
-            <a:off x="4419600" y="5353050"/>
-            <a:ext cx="95250" cy="95250"/>
-          </a:xfrm>
-          <a:prstGeom prst="rect">
-            <a:avLst/>
-          </a:prstGeom>
-          <a:solidFill>
-            <a:srgbClr val="1E9E57"/>
-          </a:solidFill>
-          <a:ln w="6350">
-            <a:solidFill>
-              <a:srgbClr val="1E9E57"/>
-            </a:solidFill>
-          </a:ln>
-        </p:spPr>
-        <p:style>
-          <a:lnRef idx="1">
-            <a:schemeClr val="accent1"/>
-          </a:lnRef>
-          <a:fillRef idx="3">
-            <a:schemeClr val="accent1"/>
-          </a:fillRef>
-          <a:effectRef idx="2">
-            <a:schemeClr val="accent1"/>
-          </a:effectRef>
-          <a:fontRef idx="minor">
-            <a:schemeClr val="lt1"/>
-          </a:fontRef>
-        </p:style>
-        <p:txBody>
-          <a:bodyPr rtlCol="0" anchor="ctr"/>
-          <a:lstStyle/>
-          <a:p>
-            <a:pPr algn="ctr"/>
-          </a:p>
-        </p:txBody>
-      </p:sp>
-      <p:sp>
-        <p:nvSpPr>
-          <p:cNvPr id="44" name="TextBox 43"/>
-          <p:cNvSpPr txBox="1"/>
-          <p:nvPr/>
-        </p:nvSpPr>
-        <p:spPr>
-          <a:xfrm>
-            <a:off x="4552950" y="5324475"/>
-            <a:ext cx="571500" cy="152400"/>
-          </a:xfrm>
-          <a:prstGeom prst="rect">
-            <a:avLst/>
-          </a:prstGeom>
-          <a:noFill/>
-        </p:spPr>
-        <p:txBody>
-          <a:bodyPr wrap="square" anchor="t" lIns="0" rIns="0" tIns="0" bIns="0">
-            <a:spAutoFit/>
-          </a:bodyPr>
-          <a:lstStyle/>
-          <a:p>
-            <a:pPr algn="l"/>
-            <a:r>
-              <a:rPr sz="900" b="0">
-                <a:solidFill>
-                  <a:srgbClr val="000000"/>
-                </a:solidFill>
-                <a:latin typeface="Neue Haas Grotesk Text Pro"/>
-              </a:rPr>
-              <a:t>Triatra</a:t>
-            </a:r>
-          </a:p>
-        </p:txBody>
-      </p:sp>
-      <p:sp>
-        <p:nvSpPr>
-          <p:cNvPr id="45" name="Rectangle 44"/>
-          <p:cNvSpPr/>
-          <p:nvPr/>
-        </p:nvSpPr>
-        <p:spPr>
-          <a:xfrm>
-            <a:off x="5105400" y="5353050"/>
-            <a:ext cx="95250" cy="95250"/>
-          </a:xfrm>
-          <a:prstGeom prst="rect">
-            <a:avLst/>
-          </a:prstGeom>
-          <a:solidFill>
-            <a:srgbClr val="D9D9D9"/>
-          </a:solidFill>
-          <a:ln w="6350">
-            <a:solidFill>
-              <a:srgbClr val="D9D9D9"/>
-            </a:solidFill>
-          </a:ln>
-        </p:spPr>
-        <p:style>
-          <a:lnRef idx="1">
-            <a:schemeClr val="accent1"/>
-          </a:lnRef>
-          <a:fillRef idx="3">
-            <a:schemeClr val="accent1"/>
-          </a:fillRef>
-          <a:effectRef idx="2">
-            <a:schemeClr val="accent1"/>
-          </a:effectRef>
-          <a:fontRef idx="minor">
-            <a:schemeClr val="lt1"/>
-          </a:fontRef>
-        </p:style>
-        <p:txBody>
-          <a:bodyPr rtlCol="0" anchor="ctr"/>
-          <a:lstStyle/>
-          <a:p>
-            <a:pPr algn="ctr"/>
-          </a:p>
-        </p:txBody>
-      </p:sp>
-      <p:sp>
-        <p:nvSpPr>
-          <p:cNvPr id="46" name="TextBox 45"/>
-          <p:cNvSpPr txBox="1"/>
-          <p:nvPr/>
-        </p:nvSpPr>
-        <p:spPr>
-          <a:xfrm>
-            <a:off x="5238750" y="5324475"/>
-            <a:ext cx="952500" cy="152400"/>
-          </a:xfrm>
-          <a:prstGeom prst="rect">
-            <a:avLst/>
-          </a:prstGeom>
-          <a:noFill/>
-        </p:spPr>
-        <p:txBody>
-          <a:bodyPr wrap="square" anchor="t" lIns="0" rIns="0" tIns="0" bIns="0">
-            <a:spAutoFit/>
-          </a:bodyPr>
-          <a:lstStyle/>
-          <a:p>
-            <a:pPr algn="l"/>
-            <a:r>
-              <a:rPr sz="900" b="0">
-                <a:solidFill>
-                  <a:srgbClr val="000000"/>
-                </a:solidFill>
-                <a:latin typeface="Neue Haas Grotesk Text Pro"/>
-              </a:rPr>
-              <a:t>Rest of market</a:t>
-            </a:r>
-          </a:p>
-        </p:txBody>
-      </p:sp>
-      <p:sp>
-        <p:nvSpPr>
-          <p:cNvPr id="47" name="Rectangle 46"/>
-          <p:cNvSpPr/>
-          <p:nvPr/>
-        </p:nvSpPr>
-        <p:spPr>
-          <a:xfrm>
-            <a:off x="4419600" y="5562600"/>
-            <a:ext cx="3333750" cy="285750"/>
+            <a:off x="9448800" y="4324350"/>
+            <a:ext cx="2266950" cy="1676400"/>
           </a:xfrm>
           <a:prstGeom prst="rect">
             <a:avLst/>
@@ -5620,9 +6374,9 @@
           <a:solidFill>
             <a:srgbClr val="F2F2F2"/>
           </a:solidFill>
-          <a:ln w="9525">
+          <a:ln w="6350">
             <a:solidFill>
-              <a:srgbClr val="BFBFBF"/>
+              <a:srgbClr val="F2F2F2"/>
             </a:solidFill>
           </a:ln>
         </p:spPr>
@@ -5645,28 +6399,19 @@
           <a:lstStyle/>
           <a:p>
             <a:pPr algn="ctr"/>
-            <a:r>
-              <a:rPr sz="1000" i="1">
-                <a:solidFill>
-                  <a:srgbClr val="6B6B6B"/>
-                </a:solidFill>
-                <a:latin typeface="Neue Haas Grotesk Text Pro"/>
-              </a:rPr>
-              <a:t>Triatra units sold in 2025: to be added  ·  market = 60 units</a:t>
-            </a:r>
-          </a:p>
-        </p:txBody>
-      </p:sp>
-      <p:sp>
-        <p:nvSpPr>
-          <p:cNvPr id="48" name="TextBox 47"/>
+          </a:p>
+        </p:txBody>
+      </p:sp>
+      <p:sp>
+        <p:nvSpPr>
+          <p:cNvPr id="63" name="TextBox 62"/>
           <p:cNvSpPr txBox="1"/>
           <p:nvPr/>
         </p:nvSpPr>
         <p:spPr>
           <a:xfrm>
-            <a:off x="4419600" y="5905500"/>
-            <a:ext cx="3333750" cy="266700"/>
+            <a:off x="9563100" y="4419600"/>
+            <a:ext cx="2038350" cy="1485900"/>
           </a:xfrm>
           <a:prstGeom prst="rect">
             <a:avLst/>
@@ -5687,118 +6432,158 @@
                 </a:solidFill>
                 <a:latin typeface="Neue Haas Grotesk Text Pro"/>
               </a:rPr>
-              <a:t>Sany Palfinger holds 30 of 60 units (50%)</a:t>
-            </a:r>
-          </a:p>
-        </p:txBody>
-      </p:sp>
-      <p:sp>
-        <p:nvSpPr>
-          <p:cNvPr id="49" name="Rectangle 48"/>
-          <p:cNvSpPr/>
+              <a:t>Palfinger</a:t>
+            </a:r>
+            <a:r>
+              <a:rPr sz="1100" b="0">
+                <a:solidFill>
+                  <a:srgbClr val="000000"/>
+                </a:solidFill>
+                <a:latin typeface="Neue Haas Grotesk Text Pro"/>
+              </a:rPr>
+              <a:t> holds 56% of units (22 of 39).</a:t>
+            </a:r>
+          </a:p>
+          <a:p>
+            <a:pPr algn="l"/>
+            <a:r>
+              <a:rPr sz="1100" b="0">
+                <a:solidFill>
+                  <a:srgbClr val="000000"/>
+                </a:solidFill>
+                <a:latin typeface="Neue Haas Grotesk Text Pro"/>
+              </a:rPr>
+              <a:t/>
+            </a:r>
+          </a:p>
+          <a:p>
+            <a:pPr algn="l"/>
+            <a:r>
+              <a:rPr sz="1100" b="1">
+                <a:solidFill>
+                  <a:srgbClr val="000000"/>
+                </a:solidFill>
+                <a:latin typeface="Neue Haas Grotesk Text Pro"/>
+              </a:rPr>
+              <a:t>Amco Veba</a:t>
+            </a:r>
+            <a:r>
+              <a:rPr sz="1100" b="0">
+                <a:solidFill>
+                  <a:srgbClr val="000000"/>
+                </a:solidFill>
+                <a:latin typeface="Neue Haas Grotesk Text Pro"/>
+              </a:rPr>
+              <a:t> (7) and </a:t>
+            </a:r>
+            <a:r>
+              <a:rPr sz="1100" b="1">
+                <a:solidFill>
+                  <a:srgbClr val="000000"/>
+                </a:solidFill>
+                <a:latin typeface="Neue Haas Grotesk Text Pro"/>
+              </a:rPr>
+              <a:t>XCMG</a:t>
+            </a:r>
+            <a:r>
+              <a:rPr sz="1100" b="0">
+                <a:solidFill>
+                  <a:srgbClr val="000000"/>
+                </a:solidFill>
+                <a:latin typeface="Neue Haas Grotesk Text Pro"/>
+              </a:rPr>
+              <a:t> (4) follow; top 3 = 85% of units.</a:t>
+            </a:r>
+          </a:p>
+          <a:p>
+            <a:pPr algn="l"/>
+            <a:r>
+              <a:rPr sz="1100" b="0">
+                <a:solidFill>
+                  <a:srgbClr val="000000"/>
+                </a:solidFill>
+                <a:latin typeface="Neue Haas Grotesk Text Pro"/>
+              </a:rPr>
+              <a:t/>
+            </a:r>
+          </a:p>
+          <a:p>
+            <a:pPr algn="l"/>
+            <a:r>
+              <a:rPr sz="1100" b="1">
+                <a:solidFill>
+                  <a:srgbClr val="000000"/>
+                </a:solidFill>
+                <a:latin typeface="Neue Haas Grotesk Text Pro"/>
+              </a:rPr>
+              <a:t>So what: </a:t>
+            </a:r>
+            <a:r>
+              <a:rPr sz="1100" b="0">
+                <a:solidFill>
+                  <a:srgbClr val="000000"/>
+                </a:solidFill>
+                <a:latin typeface="Neue Haas Grotesk Text Pro"/>
+              </a:rPr>
+              <a:t>Heavy is small in units but 42% of market value; each unit is worth about Rp 1,2 Bio.</a:t>
+            </a:r>
+          </a:p>
+        </p:txBody>
+      </p:sp>
+      <p:sp>
+        <p:nvSpPr>
+          <p:cNvPr id="64" name="TextBox 63"/>
+          <p:cNvSpPr txBox="1"/>
           <p:nvPr/>
         </p:nvSpPr>
         <p:spPr>
           <a:xfrm>
-            <a:off x="8210550" y="2038350"/>
-            <a:ext cx="3638550" cy="247650"/>
-          </a:xfrm>
-          <a:prstGeom prst="rect">
-            <a:avLst/>
-          </a:prstGeom>
-          <a:solidFill>
-            <a:srgbClr val="1E9E57"/>
-          </a:solidFill>
-          <a:ln w="12700">
-            <a:solidFill>
-              <a:srgbClr val="1E9E57"/>
-            </a:solidFill>
-          </a:ln>
-        </p:spPr>
-        <p:style>
-          <a:lnRef idx="1">
-            <a:schemeClr val="accent1"/>
-          </a:lnRef>
-          <a:fillRef idx="3">
-            <a:schemeClr val="accent1"/>
-          </a:fillRef>
-          <a:effectRef idx="2">
-            <a:schemeClr val="accent1"/>
-          </a:effectRef>
-          <a:fontRef idx="minor">
-            <a:schemeClr val="lt1"/>
-          </a:fontRef>
-        </p:style>
-        <p:txBody>
-          <a:bodyPr rtlCol="0" anchor="ctr"/>
-          <a:lstStyle/>
-          <a:p>
-            <a:pPr algn="ctr"/>
-            <a:r>
-              <a:rPr sz="1200" b="1">
-                <a:solidFill>
-                  <a:srgbClr val="FFFFFF"/>
-                </a:solidFill>
-                <a:latin typeface="Neue Haas Grotesk Text Pro"/>
-              </a:rPr>
-              <a:t>Heavy class (&gt; 45 tm): who fills it</a:t>
-            </a:r>
-          </a:p>
-        </p:txBody>
-      </p:sp>
-      <p:sp>
-        <p:nvSpPr>
-          <p:cNvPr id="50" name="Rectangle 49"/>
-          <p:cNvSpPr/>
-          <p:nvPr/>
-        </p:nvSpPr>
-        <p:spPr>
-          <a:xfrm>
-            <a:off x="8210550" y="2286000"/>
-            <a:ext cx="3638550" cy="3924300"/>
+            <a:off x="342900" y="6305550"/>
+            <a:ext cx="11506200" cy="152400"/>
           </a:xfrm>
           <a:prstGeom prst="rect">
             <a:avLst/>
           </a:prstGeom>
           <a:noFill/>
-          <a:ln w="19050">
-            <a:solidFill>
-              <a:srgbClr val="1E9E57"/>
-            </a:solidFill>
-          </a:ln>
-        </p:spPr>
-        <p:style>
-          <a:lnRef idx="1">
-            <a:schemeClr val="accent1"/>
-          </a:lnRef>
-          <a:fillRef idx="3">
-            <a:schemeClr val="accent1"/>
-          </a:fillRef>
-          <a:effectRef idx="2">
-            <a:schemeClr val="accent1"/>
-          </a:effectRef>
-          <a:fontRef idx="minor">
-            <a:schemeClr val="lt1"/>
-          </a:fontRef>
-        </p:style>
-        <p:txBody>
-          <a:bodyPr rtlCol="0" anchor="ctr"/>
-          <a:lstStyle/>
-          <a:p>
-            <a:pPr algn="ctr"/>
-          </a:p>
-        </p:txBody>
-      </p:sp>
-      <p:sp>
-        <p:nvSpPr>
-          <p:cNvPr id="51" name="TextBox 50"/>
+        </p:spPr>
+        <p:txBody>
+          <a:bodyPr wrap="square" anchor="t" lIns="0" rIns="0" tIns="0" bIns="0">
+            <a:spAutoFit/>
+          </a:bodyPr>
+          <a:lstStyle/>
+          <a:p>
+            <a:pPr algn="l"/>
+            <a:r>
+              <a:rPr sz="1000" b="1">
+                <a:solidFill>
+                  <a:srgbClr val="000000"/>
+                </a:solidFill>
+                <a:latin typeface="Neue Haas Grotesk Text Pro"/>
+              </a:rPr>
+              <a:t>Source: </a:t>
+            </a:r>
+            <a:r>
+              <a:rPr sz="1000" b="0">
+                <a:solidFill>
+                  <a:srgbClr val="000000"/>
+                </a:solidFill>
+                <a:latin typeface="Neue Haas Grotesk Text Pro"/>
+              </a:rPr>
+              <a:t>Indonesia import records 2025, knuckle boom (folding) cranes; value converted from USD at assumed Rp 16.000/USD (Bio = billion).</a:t>
+            </a:r>
+          </a:p>
+        </p:txBody>
+      </p:sp>
+      <p:sp>
+        <p:nvSpPr>
+          <p:cNvPr id="65" name="TextBox 64"/>
           <p:cNvSpPr txBox="1"/>
           <p:nvPr/>
         </p:nvSpPr>
         <p:spPr>
           <a:xfrm>
-            <a:off x="8324850" y="2362200"/>
-            <a:ext cx="3409950" cy="323850"/>
+            <a:off x="342900" y="6477000"/>
+            <a:ext cx="11506200" cy="152400"/>
           </a:xfrm>
           <a:prstGeom prst="rect">
             <a:avLst/>
@@ -5813,778 +6598,6 @@
           <a:p>
             <a:pPr algn="l"/>
             <a:r>
-              <a:rPr sz="1200" b="1">
-                <a:solidFill>
-                  <a:srgbClr val="000000"/>
-                </a:solidFill>
-                <a:latin typeface="Neue Haas Grotesk Text Pro"/>
-              </a:rPr>
-              <a:t>Heavy class market, 2025, </a:t>
-            </a:r>
-            <a:r>
-              <a:rPr sz="1200" b="0">
-                <a:solidFill>
-                  <a:srgbClr val="000000"/>
-                </a:solidFill>
-                <a:latin typeface="Neue Haas Grotesk Text Pro"/>
-              </a:rPr>
-              <a:t>n of units by brand</a:t>
-            </a:r>
-          </a:p>
-        </p:txBody>
-      </p:sp>
-      <p:sp>
-        <p:nvSpPr>
-          <p:cNvPr id="52" name="TextBox 51"/>
-          <p:cNvSpPr txBox="1"/>
-          <p:nvPr/>
-        </p:nvSpPr>
-        <p:spPr>
-          <a:xfrm>
-            <a:off x="8324850" y="2571750"/>
-            <a:ext cx="3409950" cy="171450"/>
-          </a:xfrm>
-          <a:prstGeom prst="rect">
-            <a:avLst/>
-          </a:prstGeom>
-          <a:noFill/>
-        </p:spPr>
-        <p:txBody>
-          <a:bodyPr wrap="square" anchor="t" lIns="0" rIns="0" tIns="0" bIns="0">
-            <a:spAutoFit/>
-          </a:bodyPr>
-          <a:lstStyle/>
-          <a:p>
-            <a:pPr algn="l"/>
-            <a:r>
-              <a:rPr sz="1000" b="0">
-                <a:solidFill>
-                  <a:srgbClr val="6B6B6B"/>
-                </a:solidFill>
-                <a:latin typeface="Neue Haas Grotesk Text Pro"/>
-              </a:rPr>
-              <a:t>39 units · Rp 47,2 Bio · 42% of market value</a:t>
-            </a:r>
-          </a:p>
-        </p:txBody>
-      </p:sp>
-      <p:sp>
-        <p:nvSpPr>
-          <p:cNvPr id="53" name="Rectangle 52"/>
-          <p:cNvSpPr/>
-          <p:nvPr/>
-        </p:nvSpPr>
-        <p:spPr>
-          <a:xfrm>
-            <a:off x="8324850" y="2819400"/>
-            <a:ext cx="1923562" cy="2190750"/>
-          </a:xfrm>
-          <a:prstGeom prst="rect">
-            <a:avLst/>
-          </a:prstGeom>
-          <a:solidFill>
-            <a:srgbClr val="0B4D2A"/>
-          </a:solidFill>
-          <a:ln w="19050">
-            <a:solidFill>
-              <a:srgbClr val="FFFFFF"/>
-            </a:solidFill>
-          </a:ln>
-        </p:spPr>
-        <p:style>
-          <a:lnRef idx="1">
-            <a:schemeClr val="accent1"/>
-          </a:lnRef>
-          <a:fillRef idx="3">
-            <a:schemeClr val="accent1"/>
-          </a:fillRef>
-          <a:effectRef idx="2">
-            <a:schemeClr val="accent1"/>
-          </a:effectRef>
-          <a:fontRef idx="minor">
-            <a:schemeClr val="lt1"/>
-          </a:fontRef>
-        </p:style>
-        <p:txBody>
-          <a:bodyPr rtlCol="0" anchor="t" wrap="square" lIns="57150" rIns="57150" tIns="47625" bIns="47625"/>
-          <a:lstStyle/>
-          <a:p>
-            <a:pPr algn="ctr"/>
-            <a:r>
-              <a:rPr sz="1300" b="1">
-                <a:solidFill>
-                  <a:srgbClr val="FFFFFF"/>
-                </a:solidFill>
-                <a:latin typeface="Neue Haas Grotesk Text Pro"/>
-              </a:rPr>
-              <a:t>~56%</a:t>
-            </a:r>
-          </a:p>
-        </p:txBody>
-      </p:sp>
-      <p:sp>
-        <p:nvSpPr>
-          <p:cNvPr id="54" name="TextBox 53"/>
-          <p:cNvSpPr txBox="1"/>
-          <p:nvPr/>
-        </p:nvSpPr>
-        <p:spPr>
-          <a:xfrm>
-            <a:off x="8372475" y="4629150"/>
-            <a:ext cx="1828312" cy="342900"/>
-          </a:xfrm>
-          <a:prstGeom prst="rect">
-            <a:avLst/>
-          </a:prstGeom>
-          <a:noFill/>
-        </p:spPr>
-        <p:txBody>
-          <a:bodyPr wrap="square" anchor="b" lIns="0" rIns="0" tIns="0" bIns="0">
-            <a:spAutoFit/>
-          </a:bodyPr>
-          <a:lstStyle/>
-          <a:p>
-            <a:pPr algn="l"/>
-            <a:r>
-              <a:rPr sz="1050" b="1">
-                <a:solidFill>
-                  <a:srgbClr val="FFFFFF"/>
-                </a:solidFill>
-                <a:latin typeface="Neue Haas Grotesk Text Pro"/>
-              </a:rPr>
-              <a:t>Palfinger, 22</a:t>
-            </a:r>
-          </a:p>
-        </p:txBody>
-      </p:sp>
-      <p:sp>
-        <p:nvSpPr>
-          <p:cNvPr id="55" name="Rectangle 54"/>
-          <p:cNvSpPr/>
-          <p:nvPr/>
-        </p:nvSpPr>
-        <p:spPr>
-          <a:xfrm>
-            <a:off x="10248412" y="2819400"/>
-            <a:ext cx="1486388" cy="902074"/>
-          </a:xfrm>
-          <a:prstGeom prst="rect">
-            <a:avLst/>
-          </a:prstGeom>
-          <a:solidFill>
-            <a:srgbClr val="1E9E57"/>
-          </a:solidFill>
-          <a:ln w="19050">
-            <a:solidFill>
-              <a:srgbClr val="FFFFFF"/>
-            </a:solidFill>
-          </a:ln>
-        </p:spPr>
-        <p:style>
-          <a:lnRef idx="1">
-            <a:schemeClr val="accent1"/>
-          </a:lnRef>
-          <a:fillRef idx="3">
-            <a:schemeClr val="accent1"/>
-          </a:fillRef>
-          <a:effectRef idx="2">
-            <a:schemeClr val="accent1"/>
-          </a:effectRef>
-          <a:fontRef idx="minor">
-            <a:schemeClr val="lt1"/>
-          </a:fontRef>
-        </p:style>
-        <p:txBody>
-          <a:bodyPr rtlCol="0" anchor="t" wrap="square" lIns="57150" rIns="57150" tIns="47625" bIns="47625"/>
-          <a:lstStyle/>
-          <a:p>
-            <a:pPr algn="ctr"/>
-            <a:r>
-              <a:rPr sz="1300" b="1">
-                <a:solidFill>
-                  <a:srgbClr val="FFFFFF"/>
-                </a:solidFill>
-                <a:latin typeface="Neue Haas Grotesk Text Pro"/>
-              </a:rPr>
-              <a:t>~18%</a:t>
-            </a:r>
-          </a:p>
-        </p:txBody>
-      </p:sp>
-      <p:sp>
-        <p:nvSpPr>
-          <p:cNvPr id="56" name="TextBox 55"/>
-          <p:cNvSpPr txBox="1"/>
-          <p:nvPr/>
-        </p:nvSpPr>
-        <p:spPr>
-          <a:xfrm>
-            <a:off x="10296037" y="3340474"/>
-            <a:ext cx="1391138" cy="342900"/>
-          </a:xfrm>
-          <a:prstGeom prst="rect">
-            <a:avLst/>
-          </a:prstGeom>
-          <a:noFill/>
-        </p:spPr>
-        <p:txBody>
-          <a:bodyPr wrap="square" anchor="b" lIns="0" rIns="0" tIns="0" bIns="0">
-            <a:spAutoFit/>
-          </a:bodyPr>
-          <a:lstStyle/>
-          <a:p>
-            <a:pPr algn="l"/>
-            <a:r>
-              <a:rPr sz="1050" b="1">
-                <a:solidFill>
-                  <a:srgbClr val="FFFFFF"/>
-                </a:solidFill>
-                <a:latin typeface="Neue Haas Grotesk Text Pro"/>
-              </a:rPr>
-              <a:t>Amco Veba, 7</a:t>
-            </a:r>
-          </a:p>
-        </p:txBody>
-      </p:sp>
-      <p:sp>
-        <p:nvSpPr>
-          <p:cNvPr id="57" name="Rectangle 56"/>
-          <p:cNvSpPr/>
-          <p:nvPr/>
-        </p:nvSpPr>
-        <p:spPr>
-          <a:xfrm>
-            <a:off x="10248412" y="3721474"/>
-            <a:ext cx="594555" cy="1288676"/>
-          </a:xfrm>
-          <a:prstGeom prst="rect">
-            <a:avLst/>
-          </a:prstGeom>
-          <a:solidFill>
-            <a:srgbClr val="6FCF97"/>
-          </a:solidFill>
-          <a:ln w="19050">
-            <a:solidFill>
-              <a:srgbClr val="FFFFFF"/>
-            </a:solidFill>
-          </a:ln>
-        </p:spPr>
-        <p:style>
-          <a:lnRef idx="1">
-            <a:schemeClr val="accent1"/>
-          </a:lnRef>
-          <a:fillRef idx="3">
-            <a:schemeClr val="accent1"/>
-          </a:fillRef>
-          <a:effectRef idx="2">
-            <a:schemeClr val="accent1"/>
-          </a:effectRef>
-          <a:fontRef idx="minor">
-            <a:schemeClr val="lt1"/>
-          </a:fontRef>
-        </p:style>
-        <p:txBody>
-          <a:bodyPr rtlCol="0" anchor="t" wrap="square" lIns="57150" rIns="57150" tIns="47625" bIns="47625"/>
-          <a:lstStyle/>
-          <a:p>
-            <a:pPr algn="ctr"/>
-            <a:r>
-              <a:rPr sz="1300" b="1">
-                <a:solidFill>
-                  <a:srgbClr val="000000"/>
-                </a:solidFill>
-                <a:latin typeface="Neue Haas Grotesk Text Pro"/>
-              </a:rPr>
-              <a:t>~10%</a:t>
-            </a:r>
-          </a:p>
-        </p:txBody>
-      </p:sp>
-      <p:sp>
-        <p:nvSpPr>
-          <p:cNvPr id="58" name="TextBox 57"/>
-          <p:cNvSpPr txBox="1"/>
-          <p:nvPr/>
-        </p:nvSpPr>
-        <p:spPr>
-          <a:xfrm>
-            <a:off x="10296037" y="4629150"/>
-            <a:ext cx="499305" cy="342900"/>
-          </a:xfrm>
-          <a:prstGeom prst="rect">
-            <a:avLst/>
-          </a:prstGeom>
-          <a:noFill/>
-        </p:spPr>
-        <p:txBody>
-          <a:bodyPr wrap="square" anchor="b" lIns="0" rIns="0" tIns="0" bIns="0">
-            <a:spAutoFit/>
-          </a:bodyPr>
-          <a:lstStyle/>
-          <a:p>
-            <a:pPr algn="l"/>
-            <a:r>
-              <a:rPr sz="850" b="1">
-                <a:solidFill>
-                  <a:srgbClr val="000000"/>
-                </a:solidFill>
-                <a:latin typeface="Neue Haas Grotesk Text Pro"/>
-              </a:rPr>
-              <a:t>XCMG, 4</a:t>
-            </a:r>
-          </a:p>
-        </p:txBody>
-      </p:sp>
-      <p:sp>
-        <p:nvSpPr>
-          <p:cNvPr id="59" name="Rectangle 58"/>
-          <p:cNvSpPr/>
-          <p:nvPr/>
-        </p:nvSpPr>
-        <p:spPr>
-          <a:xfrm>
-            <a:off x="10842967" y="3721474"/>
-            <a:ext cx="891833" cy="1288676"/>
-          </a:xfrm>
-          <a:prstGeom prst="rect">
-            <a:avLst/>
-          </a:prstGeom>
-          <a:solidFill>
-            <a:srgbClr val="C7EFD5"/>
-          </a:solidFill>
-          <a:ln w="19050">
-            <a:solidFill>
-              <a:srgbClr val="FFFFFF"/>
-            </a:solidFill>
-          </a:ln>
-        </p:spPr>
-        <p:style>
-          <a:lnRef idx="1">
-            <a:schemeClr val="accent1"/>
-          </a:lnRef>
-          <a:fillRef idx="3">
-            <a:schemeClr val="accent1"/>
-          </a:fillRef>
-          <a:effectRef idx="2">
-            <a:schemeClr val="accent1"/>
-          </a:effectRef>
-          <a:fontRef idx="minor">
-            <a:schemeClr val="lt1"/>
-          </a:fontRef>
-        </p:style>
-        <p:txBody>
-          <a:bodyPr rtlCol="0" anchor="t" wrap="square" lIns="57150" rIns="57150" tIns="47625" bIns="47625"/>
-          <a:lstStyle/>
-          <a:p>
-            <a:pPr algn="ctr"/>
-            <a:r>
-              <a:rPr sz="1300" b="1">
-                <a:solidFill>
-                  <a:srgbClr val="000000"/>
-                </a:solidFill>
-                <a:latin typeface="Neue Haas Grotesk Text Pro"/>
-              </a:rPr>
-              <a:t>~15%</a:t>
-            </a:r>
-          </a:p>
-        </p:txBody>
-      </p:sp>
-      <p:sp>
-        <p:nvSpPr>
-          <p:cNvPr id="60" name="TextBox 59"/>
-          <p:cNvSpPr txBox="1"/>
-          <p:nvPr/>
-        </p:nvSpPr>
-        <p:spPr>
-          <a:xfrm>
-            <a:off x="10890592" y="4629150"/>
-            <a:ext cx="796583" cy="342900"/>
-          </a:xfrm>
-          <a:prstGeom prst="rect">
-            <a:avLst/>
-          </a:prstGeom>
-          <a:noFill/>
-        </p:spPr>
-        <p:txBody>
-          <a:bodyPr wrap="square" anchor="b" lIns="0" rIns="0" tIns="0" bIns="0">
-            <a:spAutoFit/>
-          </a:bodyPr>
-          <a:lstStyle/>
-          <a:p>
-            <a:pPr algn="l"/>
-            <a:r>
-              <a:rPr sz="1050" b="1">
-                <a:solidFill>
-                  <a:srgbClr val="000000"/>
-                </a:solidFill>
-                <a:latin typeface="Neue Haas Grotesk Text Pro"/>
-              </a:rPr>
-              <a:t>Others, 6</a:t>
-            </a:r>
-          </a:p>
-        </p:txBody>
-      </p:sp>
-      <p:sp>
-        <p:nvSpPr>
-          <p:cNvPr id="61" name="TextBox 60"/>
-          <p:cNvSpPr txBox="1"/>
-          <p:nvPr/>
-        </p:nvSpPr>
-        <p:spPr>
-          <a:xfrm>
-            <a:off x="8324850" y="5124450"/>
-            <a:ext cx="3409950" cy="171450"/>
-          </a:xfrm>
-          <a:prstGeom prst="rect">
-            <a:avLst/>
-          </a:prstGeom>
-          <a:noFill/>
-        </p:spPr>
-        <p:txBody>
-          <a:bodyPr wrap="square" anchor="t" lIns="0" rIns="0" tIns="0" bIns="0">
-            <a:spAutoFit/>
-          </a:bodyPr>
-          <a:lstStyle/>
-          <a:p>
-            <a:pPr algn="l"/>
-            <a:r>
-              <a:rPr sz="1100" b="1">
-                <a:solidFill>
-                  <a:srgbClr val="000000"/>
-                </a:solidFill>
-                <a:latin typeface="Neue Haas Grotesk Text Pro"/>
-              </a:rPr>
-              <a:t>Triatra Heavy market share, </a:t>
-            </a:r>
-            <a:r>
-              <a:rPr sz="1100" b="0">
-                <a:solidFill>
-                  <a:srgbClr val="000000"/>
-                </a:solidFill>
-                <a:latin typeface="Neue Haas Grotesk Text Pro"/>
-              </a:rPr>
-              <a:t>quantity of sales</a:t>
-            </a:r>
-          </a:p>
-        </p:txBody>
-      </p:sp>
-      <p:sp>
-        <p:nvSpPr>
-          <p:cNvPr id="62" name="Rectangle 61"/>
-          <p:cNvSpPr/>
-          <p:nvPr/>
-        </p:nvSpPr>
-        <p:spPr>
-          <a:xfrm>
-            <a:off x="8324850" y="5353050"/>
-            <a:ext cx="95250" cy="95250"/>
-          </a:xfrm>
-          <a:prstGeom prst="rect">
-            <a:avLst/>
-          </a:prstGeom>
-          <a:solidFill>
-            <a:srgbClr val="1E9E57"/>
-          </a:solidFill>
-          <a:ln w="6350">
-            <a:solidFill>
-              <a:srgbClr val="1E9E57"/>
-            </a:solidFill>
-          </a:ln>
-        </p:spPr>
-        <p:style>
-          <a:lnRef idx="1">
-            <a:schemeClr val="accent1"/>
-          </a:lnRef>
-          <a:fillRef idx="3">
-            <a:schemeClr val="accent1"/>
-          </a:fillRef>
-          <a:effectRef idx="2">
-            <a:schemeClr val="accent1"/>
-          </a:effectRef>
-          <a:fontRef idx="minor">
-            <a:schemeClr val="lt1"/>
-          </a:fontRef>
-        </p:style>
-        <p:txBody>
-          <a:bodyPr rtlCol="0" anchor="ctr"/>
-          <a:lstStyle/>
-          <a:p>
-            <a:pPr algn="ctr"/>
-          </a:p>
-        </p:txBody>
-      </p:sp>
-      <p:sp>
-        <p:nvSpPr>
-          <p:cNvPr id="63" name="TextBox 62"/>
-          <p:cNvSpPr txBox="1"/>
-          <p:nvPr/>
-        </p:nvSpPr>
-        <p:spPr>
-          <a:xfrm>
-            <a:off x="8458200" y="5324475"/>
-            <a:ext cx="571500" cy="152400"/>
-          </a:xfrm>
-          <a:prstGeom prst="rect">
-            <a:avLst/>
-          </a:prstGeom>
-          <a:noFill/>
-        </p:spPr>
-        <p:txBody>
-          <a:bodyPr wrap="square" anchor="t" lIns="0" rIns="0" tIns="0" bIns="0">
-            <a:spAutoFit/>
-          </a:bodyPr>
-          <a:lstStyle/>
-          <a:p>
-            <a:pPr algn="l"/>
-            <a:r>
-              <a:rPr sz="900" b="0">
-                <a:solidFill>
-                  <a:srgbClr val="000000"/>
-                </a:solidFill>
-                <a:latin typeface="Neue Haas Grotesk Text Pro"/>
-              </a:rPr>
-              <a:t>Triatra</a:t>
-            </a:r>
-          </a:p>
-        </p:txBody>
-      </p:sp>
-      <p:sp>
-        <p:nvSpPr>
-          <p:cNvPr id="64" name="Rectangle 63"/>
-          <p:cNvSpPr/>
-          <p:nvPr/>
-        </p:nvSpPr>
-        <p:spPr>
-          <a:xfrm>
-            <a:off x="9010650" y="5353050"/>
-            <a:ext cx="95250" cy="95250"/>
-          </a:xfrm>
-          <a:prstGeom prst="rect">
-            <a:avLst/>
-          </a:prstGeom>
-          <a:solidFill>
-            <a:srgbClr val="D9D9D9"/>
-          </a:solidFill>
-          <a:ln w="6350">
-            <a:solidFill>
-              <a:srgbClr val="D9D9D9"/>
-            </a:solidFill>
-          </a:ln>
-        </p:spPr>
-        <p:style>
-          <a:lnRef idx="1">
-            <a:schemeClr val="accent1"/>
-          </a:lnRef>
-          <a:fillRef idx="3">
-            <a:schemeClr val="accent1"/>
-          </a:fillRef>
-          <a:effectRef idx="2">
-            <a:schemeClr val="accent1"/>
-          </a:effectRef>
-          <a:fontRef idx="minor">
-            <a:schemeClr val="lt1"/>
-          </a:fontRef>
-        </p:style>
-        <p:txBody>
-          <a:bodyPr rtlCol="0" anchor="ctr"/>
-          <a:lstStyle/>
-          <a:p>
-            <a:pPr algn="ctr"/>
-          </a:p>
-        </p:txBody>
-      </p:sp>
-      <p:sp>
-        <p:nvSpPr>
-          <p:cNvPr id="65" name="TextBox 64"/>
-          <p:cNvSpPr txBox="1"/>
-          <p:nvPr/>
-        </p:nvSpPr>
-        <p:spPr>
-          <a:xfrm>
-            <a:off x="9144000" y="5324475"/>
-            <a:ext cx="952500" cy="152400"/>
-          </a:xfrm>
-          <a:prstGeom prst="rect">
-            <a:avLst/>
-          </a:prstGeom>
-          <a:noFill/>
-        </p:spPr>
-        <p:txBody>
-          <a:bodyPr wrap="square" anchor="t" lIns="0" rIns="0" tIns="0" bIns="0">
-            <a:spAutoFit/>
-          </a:bodyPr>
-          <a:lstStyle/>
-          <a:p>
-            <a:pPr algn="l"/>
-            <a:r>
-              <a:rPr sz="900" b="0">
-                <a:solidFill>
-                  <a:srgbClr val="000000"/>
-                </a:solidFill>
-                <a:latin typeface="Neue Haas Grotesk Text Pro"/>
-              </a:rPr>
-              <a:t>Rest of market</a:t>
-            </a:r>
-          </a:p>
-        </p:txBody>
-      </p:sp>
-      <p:sp>
-        <p:nvSpPr>
-          <p:cNvPr id="66" name="Rectangle 65"/>
-          <p:cNvSpPr/>
-          <p:nvPr/>
-        </p:nvSpPr>
-        <p:spPr>
-          <a:xfrm>
-            <a:off x="8324850" y="5562600"/>
-            <a:ext cx="3409950" cy="285750"/>
-          </a:xfrm>
-          <a:prstGeom prst="rect">
-            <a:avLst/>
-          </a:prstGeom>
-          <a:solidFill>
-            <a:srgbClr val="F2F2F2"/>
-          </a:solidFill>
-          <a:ln w="9525">
-            <a:solidFill>
-              <a:srgbClr val="BFBFBF"/>
-            </a:solidFill>
-          </a:ln>
-        </p:spPr>
-        <p:style>
-          <a:lnRef idx="1">
-            <a:schemeClr val="accent1"/>
-          </a:lnRef>
-          <a:fillRef idx="3">
-            <a:schemeClr val="accent1"/>
-          </a:fillRef>
-          <a:effectRef idx="2">
-            <a:schemeClr val="accent1"/>
-          </a:effectRef>
-          <a:fontRef idx="minor">
-            <a:schemeClr val="lt1"/>
-          </a:fontRef>
-        </p:style>
-        <p:txBody>
-          <a:bodyPr rtlCol="0" anchor="ctr"/>
-          <a:lstStyle/>
-          <a:p>
-            <a:pPr algn="ctr"/>
-            <a:r>
-              <a:rPr sz="1000" i="1">
-                <a:solidFill>
-                  <a:srgbClr val="6B6B6B"/>
-                </a:solidFill>
-                <a:latin typeface="Neue Haas Grotesk Text Pro"/>
-              </a:rPr>
-              <a:t>Triatra units sold in 2025: to be added  ·  market = 39 units</a:t>
-            </a:r>
-          </a:p>
-        </p:txBody>
-      </p:sp>
-      <p:sp>
-        <p:nvSpPr>
-          <p:cNvPr id="67" name="TextBox 66"/>
-          <p:cNvSpPr txBox="1"/>
-          <p:nvPr/>
-        </p:nvSpPr>
-        <p:spPr>
-          <a:xfrm>
-            <a:off x="8324850" y="5905500"/>
-            <a:ext cx="3409950" cy="266700"/>
-          </a:xfrm>
-          <a:prstGeom prst="rect">
-            <a:avLst/>
-          </a:prstGeom>
-          <a:noFill/>
-        </p:spPr>
-        <p:txBody>
-          <a:bodyPr wrap="square" anchor="t" lIns="0" rIns="0" tIns="0" bIns="0">
-            <a:spAutoFit/>
-          </a:bodyPr>
-          <a:lstStyle/>
-          <a:p>
-            <a:pPr algn="l"/>
-            <a:r>
-              <a:rPr sz="1100" b="1">
-                <a:solidFill>
-                  <a:srgbClr val="1E9E57"/>
-                </a:solidFill>
-                <a:latin typeface="Neue Haas Grotesk Text Pro"/>
-              </a:rPr>
-              <a:t>Palfinger holds 22 of 39 units (56%)</a:t>
-            </a:r>
-          </a:p>
-        </p:txBody>
-      </p:sp>
-      <p:sp>
-        <p:nvSpPr>
-          <p:cNvPr id="68" name="TextBox 67"/>
-          <p:cNvSpPr txBox="1"/>
-          <p:nvPr/>
-        </p:nvSpPr>
-        <p:spPr>
-          <a:xfrm>
-            <a:off x="342900" y="6305550"/>
-            <a:ext cx="11506200" cy="152400"/>
-          </a:xfrm>
-          <a:prstGeom prst="rect">
-            <a:avLst/>
-          </a:prstGeom>
-          <a:noFill/>
-        </p:spPr>
-        <p:txBody>
-          <a:bodyPr wrap="square" anchor="t" lIns="0" rIns="0" tIns="0" bIns="0">
-            <a:spAutoFit/>
-          </a:bodyPr>
-          <a:lstStyle/>
-          <a:p>
-            <a:pPr algn="l"/>
-            <a:r>
-              <a:rPr sz="1000" b="1">
-                <a:solidFill>
-                  <a:srgbClr val="000000"/>
-                </a:solidFill>
-                <a:latin typeface="Neue Haas Grotesk Text Pro"/>
-              </a:rPr>
-              <a:t>Source: </a:t>
-            </a:r>
-            <a:r>
-              <a:rPr sz="1000" b="0">
-                <a:solidFill>
-                  <a:srgbClr val="000000"/>
-                </a:solidFill>
-                <a:latin typeface="Neue Haas Grotesk Text Pro"/>
-              </a:rPr>
-              <a:t>Indonesia import records 2025, knuckle boom (folding) cranes; value converted from USD at assumed Rp 16.000/USD (Bio = billion).</a:t>
-            </a:r>
-          </a:p>
-        </p:txBody>
-      </p:sp>
-      <p:sp>
-        <p:nvSpPr>
-          <p:cNvPr id="69" name="TextBox 68"/>
-          <p:cNvSpPr txBox="1"/>
-          <p:nvPr/>
-        </p:nvSpPr>
-        <p:spPr>
-          <a:xfrm>
-            <a:off x="342900" y="6477000"/>
-            <a:ext cx="11506200" cy="152400"/>
-          </a:xfrm>
-          <a:prstGeom prst="rect">
-            <a:avLst/>
-          </a:prstGeom>
-          <a:noFill/>
-        </p:spPr>
-        <p:txBody>
-          <a:bodyPr wrap="square" anchor="t" lIns="0" rIns="0" tIns="0" bIns="0">
-            <a:spAutoFit/>
-          </a:bodyPr>
-          <a:lstStyle/>
-          <a:p>
-            <a:pPr algn="l"/>
-            <a:r>
               <a:rPr sz="1000" b="1">
                 <a:solidFill>
                   <a:srgbClr val="6B6B6B"/>
@@ -6607,7 +6620,7 @@
       </p:sp>
       <p:cxnSp>
         <p:nvCxnSpPr>
-          <p:cNvPr id="70" name="Connector 69"/>
+          <p:cNvPr id="66" name="Connector 65"/>
           <p:cNvCxnSpPr/>
           <p:nvPr/>
         </p:nvCxnSpPr>

</xml_diff>

<commit_message>
Use native charts with live data and formulas for 2025 slide
Co-Authored-By: Claude Opus 5.5 <noreply@anthropic.com>
Claude-Session: https://claude.ai/code/session_01Cx9kswyecF7JAB1Rr5vVcV
</commit_message>
<xml_diff>
--- a/nedp_deck/Slide_2025_Medium_Heavy_Funnel.pptx
+++ b/nedp_deck/Slide_2025_Medium_Heavy_Funnel.pptx
@@ -152,91 +152,25 @@
             </a:ln>
           </c:spPr>
           <c:dLbls>
-            <c:dLbl>
-              <c:idx val="0"/>
-              <c:tx>
-                <c:rich>
-                  <a:bodyPr/>
-                  <a:lstStyle/>
-                  <a:p>
-                    <a:r>
-                      <a:rPr b="1">
-                        <a:solidFill>
-                          <a:srgbClr val="595959"/>
-                        </a:solidFill>
-                      </a:rPr>
-                      <a:t>Light 53</a:t>
-                    </a:r>
-                  </a:p>
-                  <a:p>
-                    <a:r>
-                      <a:rPr b="1">
-                        <a:solidFill>
-                          <a:srgbClr val="595959"/>
-                        </a:solidFill>
-                      </a:rPr>
-                      <a:t>23%</a:t>
-                    </a:r>
-                  </a:p>
-                </c:rich>
-              </c:tx>
-              <c:showLegendKey val="0"/>
-              <c:showVal val="1"/>
-              <c:showCatName val="0"/>
-              <c:showSerName val="0"/>
-              <c:showPercent val="0"/>
-              <c:showBubbleSize val="0"/>
-            </c:dLbl>
-            <c:dLbl>
-              <c:idx val="1"/>
-              <c:tx>
-                <c:rich>
-                  <a:bodyPr/>
-                  <a:lstStyle/>
-                  <a:p>
-                    <a:r>
-                      <a:rPr b="1">
-                        <a:solidFill>
-                          <a:srgbClr val="595959"/>
-                        </a:solidFill>
-                      </a:rPr>
-                      <a:t>Rp 8,8 Bio</a:t>
-                    </a:r>
-                  </a:p>
-                  <a:p>
-                    <a:r>
-                      <a:rPr b="1">
-                        <a:solidFill>
-                          <a:srgbClr val="595959"/>
-                        </a:solidFill>
-                      </a:rPr>
-                      <a:t>8%</a:t>
-                    </a:r>
-                  </a:p>
-                </c:rich>
-              </c:tx>
-              <c:showLegendKey val="0"/>
-              <c:showVal val="1"/>
-              <c:showCatName val="0"/>
-              <c:showSerName val="0"/>
-              <c:showPercent val="0"/>
-              <c:showBubbleSize val="0"/>
-            </c:dLbl>
+            <c:numFmt formatCode="General" sourceLinked="0"/>
             <c:txPr>
               <a:bodyPr/>
               <a:lstStyle/>
               <a:p>
                 <a:pPr>
-                  <a:defRPr sz="900">
+                  <a:defRPr sz="900" b="1">
+                    <a:solidFill>
+                      <a:srgbClr val="404040"/>
+                    </a:solidFill>
                     <a:latin typeface="Neue Haas Grotesk Text Pro"/>
                   </a:defRPr>
                 </a:pPr>
               </a:p>
             </c:txPr>
             <c:showLegendKey val="0"/>
-            <c:showVal val="0"/>
+            <c:showVal val="1"/>
             <c:showCatName val="0"/>
-            <c:showSerName val="0"/>
+            <c:showSerName val="1"/>
             <c:showPercent val="0"/>
             <c:showBubbleSize val="0"/>
             <c:showLeaderLines val="1"/>
@@ -250,7 +184,7 @@
                   <c:v>Units (227)</c:v>
                 </c:pt>
                 <c:pt idx="1">
-                  <c:v>Value (Rp 112,6 Bio)</c:v>
+                  <c:v>Value (Rp Bio)</c:v>
                 </c:pt>
               </c:strCache>
             </c:strRef>
@@ -265,7 +199,7 @@
                   <c:v>53</c:v>
                 </c:pt>
                 <c:pt idx="1">
-                  <c:v>8.81608</c:v>
+                  <c:v>8.8</c:v>
                 </c:pt>
               </c:numCache>
             </c:numRef>
@@ -296,91 +230,25 @@
             </a:ln>
           </c:spPr>
           <c:dLbls>
-            <c:dLbl>
-              <c:idx val="0"/>
-              <c:tx>
-                <c:rich>
-                  <a:bodyPr/>
-                  <a:lstStyle/>
-                  <a:p>
-                    <a:r>
-                      <a:rPr b="1">
-                        <a:solidFill>
-                          <a:srgbClr val="595959"/>
-                        </a:solidFill>
-                      </a:rPr>
-                      <a:t>Small 75</a:t>
-                    </a:r>
-                  </a:p>
-                  <a:p>
-                    <a:r>
-                      <a:rPr b="1">
-                        <a:solidFill>
-                          <a:srgbClr val="595959"/>
-                        </a:solidFill>
-                      </a:rPr>
-                      <a:t>33%</a:t>
-                    </a:r>
-                  </a:p>
-                </c:rich>
-              </c:tx>
-              <c:showLegendKey val="0"/>
-              <c:showVal val="1"/>
-              <c:showCatName val="0"/>
-              <c:showSerName val="0"/>
-              <c:showPercent val="0"/>
-              <c:showBubbleSize val="0"/>
-            </c:dLbl>
-            <c:dLbl>
-              <c:idx val="1"/>
-              <c:tx>
-                <c:rich>
-                  <a:bodyPr/>
-                  <a:lstStyle/>
-                  <a:p>
-                    <a:r>
-                      <a:rPr b="1">
-                        <a:solidFill>
-                          <a:srgbClr val="595959"/>
-                        </a:solidFill>
-                      </a:rPr>
-                      <a:t>Rp 28,4 Bio</a:t>
-                    </a:r>
-                  </a:p>
-                  <a:p>
-                    <a:r>
-                      <a:rPr b="1">
-                        <a:solidFill>
-                          <a:srgbClr val="595959"/>
-                        </a:solidFill>
-                      </a:rPr>
-                      <a:t>25%</a:t>
-                    </a:r>
-                  </a:p>
-                </c:rich>
-              </c:tx>
-              <c:showLegendKey val="0"/>
-              <c:showVal val="1"/>
-              <c:showCatName val="0"/>
-              <c:showSerName val="0"/>
-              <c:showPercent val="0"/>
-              <c:showBubbleSize val="0"/>
-            </c:dLbl>
+            <c:numFmt formatCode="General" sourceLinked="0"/>
             <c:txPr>
               <a:bodyPr/>
               <a:lstStyle/>
               <a:p>
                 <a:pPr>
-                  <a:defRPr sz="900">
+                  <a:defRPr sz="900" b="1">
+                    <a:solidFill>
+                      <a:srgbClr val="404040"/>
+                    </a:solidFill>
                     <a:latin typeface="Neue Haas Grotesk Text Pro"/>
                   </a:defRPr>
                 </a:pPr>
               </a:p>
             </c:txPr>
             <c:showLegendKey val="0"/>
-            <c:showVal val="0"/>
+            <c:showVal val="1"/>
             <c:showCatName val="0"/>
-            <c:showSerName val="0"/>
+            <c:showSerName val="1"/>
             <c:showPercent val="0"/>
             <c:showBubbleSize val="0"/>
             <c:showLeaderLines val="1"/>
@@ -394,7 +262,7 @@
                   <c:v>Units (227)</c:v>
                 </c:pt>
                 <c:pt idx="1">
-                  <c:v>Value (Rp 112,6 Bio)</c:v>
+                  <c:v>Value (Rp Bio)</c:v>
                 </c:pt>
               </c:strCache>
             </c:strRef>
@@ -409,7 +277,7 @@
                   <c:v>75</c:v>
                 </c:pt>
                 <c:pt idx="1">
-                  <c:v>28.433984</c:v>
+                  <c:v>28.4</c:v>
                 </c:pt>
               </c:numCache>
             </c:numRef>
@@ -440,91 +308,25 @@
             </a:ln>
           </c:spPr>
           <c:dLbls>
-            <c:dLbl>
-              <c:idx val="0"/>
-              <c:tx>
-                <c:rich>
-                  <a:bodyPr/>
-                  <a:lstStyle/>
-                  <a:p>
-                    <a:r>
-                      <a:rPr b="1">
-                        <a:solidFill>
-                          <a:srgbClr val="FFFFFF"/>
-                        </a:solidFill>
-                      </a:rPr>
-                      <a:t>Medium 60</a:t>
-                    </a:r>
-                  </a:p>
-                  <a:p>
-                    <a:r>
-                      <a:rPr b="1">
-                        <a:solidFill>
-                          <a:srgbClr val="FFFFFF"/>
-                        </a:solidFill>
-                      </a:rPr>
-                      <a:t>26%</a:t>
-                    </a:r>
-                  </a:p>
-                </c:rich>
-              </c:tx>
-              <c:showLegendKey val="0"/>
-              <c:showVal val="1"/>
-              <c:showCatName val="0"/>
-              <c:showSerName val="0"/>
-              <c:showPercent val="0"/>
-              <c:showBubbleSize val="0"/>
-            </c:dLbl>
-            <c:dLbl>
-              <c:idx val="1"/>
-              <c:tx>
-                <c:rich>
-                  <a:bodyPr/>
-                  <a:lstStyle/>
-                  <a:p>
-                    <a:r>
-                      <a:rPr b="1">
-                        <a:solidFill>
-                          <a:srgbClr val="FFFFFF"/>
-                        </a:solidFill>
-                      </a:rPr>
-                      <a:t>Rp 28,2 Bio</a:t>
-                    </a:r>
-                  </a:p>
-                  <a:p>
-                    <a:r>
-                      <a:rPr b="1">
-                        <a:solidFill>
-                          <a:srgbClr val="FFFFFF"/>
-                        </a:solidFill>
-                      </a:rPr>
-                      <a:t>25%</a:t>
-                    </a:r>
-                  </a:p>
-                </c:rich>
-              </c:tx>
-              <c:showLegendKey val="0"/>
-              <c:showVal val="1"/>
-              <c:showCatName val="0"/>
-              <c:showSerName val="0"/>
-              <c:showPercent val="0"/>
-              <c:showBubbleSize val="0"/>
-            </c:dLbl>
+            <c:numFmt formatCode="General" sourceLinked="0"/>
             <c:txPr>
               <a:bodyPr/>
               <a:lstStyle/>
               <a:p>
                 <a:pPr>
-                  <a:defRPr sz="900">
+                  <a:defRPr sz="900" b="1">
+                    <a:solidFill>
+                      <a:srgbClr val="FFFFFF"/>
+                    </a:solidFill>
                     <a:latin typeface="Neue Haas Grotesk Text Pro"/>
                   </a:defRPr>
                 </a:pPr>
               </a:p>
             </c:txPr>
             <c:showLegendKey val="0"/>
-            <c:showVal val="0"/>
+            <c:showVal val="1"/>
             <c:showCatName val="0"/>
-            <c:showSerName val="0"/>
+            <c:showSerName val="1"/>
             <c:showPercent val="0"/>
             <c:showBubbleSize val="0"/>
             <c:showLeaderLines val="1"/>
@@ -538,7 +340,7 @@
                   <c:v>Units (227)</c:v>
                 </c:pt>
                 <c:pt idx="1">
-                  <c:v>Value (Rp 112,6 Bio)</c:v>
+                  <c:v>Value (Rp Bio)</c:v>
                 </c:pt>
               </c:strCache>
             </c:strRef>
@@ -553,7 +355,7 @@
                   <c:v>60</c:v>
                 </c:pt>
                 <c:pt idx="1">
-                  <c:v>28.150192</c:v>
+                  <c:v>28.2</c:v>
                 </c:pt>
               </c:numCache>
             </c:numRef>
@@ -584,91 +386,25 @@
             </a:ln>
           </c:spPr>
           <c:dLbls>
-            <c:dLbl>
-              <c:idx val="0"/>
-              <c:tx>
-                <c:rich>
-                  <a:bodyPr/>
-                  <a:lstStyle/>
-                  <a:p>
-                    <a:r>
-                      <a:rPr b="1">
-                        <a:solidFill>
-                          <a:srgbClr val="FFFFFF"/>
-                        </a:solidFill>
-                      </a:rPr>
-                      <a:t>Heavy 39</a:t>
-                    </a:r>
-                  </a:p>
-                  <a:p>
-                    <a:r>
-                      <a:rPr b="1">
-                        <a:solidFill>
-                          <a:srgbClr val="FFFFFF"/>
-                        </a:solidFill>
-                      </a:rPr>
-                      <a:t>17%</a:t>
-                    </a:r>
-                  </a:p>
-                </c:rich>
-              </c:tx>
-              <c:showLegendKey val="0"/>
-              <c:showVal val="1"/>
-              <c:showCatName val="0"/>
-              <c:showSerName val="0"/>
-              <c:showPercent val="0"/>
-              <c:showBubbleSize val="0"/>
-            </c:dLbl>
-            <c:dLbl>
-              <c:idx val="1"/>
-              <c:tx>
-                <c:rich>
-                  <a:bodyPr/>
-                  <a:lstStyle/>
-                  <a:p>
-                    <a:r>
-                      <a:rPr b="1">
-                        <a:solidFill>
-                          <a:srgbClr val="FFFFFF"/>
-                        </a:solidFill>
-                      </a:rPr>
-                      <a:t>Rp 47,2 Bio</a:t>
-                    </a:r>
-                  </a:p>
-                  <a:p>
-                    <a:r>
-                      <a:rPr b="1">
-                        <a:solidFill>
-                          <a:srgbClr val="FFFFFF"/>
-                        </a:solidFill>
-                      </a:rPr>
-                      <a:t>42%</a:t>
-                    </a:r>
-                  </a:p>
-                </c:rich>
-              </c:tx>
-              <c:showLegendKey val="0"/>
-              <c:showVal val="1"/>
-              <c:showCatName val="0"/>
-              <c:showSerName val="0"/>
-              <c:showPercent val="0"/>
-              <c:showBubbleSize val="0"/>
-            </c:dLbl>
+            <c:numFmt formatCode="General" sourceLinked="0"/>
             <c:txPr>
               <a:bodyPr/>
               <a:lstStyle/>
               <a:p>
                 <a:pPr>
-                  <a:defRPr sz="900">
+                  <a:defRPr sz="900" b="1">
+                    <a:solidFill>
+                      <a:srgbClr val="FFFFFF"/>
+                    </a:solidFill>
                     <a:latin typeface="Neue Haas Grotesk Text Pro"/>
                   </a:defRPr>
                 </a:pPr>
               </a:p>
             </c:txPr>
             <c:showLegendKey val="0"/>
-            <c:showVal val="0"/>
+            <c:showVal val="1"/>
             <c:showCatName val="0"/>
-            <c:showSerName val="0"/>
+            <c:showSerName val="1"/>
             <c:showPercent val="0"/>
             <c:showBubbleSize val="0"/>
             <c:showLeaderLines val="1"/>
@@ -682,7 +418,7 @@
                   <c:v>Units (227)</c:v>
                 </c:pt>
                 <c:pt idx="1">
-                  <c:v>Value (Rp 112,6 Bio)</c:v>
+                  <c:v>Value (Rp Bio)</c:v>
                 </c:pt>
               </c:strCache>
             </c:strRef>
@@ -697,7 +433,7 @@
                   <c:v>39</c:v>
                 </c:pt>
                 <c:pt idx="1">
-                  <c:v>47.227872</c:v>
+                  <c:v>47.2</c:v>
                 </c:pt>
               </c:numCache>
             </c:numRef>
@@ -772,6 +508,497 @@
     <a:p>
       <a:pPr>
         <a:defRPr sz="900">
+          <a:latin typeface="Neue Haas Grotesk Text Pro"/>
+        </a:defRPr>
+      </a:pPr>
+      <a:endParaRPr lang="en-US"/>
+    </a:p>
+  </c:txPr>
+  <c:externalData r:id="rId1">
+    <c:autoUpdate val="0"/>
+  </c:externalData>
+</c:chartSpace>
+</file>
+
+<file path=ppt/charts/chart2.xml><?xml version="1.0" encoding="utf-8"?>
+<c:chartSpace xmlns:c="http://schemas.openxmlformats.org/drawingml/2006/chart" xmlns:a="http://schemas.openxmlformats.org/drawingml/2006/main" xmlns:r="http://schemas.openxmlformats.org/officeDocument/2006/relationships">
+  <c:date1904 val="0"/>
+  <c:chart>
+    <c:autoTitleDeleted val="0"/>
+    <c:plotArea>
+      <c:barChart>
+        <c:barDir val="bar"/>
+        <c:grouping val="percentStacked"/>
+        <c:ser>
+          <c:idx val="0"/>
+          <c:order val="0"/>
+          <c:tx>
+            <c:strRef>
+              <c:f>Sheet1!$B$1</c:f>
+              <c:strCache>
+                <c:ptCount val="1"/>
+                <c:pt idx="0">
+                  <c:v>Sany Palfinger</c:v>
+                </c:pt>
+              </c:strCache>
+            </c:strRef>
+          </c:tx>
+          <c:spPr>
+            <a:solidFill>
+              <a:srgbClr val="0B4D2A"/>
+            </a:solidFill>
+            <a:ln>
+              <a:solidFill>
+                <a:srgbClr val="FFFFFF"/>
+              </a:solidFill>
+            </a:ln>
+          </c:spPr>
+          <c:dLbls>
+            <c:numFmt formatCode="0&quot; units&quot;;;;" sourceLinked="0"/>
+            <c:txPr>
+              <a:bodyPr/>
+              <a:lstStyle/>
+              <a:p>
+                <a:pPr>
+                  <a:defRPr sz="1000" b="1">
+                    <a:solidFill>
+                      <a:srgbClr val="FFFFFF"/>
+                    </a:solidFill>
+                    <a:latin typeface="Neue Haas Grotesk Text Pro"/>
+                  </a:defRPr>
+                </a:pPr>
+              </a:p>
+            </c:txPr>
+            <c:showLegendKey val="0"/>
+            <c:showVal val="1"/>
+            <c:showCatName val="0"/>
+            <c:showSerName val="0"/>
+            <c:showPercent val="0"/>
+            <c:showBubbleSize val="0"/>
+            <c:showLeaderLines val="1"/>
+          </c:dLbls>
+          <c:cat>
+            <c:strRef>
+              <c:f>Sheet1!$A$2:$A$3</c:f>
+              <c:strCache>
+                <c:ptCount val="2"/>
+                <c:pt idx="0">
+                  <c:v>Medium</c:v>
+                </c:pt>
+                <c:pt idx="1">
+                  <c:v>Heavy</c:v>
+                </c:pt>
+              </c:strCache>
+            </c:strRef>
+          </c:cat>
+          <c:val>
+            <c:numRef>
+              <c:f>Sheet1!$B$2:$B$3</c:f>
+              <c:numCache>
+                <c:formatCode>General</c:formatCode>
+                <c:ptCount val="2"/>
+                <c:pt idx="0">
+                  <c:v>30</c:v>
+                </c:pt>
+                <c:pt idx="1">
+                  <c:v>0</c:v>
+                </c:pt>
+              </c:numCache>
+            </c:numRef>
+          </c:val>
+        </c:ser>
+        <c:ser>
+          <c:idx val="1"/>
+          <c:order val="1"/>
+          <c:tx>
+            <c:strRef>
+              <c:f>Sheet1!$C$1</c:f>
+              <c:strCache>
+                <c:ptCount val="1"/>
+                <c:pt idx="0">
+                  <c:v>Palfinger</c:v>
+                </c:pt>
+              </c:strCache>
+            </c:strRef>
+          </c:tx>
+          <c:spPr>
+            <a:solidFill>
+              <a:srgbClr val="1E9E57"/>
+            </a:solidFill>
+            <a:ln>
+              <a:solidFill>
+                <a:srgbClr val="FFFFFF"/>
+              </a:solidFill>
+            </a:ln>
+          </c:spPr>
+          <c:dLbls>
+            <c:numFmt formatCode="0&quot; units&quot;;;;" sourceLinked="0"/>
+            <c:txPr>
+              <a:bodyPr/>
+              <a:lstStyle/>
+              <a:p>
+                <a:pPr>
+                  <a:defRPr sz="1000" b="1">
+                    <a:solidFill>
+                      <a:srgbClr val="FFFFFF"/>
+                    </a:solidFill>
+                    <a:latin typeface="Neue Haas Grotesk Text Pro"/>
+                  </a:defRPr>
+                </a:pPr>
+              </a:p>
+            </c:txPr>
+            <c:showLegendKey val="0"/>
+            <c:showVal val="1"/>
+            <c:showCatName val="0"/>
+            <c:showSerName val="0"/>
+            <c:showPercent val="0"/>
+            <c:showBubbleSize val="0"/>
+            <c:showLeaderLines val="1"/>
+          </c:dLbls>
+          <c:cat>
+            <c:strRef>
+              <c:f>Sheet1!$A$2:$A$3</c:f>
+              <c:strCache>
+                <c:ptCount val="2"/>
+                <c:pt idx="0">
+                  <c:v>Medium</c:v>
+                </c:pt>
+                <c:pt idx="1">
+                  <c:v>Heavy</c:v>
+                </c:pt>
+              </c:strCache>
+            </c:strRef>
+          </c:cat>
+          <c:val>
+            <c:numRef>
+              <c:f>Sheet1!$C$2:$C$3</c:f>
+              <c:numCache>
+                <c:formatCode>General</c:formatCode>
+                <c:ptCount val="2"/>
+                <c:pt idx="0">
+                  <c:v>5</c:v>
+                </c:pt>
+                <c:pt idx="1">
+                  <c:v>22</c:v>
+                </c:pt>
+              </c:numCache>
+            </c:numRef>
+          </c:val>
+        </c:ser>
+        <c:ser>
+          <c:idx val="2"/>
+          <c:order val="2"/>
+          <c:tx>
+            <c:strRef>
+              <c:f>Sheet1!$D$1</c:f>
+              <c:strCache>
+                <c:ptCount val="1"/>
+                <c:pt idx="0">
+                  <c:v>XCMG</c:v>
+                </c:pt>
+              </c:strCache>
+            </c:strRef>
+          </c:tx>
+          <c:spPr>
+            <a:solidFill>
+              <a:srgbClr val="6FCF97"/>
+            </a:solidFill>
+            <a:ln>
+              <a:solidFill>
+                <a:srgbClr val="FFFFFF"/>
+              </a:solidFill>
+            </a:ln>
+          </c:spPr>
+          <c:dLbls>
+            <c:numFmt formatCode="0&quot; units&quot;;;;" sourceLinked="0"/>
+            <c:txPr>
+              <a:bodyPr/>
+              <a:lstStyle/>
+              <a:p>
+                <a:pPr>
+                  <a:defRPr sz="1000" b="1">
+                    <a:solidFill>
+                      <a:srgbClr val="000000"/>
+                    </a:solidFill>
+                    <a:latin typeface="Neue Haas Grotesk Text Pro"/>
+                  </a:defRPr>
+                </a:pPr>
+              </a:p>
+            </c:txPr>
+            <c:showLegendKey val="0"/>
+            <c:showVal val="1"/>
+            <c:showCatName val="0"/>
+            <c:showSerName val="0"/>
+            <c:showPercent val="0"/>
+            <c:showBubbleSize val="0"/>
+            <c:showLeaderLines val="1"/>
+          </c:dLbls>
+          <c:cat>
+            <c:strRef>
+              <c:f>Sheet1!$A$2:$A$3</c:f>
+              <c:strCache>
+                <c:ptCount val="2"/>
+                <c:pt idx="0">
+                  <c:v>Medium</c:v>
+                </c:pt>
+                <c:pt idx="1">
+                  <c:v>Heavy</c:v>
+                </c:pt>
+              </c:strCache>
+            </c:strRef>
+          </c:cat>
+          <c:val>
+            <c:numRef>
+              <c:f>Sheet1!$D$2:$D$3</c:f>
+              <c:numCache>
+                <c:formatCode>General</c:formatCode>
+                <c:ptCount val="2"/>
+                <c:pt idx="0">
+                  <c:v>14</c:v>
+                </c:pt>
+                <c:pt idx="1">
+                  <c:v>4</c:v>
+                </c:pt>
+              </c:numCache>
+            </c:numRef>
+          </c:val>
+        </c:ser>
+        <c:ser>
+          <c:idx val="3"/>
+          <c:order val="3"/>
+          <c:tx>
+            <c:strRef>
+              <c:f>Sheet1!$E$1</c:f>
+              <c:strCache>
+                <c:ptCount val="1"/>
+                <c:pt idx="0">
+                  <c:v>Amco Veba</c:v>
+                </c:pt>
+              </c:strCache>
+            </c:strRef>
+          </c:tx>
+          <c:spPr>
+            <a:solidFill>
+              <a:srgbClr val="9ADBB5"/>
+            </a:solidFill>
+            <a:ln>
+              <a:solidFill>
+                <a:srgbClr val="FFFFFF"/>
+              </a:solidFill>
+            </a:ln>
+          </c:spPr>
+          <c:dLbls>
+            <c:numFmt formatCode="0&quot; units&quot;;;;" sourceLinked="0"/>
+            <c:txPr>
+              <a:bodyPr/>
+              <a:lstStyle/>
+              <a:p>
+                <a:pPr>
+                  <a:defRPr sz="1000" b="1">
+                    <a:solidFill>
+                      <a:srgbClr val="000000"/>
+                    </a:solidFill>
+                    <a:latin typeface="Neue Haas Grotesk Text Pro"/>
+                  </a:defRPr>
+                </a:pPr>
+              </a:p>
+            </c:txPr>
+            <c:showLegendKey val="0"/>
+            <c:showVal val="1"/>
+            <c:showCatName val="0"/>
+            <c:showSerName val="0"/>
+            <c:showPercent val="0"/>
+            <c:showBubbleSize val="0"/>
+            <c:showLeaderLines val="1"/>
+          </c:dLbls>
+          <c:cat>
+            <c:strRef>
+              <c:f>Sheet1!$A$2:$A$3</c:f>
+              <c:strCache>
+                <c:ptCount val="2"/>
+                <c:pt idx="0">
+                  <c:v>Medium</c:v>
+                </c:pt>
+                <c:pt idx="1">
+                  <c:v>Heavy</c:v>
+                </c:pt>
+              </c:strCache>
+            </c:strRef>
+          </c:cat>
+          <c:val>
+            <c:numRef>
+              <c:f>Sheet1!$E$2:$E$3</c:f>
+              <c:numCache>
+                <c:formatCode>General</c:formatCode>
+                <c:ptCount val="2"/>
+                <c:pt idx="0">
+                  <c:v>0</c:v>
+                </c:pt>
+                <c:pt idx="1">
+                  <c:v>7</c:v>
+                </c:pt>
+              </c:numCache>
+            </c:numRef>
+          </c:val>
+        </c:ser>
+        <c:ser>
+          <c:idx val="4"/>
+          <c:order val="4"/>
+          <c:tx>
+            <c:strRef>
+              <c:f>Sheet1!$F$1</c:f>
+              <c:strCache>
+                <c:ptCount val="1"/>
+                <c:pt idx="0">
+                  <c:v>Others</c:v>
+                </c:pt>
+              </c:strCache>
+            </c:strRef>
+          </c:tx>
+          <c:spPr>
+            <a:solidFill>
+              <a:srgbClr val="D9D9D9"/>
+            </a:solidFill>
+            <a:ln>
+              <a:solidFill>
+                <a:srgbClr val="FFFFFF"/>
+              </a:solidFill>
+            </a:ln>
+          </c:spPr>
+          <c:dLbls>
+            <c:numFmt formatCode="0&quot; units&quot;;;;" sourceLinked="0"/>
+            <c:txPr>
+              <a:bodyPr/>
+              <a:lstStyle/>
+              <a:p>
+                <a:pPr>
+                  <a:defRPr sz="1000" b="1">
+                    <a:solidFill>
+                      <a:srgbClr val="000000"/>
+                    </a:solidFill>
+                    <a:latin typeface="Neue Haas Grotesk Text Pro"/>
+                  </a:defRPr>
+                </a:pPr>
+              </a:p>
+            </c:txPr>
+            <c:showLegendKey val="0"/>
+            <c:showVal val="1"/>
+            <c:showCatName val="0"/>
+            <c:showSerName val="0"/>
+            <c:showPercent val="0"/>
+            <c:showBubbleSize val="0"/>
+            <c:showLeaderLines val="1"/>
+          </c:dLbls>
+          <c:cat>
+            <c:strRef>
+              <c:f>Sheet1!$A$2:$A$3</c:f>
+              <c:strCache>
+                <c:ptCount val="2"/>
+                <c:pt idx="0">
+                  <c:v>Medium</c:v>
+                </c:pt>
+                <c:pt idx="1">
+                  <c:v>Heavy</c:v>
+                </c:pt>
+              </c:strCache>
+            </c:strRef>
+          </c:cat>
+          <c:val>
+            <c:numRef>
+              <c:f>Sheet1!$F$2:$F$3</c:f>
+              <c:numCache>
+                <c:formatCode>General</c:formatCode>
+                <c:ptCount val="2"/>
+                <c:pt idx="0">
+                  <c:v>11</c:v>
+                </c:pt>
+                <c:pt idx="1">
+                  <c:v>6</c:v>
+                </c:pt>
+              </c:numCache>
+            </c:numRef>
+          </c:val>
+        </c:ser>
+        <c:gapWidth val="45"/>
+        <c:overlap val="100"/>
+        <c:serLines>
+          <c:spPr>
+            <a:ln w="6350">
+              <a:solidFill>
+                <a:srgbClr val="7F7F7F"/>
+              </a:solidFill>
+            </a:ln>
+          </c:spPr>
+        </c:serLines>
+        <c:axId val="-2068027336"/>
+        <c:axId val="-2113994440"/>
+      </c:barChart>
+      <c:catAx>
+        <c:axId val="-2068027336"/>
+        <c:scaling>
+          <c:orientation val="maxMin"/>
+        </c:scaling>
+        <c:delete val="0"/>
+        <c:axPos val="l"/>
+        <c:majorTickMark val="none"/>
+        <c:minorTickMark val="none"/>
+        <c:tickLblPos val="nextTo"/>
+        <c:spPr>
+          <a:ln>
+            <a:solidFill>
+              <a:srgbClr val="000000"/>
+            </a:solidFill>
+          </a:ln>
+        </c:spPr>
+        <c:txPr>
+          <a:bodyPr/>
+          <a:lstStyle/>
+          <a:p>
+            <a:pPr>
+              <a:defRPr sz="1200" b="1"/>
+            </a:pPr>
+          </a:p>
+        </c:txPr>
+        <c:crossAx val="-2113994440"/>
+        <c:crosses val="autoZero"/>
+        <c:auto val="1"/>
+        <c:lblAlgn val="ctr"/>
+        <c:lblOffset val="100"/>
+        <c:noMultiLvlLbl val="0"/>
+      </c:catAx>
+      <c:valAx>
+        <c:axId val="-2113994440"/>
+        <c:scaling/>
+        <c:delete/>
+        <c:axPos val="b"/>
+        <c:majorTickMark val="out"/>
+        <c:minorTickMark val="none"/>
+        <c:tickLblPos val="nextTo"/>
+        <c:crossAx val="-2068027336"/>
+        <c:crosses val="autoZero"/>
+      </c:valAx>
+    </c:plotArea>
+    <c:legend>
+      <c:legendPos val="b"/>
+      <c:overlay val="0"/>
+      <c:txPr>
+        <a:bodyPr/>
+        <a:lstStyle/>
+        <a:p>
+          <a:pPr>
+            <a:defRPr sz="1000"/>
+          </a:pPr>
+        </a:p>
+      </c:txPr>
+    </c:legend>
+    <c:dispBlanksAs val="gap"/>
+  </c:chart>
+  <c:txPr>
+    <a:bodyPr/>
+    <a:lstStyle/>
+    <a:p>
+      <a:pPr>
+        <a:defRPr sz="1000">
           <a:latin typeface="Neue Haas Grotesk Text Pro"/>
         </a:defRPr>
       </a:pPr>
@@ -4951,7 +5178,7 @@
                 </a:solidFill>
                 <a:latin typeface="Neue Haas Grotesk Text Pro"/>
               </a:rPr>
-              <a:t>Medium class (25–45 tm), 2025, </a:t>
+              <a:t>Brand share of units, Medium vs Heavy, 2025, </a:t>
             </a:r>
             <a:r>
               <a:rPr sz="1200" b="0">
@@ -4960,7 +5187,7 @@
                 </a:solidFill>
                 <a:latin typeface="Neue Haas Grotesk Text Pro"/>
               </a:rPr>
-              <a:t>share of units by brand</a:t>
+              <a:t>% of class units</a:t>
             </a:r>
           </a:p>
         </p:txBody>
@@ -4989,571 +5216,45 @@
           <a:p>
             <a:pPr algn="l"/>
             <a:r>
-              <a:rPr sz="1100" b="1">
+              <a:rPr sz="1000" b="1">
                 <a:solidFill>
                   <a:srgbClr val="6B6B6B"/>
                 </a:solidFill>
                 <a:latin typeface="Neue Haas Grotesk Text Pro"/>
               </a:rPr>
-              <a:t>60 units  ·  Rp 28,2 Bio  ·  25% of market value</a:t>
-            </a:r>
-          </a:p>
-        </p:txBody>
-      </p:sp>
-      <p:sp>
-        <p:nvSpPr>
-          <p:cNvPr id="33" name="Rectangle 32"/>
+              <a:t>Medium = 60 units (Rp 28,2 Bio)  ·  Heavy = 39 units (Rp 47,2 Bio)</a:t>
+            </a:r>
+          </a:p>
+        </p:txBody>
+      </p:sp>
+      <p:graphicFrame>
+        <p:nvGraphicFramePr>
+          <p:cNvPr id="33" name="Chart 32"/>
+          <p:cNvGraphicFramePr>
+            <a:graphicFrameLocks noGrp="1"/>
+          </p:cNvGraphicFramePr>
+          <p:nvPr/>
+        </p:nvGraphicFramePr>
+        <p:xfrm>
+          <a:off x="4381500" y="2781300"/>
+          <a:ext cx="5048250" cy="3143250"/>
+        </p:xfrm>
+        <a:graphic>
+          <a:graphicData uri="http://schemas.openxmlformats.org/drawingml/2006/chart">
+            <c:chart xmlns:c="http://schemas.openxmlformats.org/drawingml/2006/chart" r:id="rId3"/>
+          </a:graphicData>
+        </a:graphic>
+      </p:graphicFrame>
+      <p:sp>
+        <p:nvSpPr>
+          <p:cNvPr id="34" name="Rectangle 33"/>
           <p:cNvSpPr/>
           <p:nvPr/>
         </p:nvSpPr>
         <p:spPr>
           <a:xfrm>
-            <a:off x="4438650" y="2819400"/>
-            <a:ext cx="2381250" cy="438150"/>
-          </a:xfrm>
-          <a:prstGeom prst="rect">
-            <a:avLst/>
-          </a:prstGeom>
-          <a:solidFill>
-            <a:srgbClr val="0B4D2A"/>
-          </a:solidFill>
-          <a:ln w="19050">
-            <a:solidFill>
-              <a:srgbClr val="FFFFFF"/>
-            </a:solidFill>
-          </a:ln>
-        </p:spPr>
-        <p:style>
-          <a:lnRef idx="1">
-            <a:schemeClr val="accent1"/>
-          </a:lnRef>
-          <a:fillRef idx="3">
-            <a:schemeClr val="accent1"/>
-          </a:fillRef>
-          <a:effectRef idx="2">
-            <a:schemeClr val="accent1"/>
-          </a:effectRef>
-          <a:fontRef idx="minor">
-            <a:schemeClr val="lt1"/>
-          </a:fontRef>
-        </p:style>
-        <p:txBody>
-          <a:bodyPr rtlCol="0" anchor="ctr" lIns="0" rIns="0"/>
-          <a:lstStyle/>
-          <a:p>
-            <a:pPr algn="ctr"/>
-            <a:r>
-              <a:rPr sz="1300" b="1">
-                <a:solidFill>
-                  <a:srgbClr val="FFFFFF"/>
-                </a:solidFill>
-                <a:latin typeface="Neue Haas Grotesk Text Pro"/>
-              </a:rPr>
-              <a:t>50%</a:t>
-            </a:r>
-          </a:p>
-        </p:txBody>
-      </p:sp>
-      <p:cxnSp>
-        <p:nvCxnSpPr>
-          <p:cNvPr id="34" name="Connector 33"/>
-          <p:cNvCxnSpPr/>
-          <p:nvPr/>
-        </p:nvCxnSpPr>
-        <p:spPr>
-          <a:xfrm>
-            <a:off x="5629275" y="3257550"/>
-            <a:ext cx="0" cy="133350"/>
-          </a:xfrm>
-          <a:prstGeom prst="line">
-            <a:avLst/>
-          </a:prstGeom>
-          <a:ln w="9525">
-            <a:solidFill>
-              <a:srgbClr val="7F7F7F"/>
-            </a:solidFill>
-          </a:ln>
-        </p:spPr>
-        <p:style>
-          <a:lnRef idx="2">
-            <a:schemeClr val="accent1"/>
-          </a:lnRef>
-          <a:fillRef idx="0">
-            <a:schemeClr val="accent1"/>
-          </a:fillRef>
-          <a:effectRef idx="1">
-            <a:schemeClr val="accent1"/>
-          </a:effectRef>
-          <a:fontRef idx="minor">
-            <a:schemeClr val="tx1"/>
-          </a:fontRef>
-        </p:style>
-      </p:cxnSp>
-      <p:sp>
-        <p:nvSpPr>
-          <p:cNvPr id="35" name="TextBox 34"/>
-          <p:cNvSpPr txBox="1"/>
-          <p:nvPr/>
-        </p:nvSpPr>
-        <p:spPr>
-          <a:xfrm>
-            <a:off x="5191125" y="3409950"/>
-            <a:ext cx="876300" cy="323850"/>
-          </a:xfrm>
-          <a:prstGeom prst="rect">
-            <a:avLst/>
-          </a:prstGeom>
-          <a:noFill/>
-        </p:spPr>
-        <p:txBody>
-          <a:bodyPr wrap="square" anchor="t" lIns="0" rIns="0" tIns="0" bIns="0">
-            <a:spAutoFit/>
-          </a:bodyPr>
-          <a:lstStyle/>
-          <a:p>
-            <a:pPr algn="ctr"/>
-            <a:r>
-              <a:rPr sz="1000" b="1">
-                <a:solidFill>
-                  <a:srgbClr val="000000"/>
-                </a:solidFill>
-                <a:latin typeface="Neue Haas Grotesk Text Pro"/>
-              </a:rPr>
-              <a:t>Sany Palfinger</a:t>
-            </a:r>
-          </a:p>
-          <a:p>
-            <a:pPr algn="ctr"/>
-            <a:r>
-              <a:rPr sz="1000" b="0">
-                <a:solidFill>
-                  <a:srgbClr val="6B6B6B"/>
-                </a:solidFill>
-                <a:latin typeface="Neue Haas Grotesk Text Pro"/>
-              </a:rPr>
-              <a:t>30 units</a:t>
-            </a:r>
-          </a:p>
-        </p:txBody>
-      </p:sp>
-      <p:sp>
-        <p:nvSpPr>
-          <p:cNvPr id="36" name="Rectangle 35"/>
-          <p:cNvSpPr/>
-          <p:nvPr/>
-        </p:nvSpPr>
-        <p:spPr>
-          <a:xfrm>
-            <a:off x="6819900" y="2819400"/>
-            <a:ext cx="1111250" cy="438150"/>
-          </a:xfrm>
-          <a:prstGeom prst="rect">
-            <a:avLst/>
-          </a:prstGeom>
-          <a:solidFill>
-            <a:srgbClr val="6FCF97"/>
-          </a:solidFill>
-          <a:ln w="19050">
-            <a:solidFill>
-              <a:srgbClr val="FFFFFF"/>
-            </a:solidFill>
-          </a:ln>
-        </p:spPr>
-        <p:style>
-          <a:lnRef idx="1">
-            <a:schemeClr val="accent1"/>
-          </a:lnRef>
-          <a:fillRef idx="3">
-            <a:schemeClr val="accent1"/>
-          </a:fillRef>
-          <a:effectRef idx="2">
-            <a:schemeClr val="accent1"/>
-          </a:effectRef>
-          <a:fontRef idx="minor">
-            <a:schemeClr val="lt1"/>
-          </a:fontRef>
-        </p:style>
-        <p:txBody>
-          <a:bodyPr rtlCol="0" anchor="ctr" lIns="0" rIns="0"/>
-          <a:lstStyle/>
-          <a:p>
-            <a:pPr algn="ctr"/>
-            <a:r>
-              <a:rPr sz="1300" b="1">
-                <a:solidFill>
-                  <a:srgbClr val="000000"/>
-                </a:solidFill>
-                <a:latin typeface="Neue Haas Grotesk Text Pro"/>
-              </a:rPr>
-              <a:t>23%</a:t>
-            </a:r>
-          </a:p>
-        </p:txBody>
-      </p:sp>
-      <p:cxnSp>
-        <p:nvCxnSpPr>
-          <p:cNvPr id="37" name="Connector 36"/>
-          <p:cNvCxnSpPr/>
-          <p:nvPr/>
-        </p:nvCxnSpPr>
-        <p:spPr>
-          <a:xfrm>
-            <a:off x="7375525" y="3257550"/>
-            <a:ext cx="0" cy="133350"/>
-          </a:xfrm>
-          <a:prstGeom prst="line">
-            <a:avLst/>
-          </a:prstGeom>
-          <a:ln w="9525">
-            <a:solidFill>
-              <a:srgbClr val="7F7F7F"/>
-            </a:solidFill>
-          </a:ln>
-        </p:spPr>
-        <p:style>
-          <a:lnRef idx="2">
-            <a:schemeClr val="accent1"/>
-          </a:lnRef>
-          <a:fillRef idx="0">
-            <a:schemeClr val="accent1"/>
-          </a:fillRef>
-          <a:effectRef idx="1">
-            <a:schemeClr val="accent1"/>
-          </a:effectRef>
-          <a:fontRef idx="minor">
-            <a:schemeClr val="tx1"/>
-          </a:fontRef>
-        </p:style>
-      </p:cxnSp>
-      <p:sp>
-        <p:nvSpPr>
-          <p:cNvPr id="38" name="TextBox 37"/>
-          <p:cNvSpPr txBox="1"/>
-          <p:nvPr/>
-        </p:nvSpPr>
-        <p:spPr>
-          <a:xfrm>
-            <a:off x="6937375" y="3409950"/>
-            <a:ext cx="876300" cy="323850"/>
-          </a:xfrm>
-          <a:prstGeom prst="rect">
-            <a:avLst/>
-          </a:prstGeom>
-          <a:noFill/>
-        </p:spPr>
-        <p:txBody>
-          <a:bodyPr wrap="square" anchor="t" lIns="0" rIns="0" tIns="0" bIns="0">
-            <a:spAutoFit/>
-          </a:bodyPr>
-          <a:lstStyle/>
-          <a:p>
-            <a:pPr algn="ctr"/>
-            <a:r>
-              <a:rPr sz="1000" b="0">
-                <a:solidFill>
-                  <a:srgbClr val="000000"/>
-                </a:solidFill>
-                <a:latin typeface="Neue Haas Grotesk Text Pro"/>
-              </a:rPr>
-              <a:t>XCMG</a:t>
-            </a:r>
-          </a:p>
-          <a:p>
-            <a:pPr algn="ctr"/>
-            <a:r>
-              <a:rPr sz="1000" b="0">
-                <a:solidFill>
-                  <a:srgbClr val="6B6B6B"/>
-                </a:solidFill>
-                <a:latin typeface="Neue Haas Grotesk Text Pro"/>
-              </a:rPr>
-              <a:t>14 units</a:t>
-            </a:r>
-          </a:p>
-        </p:txBody>
-      </p:sp>
-      <p:sp>
-        <p:nvSpPr>
-          <p:cNvPr id="39" name="Rectangle 38"/>
-          <p:cNvSpPr/>
-          <p:nvPr/>
-        </p:nvSpPr>
-        <p:spPr>
-          <a:xfrm>
-            <a:off x="7931150" y="2819400"/>
-            <a:ext cx="396875" cy="438150"/>
-          </a:xfrm>
-          <a:prstGeom prst="rect">
-            <a:avLst/>
-          </a:prstGeom>
-          <a:solidFill>
-            <a:srgbClr val="1E9E57"/>
-          </a:solidFill>
-          <a:ln w="19050">
-            <a:solidFill>
-              <a:srgbClr val="FFFFFF"/>
-            </a:solidFill>
-          </a:ln>
-        </p:spPr>
-        <p:style>
-          <a:lnRef idx="1">
-            <a:schemeClr val="accent1"/>
-          </a:lnRef>
-          <a:fillRef idx="3">
-            <a:schemeClr val="accent1"/>
-          </a:fillRef>
-          <a:effectRef idx="2">
-            <a:schemeClr val="accent1"/>
-          </a:effectRef>
-          <a:fontRef idx="minor">
-            <a:schemeClr val="lt1"/>
-          </a:fontRef>
-        </p:style>
-        <p:txBody>
-          <a:bodyPr rtlCol="0" anchor="ctr" lIns="0" rIns="0"/>
-          <a:lstStyle/>
-          <a:p>
-            <a:pPr algn="ctr"/>
-            <a:r>
-              <a:rPr sz="1300" b="1">
-                <a:solidFill>
-                  <a:srgbClr val="FFFFFF"/>
-                </a:solidFill>
-                <a:latin typeface="Neue Haas Grotesk Text Pro"/>
-              </a:rPr>
-              <a:t>8%</a:t>
-            </a:r>
-          </a:p>
-        </p:txBody>
-      </p:sp>
-      <p:cxnSp>
-        <p:nvCxnSpPr>
-          <p:cNvPr id="40" name="Connector 39"/>
-          <p:cNvCxnSpPr/>
-          <p:nvPr/>
-        </p:nvCxnSpPr>
-        <p:spPr>
-          <a:xfrm>
-            <a:off x="8129588" y="3257550"/>
-            <a:ext cx="0" cy="133350"/>
-          </a:xfrm>
-          <a:prstGeom prst="line">
-            <a:avLst/>
-          </a:prstGeom>
-          <a:ln w="9525">
-            <a:solidFill>
-              <a:srgbClr val="7F7F7F"/>
-            </a:solidFill>
-          </a:ln>
-        </p:spPr>
-        <p:style>
-          <a:lnRef idx="2">
-            <a:schemeClr val="accent1"/>
-          </a:lnRef>
-          <a:fillRef idx="0">
-            <a:schemeClr val="accent1"/>
-          </a:fillRef>
-          <a:effectRef idx="1">
-            <a:schemeClr val="accent1"/>
-          </a:effectRef>
-          <a:fontRef idx="minor">
-            <a:schemeClr val="tx1"/>
-          </a:fontRef>
-        </p:style>
-      </p:cxnSp>
-      <p:sp>
-        <p:nvSpPr>
-          <p:cNvPr id="41" name="TextBox 40"/>
-          <p:cNvSpPr txBox="1"/>
-          <p:nvPr/>
-        </p:nvSpPr>
-        <p:spPr>
-          <a:xfrm>
-            <a:off x="7691438" y="3409950"/>
-            <a:ext cx="876300" cy="323850"/>
-          </a:xfrm>
-          <a:prstGeom prst="rect">
-            <a:avLst/>
-          </a:prstGeom>
-          <a:noFill/>
-        </p:spPr>
-        <p:txBody>
-          <a:bodyPr wrap="square" anchor="t" lIns="0" rIns="0" tIns="0" bIns="0">
-            <a:spAutoFit/>
-          </a:bodyPr>
-          <a:lstStyle/>
-          <a:p>
-            <a:pPr algn="ctr"/>
-            <a:r>
-              <a:rPr sz="1000" b="0">
-                <a:solidFill>
-                  <a:srgbClr val="000000"/>
-                </a:solidFill>
-                <a:latin typeface="Neue Haas Grotesk Text Pro"/>
-              </a:rPr>
-              <a:t>Palfinger</a:t>
-            </a:r>
-          </a:p>
-          <a:p>
-            <a:pPr algn="ctr"/>
-            <a:r>
-              <a:rPr sz="1000" b="0">
-                <a:solidFill>
-                  <a:srgbClr val="6B6B6B"/>
-                </a:solidFill>
-                <a:latin typeface="Neue Haas Grotesk Text Pro"/>
-              </a:rPr>
-              <a:t>5 units</a:t>
-            </a:r>
-          </a:p>
-        </p:txBody>
-      </p:sp>
-      <p:sp>
-        <p:nvSpPr>
-          <p:cNvPr id="42" name="Rectangle 41"/>
-          <p:cNvSpPr/>
-          <p:nvPr/>
-        </p:nvSpPr>
-        <p:spPr>
-          <a:xfrm>
-            <a:off x="8328025" y="2819400"/>
-            <a:ext cx="873125" cy="438150"/>
-          </a:xfrm>
-          <a:prstGeom prst="rect">
-            <a:avLst/>
-          </a:prstGeom>
-          <a:solidFill>
-            <a:srgbClr val="D9D9D9"/>
-          </a:solidFill>
-          <a:ln w="19050">
-            <a:solidFill>
-              <a:srgbClr val="FFFFFF"/>
-            </a:solidFill>
-          </a:ln>
-        </p:spPr>
-        <p:style>
-          <a:lnRef idx="1">
-            <a:schemeClr val="accent1"/>
-          </a:lnRef>
-          <a:fillRef idx="3">
-            <a:schemeClr val="accent1"/>
-          </a:fillRef>
-          <a:effectRef idx="2">
-            <a:schemeClr val="accent1"/>
-          </a:effectRef>
-          <a:fontRef idx="minor">
-            <a:schemeClr val="lt1"/>
-          </a:fontRef>
-        </p:style>
-        <p:txBody>
-          <a:bodyPr rtlCol="0" anchor="ctr" lIns="0" rIns="0"/>
-          <a:lstStyle/>
-          <a:p>
-            <a:pPr algn="ctr"/>
-            <a:r>
-              <a:rPr sz="1300" b="1">
-                <a:solidFill>
-                  <a:srgbClr val="000000"/>
-                </a:solidFill>
-                <a:latin typeface="Neue Haas Grotesk Text Pro"/>
-              </a:rPr>
-              <a:t>18%</a:t>
-            </a:r>
-          </a:p>
-        </p:txBody>
-      </p:sp>
-      <p:cxnSp>
-        <p:nvCxnSpPr>
-          <p:cNvPr id="43" name="Connector 42"/>
-          <p:cNvCxnSpPr/>
-          <p:nvPr/>
-        </p:nvCxnSpPr>
-        <p:spPr>
-          <a:xfrm>
-            <a:off x="8764588" y="3257550"/>
-            <a:ext cx="0" cy="133350"/>
-          </a:xfrm>
-          <a:prstGeom prst="line">
-            <a:avLst/>
-          </a:prstGeom>
-          <a:ln w="9525">
-            <a:solidFill>
-              <a:srgbClr val="7F7F7F"/>
-            </a:solidFill>
-          </a:ln>
-        </p:spPr>
-        <p:style>
-          <a:lnRef idx="2">
-            <a:schemeClr val="accent1"/>
-          </a:lnRef>
-          <a:fillRef idx="0">
-            <a:schemeClr val="accent1"/>
-          </a:fillRef>
-          <a:effectRef idx="1">
-            <a:schemeClr val="accent1"/>
-          </a:effectRef>
-          <a:fontRef idx="minor">
-            <a:schemeClr val="tx1"/>
-          </a:fontRef>
-        </p:style>
-      </p:cxnSp>
-      <p:sp>
-        <p:nvSpPr>
-          <p:cNvPr id="44" name="TextBox 43"/>
-          <p:cNvSpPr txBox="1"/>
-          <p:nvPr/>
-        </p:nvSpPr>
-        <p:spPr>
-          <a:xfrm>
-            <a:off x="8326438" y="3409950"/>
-            <a:ext cx="876300" cy="323850"/>
-          </a:xfrm>
-          <a:prstGeom prst="rect">
-            <a:avLst/>
-          </a:prstGeom>
-          <a:noFill/>
-        </p:spPr>
-        <p:txBody>
-          <a:bodyPr wrap="square" anchor="t" lIns="0" rIns="0" tIns="0" bIns="0">
-            <a:spAutoFit/>
-          </a:bodyPr>
-          <a:lstStyle/>
-          <a:p>
-            <a:pPr algn="ctr"/>
-            <a:r>
-              <a:rPr sz="1000" b="0">
-                <a:solidFill>
-                  <a:srgbClr val="000000"/>
-                </a:solidFill>
-                <a:latin typeface="Neue Haas Grotesk Text Pro"/>
-              </a:rPr>
-              <a:t>Others</a:t>
-            </a:r>
-          </a:p>
-          <a:p>
-            <a:pPr algn="ctr"/>
-            <a:r>
-              <a:rPr sz="1000" b="0">
-                <a:solidFill>
-                  <a:srgbClr val="6B6B6B"/>
-                </a:solidFill>
-                <a:latin typeface="Neue Haas Grotesk Text Pro"/>
-              </a:rPr>
-              <a:t>11 units</a:t>
-            </a:r>
-          </a:p>
-        </p:txBody>
-      </p:sp>
-      <p:sp>
-        <p:nvSpPr>
-          <p:cNvPr id="45" name="Rectangle 44"/>
-          <p:cNvSpPr/>
-          <p:nvPr/>
-        </p:nvSpPr>
-        <p:spPr>
-          <a:xfrm>
-            <a:off x="9448800" y="2381250"/>
-            <a:ext cx="2266950" cy="1676400"/>
+            <a:off x="9525000" y="2857500"/>
+            <a:ext cx="2190750" cy="1352550"/>
           </a:xfrm>
           <a:prstGeom prst="rect">
             <a:avLst/>
@@ -5591,14 +5292,14 @@
       </p:sp>
       <p:sp>
         <p:nvSpPr>
-          <p:cNvPr id="46" name="TextBox 45"/>
+          <p:cNvPr id="35" name="TextBox 34"/>
           <p:cNvSpPr txBox="1"/>
           <p:nvPr/>
         </p:nvSpPr>
         <p:spPr>
           <a:xfrm>
-            <a:off x="9563100" y="2476500"/>
-            <a:ext cx="2038350" cy="1485900"/>
+            <a:off x="9620250" y="2914650"/>
+            <a:ext cx="2000250" cy="1257300"/>
           </a:xfrm>
           <a:prstGeom prst="rect">
             <a:avLst/>
@@ -5613,7 +5314,19 @@
           <a:p>
             <a:pPr algn="l"/>
             <a:r>
-              <a:rPr sz="1100" b="1">
+              <a:rPr sz="950" b="1">
+                <a:solidFill>
+                  <a:srgbClr val="000000"/>
+                </a:solidFill>
+                <a:latin typeface="Neue Haas Grotesk Text Pro"/>
+              </a:rPr>
+              <a:t>Medium</a:t>
+            </a:r>
+          </a:p>
+          <a:p>
+            <a:pPr algn="l"/>
+            <a:r>
+              <a:rPr sz="950" b="1">
                 <a:solidFill>
                   <a:srgbClr val="1E9E57"/>
                 </a:solidFill>
@@ -5622,31 +5335,19 @@
               <a:t>Sany Palfinger</a:t>
             </a:r>
             <a:r>
-              <a:rPr sz="1100" b="0">
+              <a:rPr sz="950" b="0">
                 <a:solidFill>
                   <a:srgbClr val="000000"/>
                 </a:solidFill>
                 <a:latin typeface="Neue Haas Grotesk Text Pro"/>
               </a:rPr>
-              <a:t> leads with half of the class (30 units).</a:t>
+              <a:t> leads with 30 of 60 units (50%).</a:t>
             </a:r>
           </a:p>
           <a:p>
             <a:pPr algn="l"/>
             <a:r>
-              <a:rPr sz="1100" b="0">
-                <a:solidFill>
-                  <a:srgbClr val="000000"/>
-                </a:solidFill>
-                <a:latin typeface="Neue Haas Grotesk Text Pro"/>
-              </a:rPr>
-              <a:t/>
-            </a:r>
-          </a:p>
-          <a:p>
-            <a:pPr algn="l"/>
-            <a:r>
-              <a:rPr sz="1100" b="1">
+              <a:rPr sz="950" b="1">
                 <a:solidFill>
                   <a:srgbClr val="000000"/>
                 </a:solidFill>
@@ -5655,31 +5356,19 @@
               <a:t>XCMG</a:t>
             </a:r>
             <a:r>
-              <a:rPr sz="1100" b="0">
+              <a:rPr sz="950" b="0">
                 <a:solidFill>
                   <a:srgbClr val="000000"/>
                 </a:solidFill>
                 <a:latin typeface="Neue Haas Grotesk Text Pro"/>
               </a:rPr>
-              <a:t> is a distant #2 at 23%; Palfinger sells only 5 units here.</a:t>
+              <a:t> is #2 with 14 units; Palfinger sells 5.</a:t>
             </a:r>
           </a:p>
           <a:p>
             <a:pPr algn="l"/>
             <a:r>
-              <a:rPr sz="1100" b="0">
-                <a:solidFill>
-                  <a:srgbClr val="000000"/>
-                </a:solidFill>
-                <a:latin typeface="Neue Haas Grotesk Text Pro"/>
-              </a:rPr>
-              <a:t/>
-            </a:r>
-          </a:p>
-          <a:p>
-            <a:pPr algn="l"/>
-            <a:r>
-              <a:rPr sz="1100" b="1">
+              <a:rPr sz="950" b="1">
                 <a:solidFill>
                   <a:srgbClr val="000000"/>
                 </a:solidFill>
@@ -5688,685 +5377,27 @@
               <a:t>So what: </a:t>
             </a:r>
             <a:r>
-              <a:rPr sz="1100" b="0">
+              <a:rPr sz="950" b="0">
                 <a:solidFill>
                   <a:srgbClr val="000000"/>
                 </a:solidFill>
                 <a:latin typeface="Neue Haas Grotesk Text Pro"/>
               </a:rPr>
-              <a:t>Medium is a one-leader market; to grow, we take units from Sany Palfinger.</a:t>
-            </a:r>
-          </a:p>
-        </p:txBody>
-      </p:sp>
-      <p:cxnSp>
-        <p:nvCxnSpPr>
-          <p:cNvPr id="47" name="Connector 46"/>
-          <p:cNvCxnSpPr/>
+              <a:t>one-leader market; growth means taking units from Sany Palfinger.</a:t>
+            </a:r>
+          </a:p>
+        </p:txBody>
+      </p:sp>
+      <p:sp>
+        <p:nvSpPr>
+          <p:cNvPr id="36" name="Rectangle 35"/>
+          <p:cNvSpPr/>
           <p:nvPr/>
-        </p:nvCxnSpPr>
+        </p:nvSpPr>
         <p:spPr>
           <a:xfrm>
-            <a:off x="4438650" y="4229100"/>
-            <a:ext cx="7277100" cy="0"/>
-          </a:xfrm>
-          <a:prstGeom prst="line">
-            <a:avLst/>
-          </a:prstGeom>
-          <a:ln w="9525">
-            <a:solidFill>
-              <a:srgbClr val="BFBFBF"/>
-            </a:solidFill>
-          </a:ln>
-        </p:spPr>
-        <p:style>
-          <a:lnRef idx="2">
-            <a:schemeClr val="accent1"/>
-          </a:lnRef>
-          <a:fillRef idx="0">
-            <a:schemeClr val="accent1"/>
-          </a:fillRef>
-          <a:effectRef idx="1">
-            <a:schemeClr val="accent1"/>
-          </a:effectRef>
-          <a:fontRef idx="minor">
-            <a:schemeClr val="tx1"/>
-          </a:fontRef>
-        </p:style>
-      </p:cxnSp>
-      <p:sp>
-        <p:nvSpPr>
-          <p:cNvPr id="48" name="TextBox 47"/>
-          <p:cNvSpPr txBox="1"/>
-          <p:nvPr/>
-        </p:nvSpPr>
-        <p:spPr>
-          <a:xfrm>
-            <a:off x="4438650" y="4324350"/>
-            <a:ext cx="4953000" cy="190500"/>
-          </a:xfrm>
-          <a:prstGeom prst="rect">
-            <a:avLst/>
-          </a:prstGeom>
-          <a:noFill/>
-        </p:spPr>
-        <p:txBody>
-          <a:bodyPr wrap="square" anchor="t" lIns="0" rIns="0" tIns="0" bIns="0">
-            <a:spAutoFit/>
-          </a:bodyPr>
-          <a:lstStyle/>
-          <a:p>
-            <a:pPr algn="l"/>
-            <a:r>
-              <a:rPr sz="1200" b="1">
-                <a:solidFill>
-                  <a:srgbClr val="000000"/>
-                </a:solidFill>
-                <a:latin typeface="Neue Haas Grotesk Text Pro"/>
-              </a:rPr>
-              <a:t>Heavy class (&gt; 45 tm), 2025, </a:t>
-            </a:r>
-            <a:r>
-              <a:rPr sz="1200" b="0">
-                <a:solidFill>
-                  <a:srgbClr val="000000"/>
-                </a:solidFill>
-                <a:latin typeface="Neue Haas Grotesk Text Pro"/>
-              </a:rPr>
-              <a:t>share of units by brand</a:t>
-            </a:r>
-          </a:p>
-        </p:txBody>
-      </p:sp>
-      <p:sp>
-        <p:nvSpPr>
-          <p:cNvPr id="49" name="TextBox 48"/>
-          <p:cNvSpPr txBox="1"/>
-          <p:nvPr/>
-        </p:nvSpPr>
-        <p:spPr>
-          <a:xfrm>
-            <a:off x="4438650" y="4514850"/>
-            <a:ext cx="4953000" cy="171450"/>
-          </a:xfrm>
-          <a:prstGeom prst="rect">
-            <a:avLst/>
-          </a:prstGeom>
-          <a:noFill/>
-        </p:spPr>
-        <p:txBody>
-          <a:bodyPr wrap="square" anchor="t" lIns="0" rIns="0" tIns="0" bIns="0">
-            <a:spAutoFit/>
-          </a:bodyPr>
-          <a:lstStyle/>
-          <a:p>
-            <a:pPr algn="l"/>
-            <a:r>
-              <a:rPr sz="1100" b="1">
-                <a:solidFill>
-                  <a:srgbClr val="6B6B6B"/>
-                </a:solidFill>
-                <a:latin typeface="Neue Haas Grotesk Text Pro"/>
-              </a:rPr>
-              <a:t>39 units  ·  Rp 47,2 Bio  ·  42% of market value</a:t>
-            </a:r>
-          </a:p>
-        </p:txBody>
-      </p:sp>
-      <p:sp>
-        <p:nvSpPr>
-          <p:cNvPr id="50" name="Rectangle 49"/>
-          <p:cNvSpPr/>
-          <p:nvPr/>
-        </p:nvSpPr>
-        <p:spPr>
-          <a:xfrm>
-            <a:off x="4438650" y="4762500"/>
-            <a:ext cx="2686538" cy="438150"/>
-          </a:xfrm>
-          <a:prstGeom prst="rect">
-            <a:avLst/>
-          </a:prstGeom>
-          <a:solidFill>
-            <a:srgbClr val="1E9E57"/>
-          </a:solidFill>
-          <a:ln w="19050">
-            <a:solidFill>
-              <a:srgbClr val="FFFFFF"/>
-            </a:solidFill>
-          </a:ln>
-        </p:spPr>
-        <p:style>
-          <a:lnRef idx="1">
-            <a:schemeClr val="accent1"/>
-          </a:lnRef>
-          <a:fillRef idx="3">
-            <a:schemeClr val="accent1"/>
-          </a:fillRef>
-          <a:effectRef idx="2">
-            <a:schemeClr val="accent1"/>
-          </a:effectRef>
-          <a:fontRef idx="minor">
-            <a:schemeClr val="lt1"/>
-          </a:fontRef>
-        </p:style>
-        <p:txBody>
-          <a:bodyPr rtlCol="0" anchor="ctr" lIns="0" rIns="0"/>
-          <a:lstStyle/>
-          <a:p>
-            <a:pPr algn="ctr"/>
-            <a:r>
-              <a:rPr sz="1300" b="1">
-                <a:solidFill>
-                  <a:srgbClr val="FFFFFF"/>
-                </a:solidFill>
-                <a:latin typeface="Neue Haas Grotesk Text Pro"/>
-              </a:rPr>
-              <a:t>56%</a:t>
-            </a:r>
-          </a:p>
-        </p:txBody>
-      </p:sp>
-      <p:cxnSp>
-        <p:nvCxnSpPr>
-          <p:cNvPr id="51" name="Connector 50"/>
-          <p:cNvCxnSpPr/>
-          <p:nvPr/>
-        </p:nvCxnSpPr>
-        <p:spPr>
-          <a:xfrm>
-            <a:off x="5781919" y="5200650"/>
-            <a:ext cx="0" cy="133350"/>
-          </a:xfrm>
-          <a:prstGeom prst="line">
-            <a:avLst/>
-          </a:prstGeom>
-          <a:ln w="9525">
-            <a:solidFill>
-              <a:srgbClr val="7F7F7F"/>
-            </a:solidFill>
-          </a:ln>
-        </p:spPr>
-        <p:style>
-          <a:lnRef idx="2">
-            <a:schemeClr val="accent1"/>
-          </a:lnRef>
-          <a:fillRef idx="0">
-            <a:schemeClr val="accent1"/>
-          </a:fillRef>
-          <a:effectRef idx="1">
-            <a:schemeClr val="accent1"/>
-          </a:effectRef>
-          <a:fontRef idx="minor">
-            <a:schemeClr val="tx1"/>
-          </a:fontRef>
-        </p:style>
-      </p:cxnSp>
-      <p:sp>
-        <p:nvSpPr>
-          <p:cNvPr id="52" name="TextBox 51"/>
-          <p:cNvSpPr txBox="1"/>
-          <p:nvPr/>
-        </p:nvSpPr>
-        <p:spPr>
-          <a:xfrm>
-            <a:off x="5343769" y="5353050"/>
-            <a:ext cx="876300" cy="323850"/>
-          </a:xfrm>
-          <a:prstGeom prst="rect">
-            <a:avLst/>
-          </a:prstGeom>
-          <a:noFill/>
-        </p:spPr>
-        <p:txBody>
-          <a:bodyPr wrap="square" anchor="t" lIns="0" rIns="0" tIns="0" bIns="0">
-            <a:spAutoFit/>
-          </a:bodyPr>
-          <a:lstStyle/>
-          <a:p>
-            <a:pPr algn="ctr"/>
-            <a:r>
-              <a:rPr sz="1000" b="1">
-                <a:solidFill>
-                  <a:srgbClr val="000000"/>
-                </a:solidFill>
-                <a:latin typeface="Neue Haas Grotesk Text Pro"/>
-              </a:rPr>
-              <a:t>Palfinger</a:t>
-            </a:r>
-          </a:p>
-          <a:p>
-            <a:pPr algn="ctr"/>
-            <a:r>
-              <a:rPr sz="1000" b="0">
-                <a:solidFill>
-                  <a:srgbClr val="6B6B6B"/>
-                </a:solidFill>
-                <a:latin typeface="Neue Haas Grotesk Text Pro"/>
-              </a:rPr>
-              <a:t>22 units</a:t>
-            </a:r>
-          </a:p>
-        </p:txBody>
-      </p:sp>
-      <p:sp>
-        <p:nvSpPr>
-          <p:cNvPr id="53" name="Rectangle 52"/>
-          <p:cNvSpPr/>
-          <p:nvPr/>
-        </p:nvSpPr>
-        <p:spPr>
-          <a:xfrm>
-            <a:off x="7125188" y="4762500"/>
-            <a:ext cx="854808" cy="438150"/>
-          </a:xfrm>
-          <a:prstGeom prst="rect">
-            <a:avLst/>
-          </a:prstGeom>
-          <a:solidFill>
-            <a:srgbClr val="9ADBB5"/>
-          </a:solidFill>
-          <a:ln w="19050">
-            <a:solidFill>
-              <a:srgbClr val="FFFFFF"/>
-            </a:solidFill>
-          </a:ln>
-        </p:spPr>
-        <p:style>
-          <a:lnRef idx="1">
-            <a:schemeClr val="accent1"/>
-          </a:lnRef>
-          <a:fillRef idx="3">
-            <a:schemeClr val="accent1"/>
-          </a:fillRef>
-          <a:effectRef idx="2">
-            <a:schemeClr val="accent1"/>
-          </a:effectRef>
-          <a:fontRef idx="minor">
-            <a:schemeClr val="lt1"/>
-          </a:fontRef>
-        </p:style>
-        <p:txBody>
-          <a:bodyPr rtlCol="0" anchor="ctr" lIns="0" rIns="0"/>
-          <a:lstStyle/>
-          <a:p>
-            <a:pPr algn="ctr"/>
-            <a:r>
-              <a:rPr sz="1300" b="1">
-                <a:solidFill>
-                  <a:srgbClr val="000000"/>
-                </a:solidFill>
-                <a:latin typeface="Neue Haas Grotesk Text Pro"/>
-              </a:rPr>
-              <a:t>18%</a:t>
-            </a:r>
-          </a:p>
-        </p:txBody>
-      </p:sp>
-      <p:cxnSp>
-        <p:nvCxnSpPr>
-          <p:cNvPr id="54" name="Connector 53"/>
-          <p:cNvCxnSpPr/>
-          <p:nvPr/>
-        </p:nvCxnSpPr>
-        <p:spPr>
-          <a:xfrm>
-            <a:off x="7552592" y="5200650"/>
-            <a:ext cx="0" cy="133350"/>
-          </a:xfrm>
-          <a:prstGeom prst="line">
-            <a:avLst/>
-          </a:prstGeom>
-          <a:ln w="9525">
-            <a:solidFill>
-              <a:srgbClr val="7F7F7F"/>
-            </a:solidFill>
-          </a:ln>
-        </p:spPr>
-        <p:style>
-          <a:lnRef idx="2">
-            <a:schemeClr val="accent1"/>
-          </a:lnRef>
-          <a:fillRef idx="0">
-            <a:schemeClr val="accent1"/>
-          </a:fillRef>
-          <a:effectRef idx="1">
-            <a:schemeClr val="accent1"/>
-          </a:effectRef>
-          <a:fontRef idx="minor">
-            <a:schemeClr val="tx1"/>
-          </a:fontRef>
-        </p:style>
-      </p:cxnSp>
-      <p:sp>
-        <p:nvSpPr>
-          <p:cNvPr id="55" name="TextBox 54"/>
-          <p:cNvSpPr txBox="1"/>
-          <p:nvPr/>
-        </p:nvSpPr>
-        <p:spPr>
-          <a:xfrm>
-            <a:off x="7114442" y="5353050"/>
-            <a:ext cx="876300" cy="323850"/>
-          </a:xfrm>
-          <a:prstGeom prst="rect">
-            <a:avLst/>
-          </a:prstGeom>
-          <a:noFill/>
-        </p:spPr>
-        <p:txBody>
-          <a:bodyPr wrap="square" anchor="t" lIns="0" rIns="0" tIns="0" bIns="0">
-            <a:spAutoFit/>
-          </a:bodyPr>
-          <a:lstStyle/>
-          <a:p>
-            <a:pPr algn="ctr"/>
-            <a:r>
-              <a:rPr sz="1000" b="0">
-                <a:solidFill>
-                  <a:srgbClr val="000000"/>
-                </a:solidFill>
-                <a:latin typeface="Neue Haas Grotesk Text Pro"/>
-              </a:rPr>
-              <a:t>Amco Veba</a:t>
-            </a:r>
-          </a:p>
-          <a:p>
-            <a:pPr algn="ctr"/>
-            <a:r>
-              <a:rPr sz="1000" b="0">
-                <a:solidFill>
-                  <a:srgbClr val="6B6B6B"/>
-                </a:solidFill>
-                <a:latin typeface="Neue Haas Grotesk Text Pro"/>
-              </a:rPr>
-              <a:t>7 units</a:t>
-            </a:r>
-          </a:p>
-        </p:txBody>
-      </p:sp>
-      <p:sp>
-        <p:nvSpPr>
-          <p:cNvPr id="56" name="Rectangle 55"/>
-          <p:cNvSpPr/>
-          <p:nvPr/>
-        </p:nvSpPr>
-        <p:spPr>
-          <a:xfrm>
-            <a:off x="7979996" y="4762500"/>
-            <a:ext cx="488462" cy="438150"/>
-          </a:xfrm>
-          <a:prstGeom prst="rect">
-            <a:avLst/>
-          </a:prstGeom>
-          <a:solidFill>
-            <a:srgbClr val="6FCF97"/>
-          </a:solidFill>
-          <a:ln w="19050">
-            <a:solidFill>
-              <a:srgbClr val="FFFFFF"/>
-            </a:solidFill>
-          </a:ln>
-        </p:spPr>
-        <p:style>
-          <a:lnRef idx="1">
-            <a:schemeClr val="accent1"/>
-          </a:lnRef>
-          <a:fillRef idx="3">
-            <a:schemeClr val="accent1"/>
-          </a:fillRef>
-          <a:effectRef idx="2">
-            <a:schemeClr val="accent1"/>
-          </a:effectRef>
-          <a:fontRef idx="minor">
-            <a:schemeClr val="lt1"/>
-          </a:fontRef>
-        </p:style>
-        <p:txBody>
-          <a:bodyPr rtlCol="0" anchor="ctr" lIns="0" rIns="0"/>
-          <a:lstStyle/>
-          <a:p>
-            <a:pPr algn="ctr"/>
-            <a:r>
-              <a:rPr sz="1300" b="1">
-                <a:solidFill>
-                  <a:srgbClr val="000000"/>
-                </a:solidFill>
-                <a:latin typeface="Neue Haas Grotesk Text Pro"/>
-              </a:rPr>
-              <a:t>10%</a:t>
-            </a:r>
-          </a:p>
-        </p:txBody>
-      </p:sp>
-      <p:cxnSp>
-        <p:nvCxnSpPr>
-          <p:cNvPr id="57" name="Connector 56"/>
-          <p:cNvCxnSpPr/>
-          <p:nvPr/>
-        </p:nvCxnSpPr>
-        <p:spPr>
-          <a:xfrm>
-            <a:off x="8224227" y="5200650"/>
-            <a:ext cx="0" cy="133350"/>
-          </a:xfrm>
-          <a:prstGeom prst="line">
-            <a:avLst/>
-          </a:prstGeom>
-          <a:ln w="9525">
-            <a:solidFill>
-              <a:srgbClr val="7F7F7F"/>
-            </a:solidFill>
-          </a:ln>
-        </p:spPr>
-        <p:style>
-          <a:lnRef idx="2">
-            <a:schemeClr val="accent1"/>
-          </a:lnRef>
-          <a:fillRef idx="0">
-            <a:schemeClr val="accent1"/>
-          </a:fillRef>
-          <a:effectRef idx="1">
-            <a:schemeClr val="accent1"/>
-          </a:effectRef>
-          <a:fontRef idx="minor">
-            <a:schemeClr val="tx1"/>
-          </a:fontRef>
-        </p:style>
-      </p:cxnSp>
-      <p:sp>
-        <p:nvSpPr>
-          <p:cNvPr id="58" name="TextBox 57"/>
-          <p:cNvSpPr txBox="1"/>
-          <p:nvPr/>
-        </p:nvSpPr>
-        <p:spPr>
-          <a:xfrm>
-            <a:off x="7786077" y="5353050"/>
-            <a:ext cx="876300" cy="323850"/>
-          </a:xfrm>
-          <a:prstGeom prst="rect">
-            <a:avLst/>
-          </a:prstGeom>
-          <a:noFill/>
-        </p:spPr>
-        <p:txBody>
-          <a:bodyPr wrap="square" anchor="t" lIns="0" rIns="0" tIns="0" bIns="0">
-            <a:spAutoFit/>
-          </a:bodyPr>
-          <a:lstStyle/>
-          <a:p>
-            <a:pPr algn="ctr"/>
-            <a:r>
-              <a:rPr sz="1000" b="0">
-                <a:solidFill>
-                  <a:srgbClr val="000000"/>
-                </a:solidFill>
-                <a:latin typeface="Neue Haas Grotesk Text Pro"/>
-              </a:rPr>
-              <a:t>XCMG</a:t>
-            </a:r>
-          </a:p>
-          <a:p>
-            <a:pPr algn="ctr"/>
-            <a:r>
-              <a:rPr sz="1000" b="0">
-                <a:solidFill>
-                  <a:srgbClr val="6B6B6B"/>
-                </a:solidFill>
-                <a:latin typeface="Neue Haas Grotesk Text Pro"/>
-              </a:rPr>
-              <a:t>4 units</a:t>
-            </a:r>
-          </a:p>
-        </p:txBody>
-      </p:sp>
-      <p:sp>
-        <p:nvSpPr>
-          <p:cNvPr id="59" name="Rectangle 58"/>
-          <p:cNvSpPr/>
-          <p:nvPr/>
-        </p:nvSpPr>
-        <p:spPr>
-          <a:xfrm>
-            <a:off x="8468458" y="4762500"/>
-            <a:ext cx="732692" cy="438150"/>
-          </a:xfrm>
-          <a:prstGeom prst="rect">
-            <a:avLst/>
-          </a:prstGeom>
-          <a:solidFill>
-            <a:srgbClr val="D9D9D9"/>
-          </a:solidFill>
-          <a:ln w="19050">
-            <a:solidFill>
-              <a:srgbClr val="FFFFFF"/>
-            </a:solidFill>
-          </a:ln>
-        </p:spPr>
-        <p:style>
-          <a:lnRef idx="1">
-            <a:schemeClr val="accent1"/>
-          </a:lnRef>
-          <a:fillRef idx="3">
-            <a:schemeClr val="accent1"/>
-          </a:fillRef>
-          <a:effectRef idx="2">
-            <a:schemeClr val="accent1"/>
-          </a:effectRef>
-          <a:fontRef idx="minor">
-            <a:schemeClr val="lt1"/>
-          </a:fontRef>
-        </p:style>
-        <p:txBody>
-          <a:bodyPr rtlCol="0" anchor="ctr" lIns="0" rIns="0"/>
-          <a:lstStyle/>
-          <a:p>
-            <a:pPr algn="ctr"/>
-            <a:r>
-              <a:rPr sz="1300" b="1">
-                <a:solidFill>
-                  <a:srgbClr val="000000"/>
-                </a:solidFill>
-                <a:latin typeface="Neue Haas Grotesk Text Pro"/>
-              </a:rPr>
-              <a:t>15%</a:t>
-            </a:r>
-          </a:p>
-        </p:txBody>
-      </p:sp>
-      <p:cxnSp>
-        <p:nvCxnSpPr>
-          <p:cNvPr id="60" name="Connector 59"/>
-          <p:cNvCxnSpPr/>
-          <p:nvPr/>
-        </p:nvCxnSpPr>
-        <p:spPr>
-          <a:xfrm>
-            <a:off x="8834804" y="5200650"/>
-            <a:ext cx="0" cy="133350"/>
-          </a:xfrm>
-          <a:prstGeom prst="line">
-            <a:avLst/>
-          </a:prstGeom>
-          <a:ln w="9525">
-            <a:solidFill>
-              <a:srgbClr val="7F7F7F"/>
-            </a:solidFill>
-          </a:ln>
-        </p:spPr>
-        <p:style>
-          <a:lnRef idx="2">
-            <a:schemeClr val="accent1"/>
-          </a:lnRef>
-          <a:fillRef idx="0">
-            <a:schemeClr val="accent1"/>
-          </a:fillRef>
-          <a:effectRef idx="1">
-            <a:schemeClr val="accent1"/>
-          </a:effectRef>
-          <a:fontRef idx="minor">
-            <a:schemeClr val="tx1"/>
-          </a:fontRef>
-        </p:style>
-      </p:cxnSp>
-      <p:sp>
-        <p:nvSpPr>
-          <p:cNvPr id="61" name="TextBox 60"/>
-          <p:cNvSpPr txBox="1"/>
-          <p:nvPr/>
-        </p:nvSpPr>
-        <p:spPr>
-          <a:xfrm>
-            <a:off x="8396654" y="5353050"/>
-            <a:ext cx="876300" cy="323850"/>
-          </a:xfrm>
-          <a:prstGeom prst="rect">
-            <a:avLst/>
-          </a:prstGeom>
-          <a:noFill/>
-        </p:spPr>
-        <p:txBody>
-          <a:bodyPr wrap="square" anchor="t" lIns="0" rIns="0" tIns="0" bIns="0">
-            <a:spAutoFit/>
-          </a:bodyPr>
-          <a:lstStyle/>
-          <a:p>
-            <a:pPr algn="ctr"/>
-            <a:r>
-              <a:rPr sz="1000" b="0">
-                <a:solidFill>
-                  <a:srgbClr val="000000"/>
-                </a:solidFill>
-                <a:latin typeface="Neue Haas Grotesk Text Pro"/>
-              </a:rPr>
-              <a:t>Others</a:t>
-            </a:r>
-          </a:p>
-          <a:p>
-            <a:pPr algn="ctr"/>
-            <a:r>
-              <a:rPr sz="1000" b="0">
-                <a:solidFill>
-                  <a:srgbClr val="6B6B6B"/>
-                </a:solidFill>
-                <a:latin typeface="Neue Haas Grotesk Text Pro"/>
-              </a:rPr>
-              <a:t>6 units</a:t>
-            </a:r>
-          </a:p>
-        </p:txBody>
-      </p:sp>
-      <p:sp>
-        <p:nvSpPr>
-          <p:cNvPr id="62" name="Rectangle 61"/>
-          <p:cNvSpPr/>
-          <p:nvPr/>
-        </p:nvSpPr>
-        <p:spPr>
-          <a:xfrm>
-            <a:off x="9448800" y="4324350"/>
-            <a:ext cx="2266950" cy="1676400"/>
+            <a:off x="9525000" y="4267200"/>
+            <a:ext cx="2190750" cy="1352550"/>
           </a:xfrm>
           <a:prstGeom prst="rect">
             <a:avLst/>
@@ -6404,14 +5435,14 @@
       </p:sp>
       <p:sp>
         <p:nvSpPr>
-          <p:cNvPr id="63" name="TextBox 62"/>
+          <p:cNvPr id="37" name="TextBox 36"/>
           <p:cNvSpPr txBox="1"/>
           <p:nvPr/>
         </p:nvSpPr>
         <p:spPr>
           <a:xfrm>
-            <a:off x="9563100" y="4419600"/>
-            <a:ext cx="2038350" cy="1485900"/>
+            <a:off x="9620250" y="4324350"/>
+            <a:ext cx="2000250" cy="1257300"/>
           </a:xfrm>
           <a:prstGeom prst="rect">
             <a:avLst/>
@@ -6426,7 +5457,19 @@
           <a:p>
             <a:pPr algn="l"/>
             <a:r>
-              <a:rPr sz="1100" b="1">
+              <a:rPr sz="950" b="1">
+                <a:solidFill>
+                  <a:srgbClr val="000000"/>
+                </a:solidFill>
+                <a:latin typeface="Neue Haas Grotesk Text Pro"/>
+              </a:rPr>
+              <a:t>Heavy</a:t>
+            </a:r>
+          </a:p>
+          <a:p>
+            <a:pPr algn="l"/>
+            <a:r>
+              <a:rPr sz="950" b="1">
                 <a:solidFill>
                   <a:srgbClr val="1E9E57"/>
                 </a:solidFill>
@@ -6435,31 +5478,19 @@
               <a:t>Palfinger</a:t>
             </a:r>
             <a:r>
-              <a:rPr sz="1100" b="0">
+              <a:rPr sz="950" b="0">
                 <a:solidFill>
                   <a:srgbClr val="000000"/>
                 </a:solidFill>
                 <a:latin typeface="Neue Haas Grotesk Text Pro"/>
               </a:rPr>
-              <a:t> holds 56% of units (22 of 39).</a:t>
+              <a:t> holds 22 of 39 units (56%).</a:t>
             </a:r>
           </a:p>
           <a:p>
             <a:pPr algn="l"/>
             <a:r>
-              <a:rPr sz="1100" b="0">
-                <a:solidFill>
-                  <a:srgbClr val="000000"/>
-                </a:solidFill>
-                <a:latin typeface="Neue Haas Grotesk Text Pro"/>
-              </a:rPr>
-              <a:t/>
-            </a:r>
-          </a:p>
-          <a:p>
-            <a:pPr algn="l"/>
-            <a:r>
-              <a:rPr sz="1100" b="1">
+              <a:rPr sz="950" b="1">
                 <a:solidFill>
                   <a:srgbClr val="000000"/>
                 </a:solidFill>
@@ -6468,7 +5499,7 @@
               <a:t>Amco Veba</a:t>
             </a:r>
             <a:r>
-              <a:rPr sz="1100" b="0">
+              <a:rPr sz="950" b="0">
                 <a:solidFill>
                   <a:srgbClr val="000000"/>
                 </a:solidFill>
@@ -6477,7 +5508,7 @@
               <a:t> (7) and </a:t>
             </a:r>
             <a:r>
-              <a:rPr sz="1100" b="1">
+              <a:rPr sz="950" b="1">
                 <a:solidFill>
                   <a:srgbClr val="000000"/>
                 </a:solidFill>
@@ -6486,31 +5517,19 @@
               <a:t>XCMG</a:t>
             </a:r>
             <a:r>
-              <a:rPr sz="1100" b="0">
+              <a:rPr sz="950" b="0">
                 <a:solidFill>
                   <a:srgbClr val="000000"/>
                 </a:solidFill>
                 <a:latin typeface="Neue Haas Grotesk Text Pro"/>
               </a:rPr>
-              <a:t> (4) follow; top 3 = 85% of units.</a:t>
+              <a:t> (4) follow.</a:t>
             </a:r>
           </a:p>
           <a:p>
             <a:pPr algn="l"/>
             <a:r>
-              <a:rPr sz="1100" b="0">
-                <a:solidFill>
-                  <a:srgbClr val="000000"/>
-                </a:solidFill>
-                <a:latin typeface="Neue Haas Grotesk Text Pro"/>
-              </a:rPr>
-              <a:t/>
-            </a:r>
-          </a:p>
-          <a:p>
-            <a:pPr algn="l"/>
-            <a:r>
-              <a:rPr sz="1100" b="1">
+              <a:rPr sz="950" b="1">
                 <a:solidFill>
                   <a:srgbClr val="000000"/>
                 </a:solidFill>
@@ -6519,20 +5538,20 @@
               <a:t>So what: </a:t>
             </a:r>
             <a:r>
-              <a:rPr sz="1100" b="0">
+              <a:rPr sz="950" b="0">
                 <a:solidFill>
                   <a:srgbClr val="000000"/>
                 </a:solidFill>
                 <a:latin typeface="Neue Haas Grotesk Text Pro"/>
               </a:rPr>
-              <a:t>Heavy is small in units but 42% of market value; each unit is worth about Rp 1,2 Bio.</a:t>
-            </a:r>
-          </a:p>
-        </p:txBody>
-      </p:sp>
-      <p:sp>
-        <p:nvSpPr>
-          <p:cNvPr id="64" name="TextBox 63"/>
+              <a:t>small in units but 42% of market value; about Rp 1,2 Bio per unit.</a:t>
+            </a:r>
+          </a:p>
+        </p:txBody>
+      </p:sp>
+      <p:sp>
+        <p:nvSpPr>
+          <p:cNvPr id="38" name="TextBox 37"/>
           <p:cNvSpPr txBox="1"/>
           <p:nvPr/>
         </p:nvSpPr>
@@ -6576,7 +5595,7 @@
       </p:sp>
       <p:sp>
         <p:nvSpPr>
-          <p:cNvPr id="65" name="TextBox 64"/>
+          <p:cNvPr id="39" name="TextBox 38"/>
           <p:cNvSpPr txBox="1"/>
           <p:nvPr/>
         </p:nvSpPr>
@@ -6613,14 +5632,14 @@
                 </a:solidFill>
                 <a:latin typeface="Neue Haas Grotesk Text Pro"/>
               </a:rPr>
-              <a:t>Brand units for top 3 per class from earlier data cut; Others = 2025 class total minus top 3. Light (&lt; 8 tm) and Small (8–25 tm) excluded from focus.</a:t>
+              <a:t>Chart numbers live in chart data (Edit Data); Others = class total minus named brands (formula); brand units from earlier data cut. Light (&lt; 8 tm) and Small (8–25 tm) excluded from focus.</a:t>
             </a:r>
           </a:p>
         </p:txBody>
       </p:sp>
       <p:cxnSp>
         <p:nvCxnSpPr>
-          <p:cNvPr id="66" name="Connector 65"/>
+          <p:cNvPr id="40" name="Connector 39"/>
           <p:cNvCxnSpPr/>
           <p:nvPr/>
         </p:nvCxnSpPr>

</xml_diff>

<commit_message>
Show brand name and units as live labels on brand chart
Co-Authored-By: Claude Opus 5.5 <noreply@anthropic.com>
Claude-Session: https://claude.ai/code/session_01Cx9kswyecF7JAB1Rr5vVcV
</commit_message>
<xml_diff>
--- a/nedp_deck/Slide_2025_Medium_Heavy_Funnel.pptx
+++ b/nedp_deck/Slide_2025_Medium_Heavy_Funnel.pptx
@@ -554,13 +554,17 @@
             </a:ln>
           </c:spPr>
           <c:dLbls>
+            <c:dLbl>
+              <c:idx val="1"/>
+              <c:delete val="1"/>
+            </c:dLbl>
             <c:numFmt formatCode="0&quot; units&quot;;;;" sourceLinked="0"/>
             <c:txPr>
               <a:bodyPr/>
               <a:lstStyle/>
               <a:p>
                 <a:pPr>
-                  <a:defRPr sz="1000" b="1">
+                  <a:defRPr sz="900" b="1">
                     <a:solidFill>
                       <a:srgbClr val="FFFFFF"/>
                     </a:solidFill>
@@ -572,10 +576,12 @@
             <c:showLegendKey val="0"/>
             <c:showVal val="1"/>
             <c:showCatName val="0"/>
-            <c:showSerName val="0"/>
+            <c:showSerName val="1"/>
             <c:showPercent val="0"/>
             <c:showBubbleSize val="0"/>
             <c:showLeaderLines val="1"/>
+            <c:separator>
+</c:separator>
           </c:dLbls>
           <c:cat>
             <c:strRef>
@@ -638,7 +644,7 @@
               <a:lstStyle/>
               <a:p>
                 <a:pPr>
-                  <a:defRPr sz="1000" b="1">
+                  <a:defRPr sz="900" b="1">
                     <a:solidFill>
                       <a:srgbClr val="FFFFFF"/>
                     </a:solidFill>
@@ -650,10 +656,12 @@
             <c:showLegendKey val="0"/>
             <c:showVal val="1"/>
             <c:showCatName val="0"/>
-            <c:showSerName val="0"/>
+            <c:showSerName val="1"/>
             <c:showPercent val="0"/>
             <c:showBubbleSize val="0"/>
             <c:showLeaderLines val="1"/>
+            <c:separator>
+</c:separator>
           </c:dLbls>
           <c:cat>
             <c:strRef>
@@ -716,7 +724,7 @@
               <a:lstStyle/>
               <a:p>
                 <a:pPr>
-                  <a:defRPr sz="1000" b="1">
+                  <a:defRPr sz="900" b="1">
                     <a:solidFill>
                       <a:srgbClr val="000000"/>
                     </a:solidFill>
@@ -728,10 +736,12 @@
             <c:showLegendKey val="0"/>
             <c:showVal val="1"/>
             <c:showCatName val="0"/>
-            <c:showSerName val="0"/>
+            <c:showSerName val="1"/>
             <c:showPercent val="0"/>
             <c:showBubbleSize val="0"/>
             <c:showLeaderLines val="1"/>
+            <c:separator>
+</c:separator>
           </c:dLbls>
           <c:cat>
             <c:strRef>
@@ -788,13 +798,17 @@
             </a:ln>
           </c:spPr>
           <c:dLbls>
+            <c:dLbl>
+              <c:idx val="0"/>
+              <c:delete val="1"/>
+            </c:dLbl>
             <c:numFmt formatCode="0&quot; units&quot;;;;" sourceLinked="0"/>
             <c:txPr>
               <a:bodyPr/>
               <a:lstStyle/>
               <a:p>
                 <a:pPr>
-                  <a:defRPr sz="1000" b="1">
+                  <a:defRPr sz="900" b="1">
                     <a:solidFill>
                       <a:srgbClr val="000000"/>
                     </a:solidFill>
@@ -806,10 +820,12 @@
             <c:showLegendKey val="0"/>
             <c:showVal val="1"/>
             <c:showCatName val="0"/>
-            <c:showSerName val="0"/>
+            <c:showSerName val="1"/>
             <c:showPercent val="0"/>
             <c:showBubbleSize val="0"/>
             <c:showLeaderLines val="1"/>
+            <c:separator>
+</c:separator>
           </c:dLbls>
           <c:cat>
             <c:strRef>
@@ -872,7 +888,7 @@
               <a:lstStyle/>
               <a:p>
                 <a:pPr>
-                  <a:defRPr sz="1000" b="1">
+                  <a:defRPr sz="900" b="1">
                     <a:solidFill>
                       <a:srgbClr val="000000"/>
                     </a:solidFill>
@@ -884,10 +900,12 @@
             <c:showLegendKey val="0"/>
             <c:showVal val="1"/>
             <c:showCatName val="0"/>
-            <c:showSerName val="0"/>
+            <c:showSerName val="1"/>
             <c:showPercent val="0"/>
             <c:showBubbleSize val="0"/>
             <c:showLeaderLines val="1"/>
+            <c:separator>
+</c:separator>
           </c:dLbls>
           <c:cat>
             <c:strRef>
@@ -978,19 +996,6 @@
         <c:crosses val="autoZero"/>
       </c:valAx>
     </c:plotArea>
-    <c:legend>
-      <c:legendPos val="b"/>
-      <c:overlay val="0"/>
-      <c:txPr>
-        <a:bodyPr/>
-        <a:lstStyle/>
-        <a:p>
-          <a:pPr>
-            <a:defRPr sz="1000"/>
-          </a:pPr>
-        </a:p>
-      </c:txPr>
-    </c:legend>
     <c:dispBlanksAs val="gap"/>
   </c:chart>
   <c:txPr>

</xml_diff>

<commit_message>
Rebuild 2025 slide from Noir database: Pareto brands (80%) with SUMIFS-linked charts
Co-Authored-By: Claude Opus 5.5 <noreply@anthropic.com>
Claude-Session: https://claude.ai/code/session_01Cx9kswyecF7JAB1Rr5vVcV
</commit_message>
<xml_diff>
--- a/nedp_deck/Slide_2025_Medium_Heavy_Funnel.pptx
+++ b/nedp_deck/Slide_2025_Medium_Heavy_Funnel.pptx
@@ -702,7 +702,7 @@
               <c:strCache>
                 <c:ptCount val="1"/>
                 <c:pt idx="0">
-                  <c:v>XCMG</c:v>
+                  <c:v>Amco Veba</c:v>
                 </c:pt>
               </c:strCache>
             </c:strRef>
@@ -710,86 +710,6 @@
           <c:spPr>
             <a:solidFill>
               <a:srgbClr val="6FCF97"/>
-            </a:solidFill>
-            <a:ln>
-              <a:solidFill>
-                <a:srgbClr val="FFFFFF"/>
-              </a:solidFill>
-            </a:ln>
-          </c:spPr>
-          <c:dLbls>
-            <c:numFmt formatCode="0&quot; units&quot;;;;" sourceLinked="0"/>
-            <c:txPr>
-              <a:bodyPr/>
-              <a:lstStyle/>
-              <a:p>
-                <a:pPr>
-                  <a:defRPr sz="900" b="1">
-                    <a:solidFill>
-                      <a:srgbClr val="000000"/>
-                    </a:solidFill>
-                    <a:latin typeface="Neue Haas Grotesk Text Pro"/>
-                  </a:defRPr>
-                </a:pPr>
-              </a:p>
-            </c:txPr>
-            <c:showLegendKey val="0"/>
-            <c:showVal val="1"/>
-            <c:showCatName val="0"/>
-            <c:showSerName val="1"/>
-            <c:showPercent val="0"/>
-            <c:showBubbleSize val="0"/>
-            <c:showLeaderLines val="1"/>
-            <c:separator>
-</c:separator>
-          </c:dLbls>
-          <c:cat>
-            <c:strRef>
-              <c:f>Sheet1!$A$2:$A$3</c:f>
-              <c:strCache>
-                <c:ptCount val="2"/>
-                <c:pt idx="0">
-                  <c:v>Medium</c:v>
-                </c:pt>
-                <c:pt idx="1">
-                  <c:v>Heavy</c:v>
-                </c:pt>
-              </c:strCache>
-            </c:strRef>
-          </c:cat>
-          <c:val>
-            <c:numRef>
-              <c:f>Sheet1!$D$2:$D$3</c:f>
-              <c:numCache>
-                <c:formatCode>General</c:formatCode>
-                <c:ptCount val="2"/>
-                <c:pt idx="0">
-                  <c:v>14</c:v>
-                </c:pt>
-                <c:pt idx="1">
-                  <c:v>4</c:v>
-                </c:pt>
-              </c:numCache>
-            </c:numRef>
-          </c:val>
-        </c:ser>
-        <c:ser>
-          <c:idx val="3"/>
-          <c:order val="3"/>
-          <c:tx>
-            <c:strRef>
-              <c:f>Sheet1!$E$1</c:f>
-              <c:strCache>
-                <c:ptCount val="1"/>
-                <c:pt idx="0">
-                  <c:v>Amco Veba</c:v>
-                </c:pt>
-              </c:strCache>
-            </c:strRef>
-          </c:tx>
-          <c:spPr>
-            <a:solidFill>
-              <a:srgbClr val="9ADBB5"/>
             </a:solidFill>
             <a:ln>
               <a:solidFill>
@@ -843,7 +763,7 @@
           </c:cat>
           <c:val>
             <c:numRef>
-              <c:f>Sheet1!$E$2:$E$3</c:f>
+              <c:f>Sheet1!$D$2:$D$3</c:f>
               <c:numCache>
                 <c:formatCode>General</c:formatCode>
                 <c:ptCount val="2"/>
@@ -852,6 +772,86 @@
                 </c:pt>
                 <c:pt idx="1">
                   <c:v>7</c:v>
+                </c:pt>
+              </c:numCache>
+            </c:numRef>
+          </c:val>
+        </c:ser>
+        <c:ser>
+          <c:idx val="3"/>
+          <c:order val="3"/>
+          <c:tx>
+            <c:strRef>
+              <c:f>Sheet1!$E$1</c:f>
+              <c:strCache>
+                <c:ptCount val="1"/>
+                <c:pt idx="0">
+                  <c:v>XCMG</c:v>
+                </c:pt>
+              </c:strCache>
+            </c:strRef>
+          </c:tx>
+          <c:spPr>
+            <a:solidFill>
+              <a:srgbClr val="9ADBB5"/>
+            </a:solidFill>
+            <a:ln>
+              <a:solidFill>
+                <a:srgbClr val="FFFFFF"/>
+              </a:solidFill>
+            </a:ln>
+          </c:spPr>
+          <c:dLbls>
+            <c:numFmt formatCode="0&quot; units&quot;;;;" sourceLinked="0"/>
+            <c:txPr>
+              <a:bodyPr/>
+              <a:lstStyle/>
+              <a:p>
+                <a:pPr>
+                  <a:defRPr sz="900" b="1">
+                    <a:solidFill>
+                      <a:srgbClr val="000000"/>
+                    </a:solidFill>
+                    <a:latin typeface="Neue Haas Grotesk Text Pro"/>
+                  </a:defRPr>
+                </a:pPr>
+              </a:p>
+            </c:txPr>
+            <c:showLegendKey val="0"/>
+            <c:showVal val="1"/>
+            <c:showCatName val="0"/>
+            <c:showSerName val="1"/>
+            <c:showPercent val="0"/>
+            <c:showBubbleSize val="0"/>
+            <c:showLeaderLines val="1"/>
+            <c:separator>
+</c:separator>
+          </c:dLbls>
+          <c:cat>
+            <c:strRef>
+              <c:f>Sheet1!$A$2:$A$3</c:f>
+              <c:strCache>
+                <c:ptCount val="2"/>
+                <c:pt idx="0">
+                  <c:v>Medium</c:v>
+                </c:pt>
+                <c:pt idx="1">
+                  <c:v>Heavy</c:v>
+                </c:pt>
+              </c:strCache>
+            </c:strRef>
+          </c:cat>
+          <c:val>
+            <c:numRef>
+              <c:f>Sheet1!$E$2:$E$3</c:f>
+              <c:numCache>
+                <c:formatCode>General</c:formatCode>
+                <c:ptCount val="2"/>
+                <c:pt idx="0">
+                  <c:v>14</c:v>
+                </c:pt>
+                <c:pt idx="1">
+                  <c:v>4</c:v>
                 </c:pt>
               </c:numCache>
             </c:numRef>
@@ -4249,7 +4249,7 @@
                 </a:solidFill>
                 <a:latin typeface="Neue Haas Grotesk Text Pro"/>
               </a:rPr>
-              <a:t>Medium and Heavy are 44% of units but 67% of value, and each class has one clear leader</a:t>
+              <a:t>Medium and Heavy are 44% of units but 67% of value; 3 brands hold 80%+ of each class</a:t>
             </a:r>
           </a:p>
         </p:txBody>
@@ -4346,7 +4346,7 @@
                 </a:solidFill>
                 <a:latin typeface="Neue Haas Grotesk Text Pro"/>
               </a:rPr>
-              <a:t>Sany Palfinger leads Medium with half of the units; Palfinger leads Heavy with 56%.</a:t>
+              <a:t>Three brands cover 82% of Medium and 85% of Heavy units.</a:t>
             </a:r>
           </a:p>
         </p:txBody>
@@ -5337,7 +5337,7 @@
                 </a:solidFill>
                 <a:latin typeface="Neue Haas Grotesk Text Pro"/>
               </a:rPr>
-              <a:t>Sany Palfinger</a:t>
+              <a:t>3 brands = 82% of units</a:t>
             </a:r>
             <a:r>
               <a:rPr sz="950" b="0">
@@ -5346,7 +5346,7 @@
                 </a:solidFill>
                 <a:latin typeface="Neue Haas Grotesk Text Pro"/>
               </a:rPr>
-              <a:t> leads with 30 of 60 units (50%).</a:t>
+              <a:t> (49 of 60) and 81% of value: Sany Palfinger, XCMG and Palfinger.</a:t>
             </a:r>
           </a:p>
           <a:p>
@@ -5358,7 +5358,7 @@
                 </a:solidFill>
                 <a:latin typeface="Neue Haas Grotesk Text Pro"/>
               </a:rPr>
-              <a:t>XCMG</a:t>
+              <a:t>Sany Palfinger</a:t>
             </a:r>
             <a:r>
               <a:rPr sz="950" b="0">
@@ -5367,7 +5367,7 @@
                 </a:solidFill>
                 <a:latin typeface="Neue Haas Grotesk Text Pro"/>
               </a:rPr>
-              <a:t> is #2 with 14 units; Palfinger sells 5.</a:t>
+              <a:t> alone holds 30 units (50%).</a:t>
             </a:r>
           </a:p>
           <a:p>
@@ -5375,20 +5375,20 @@
             <a:r>
               <a:rPr sz="950" b="1">
                 <a:solidFill>
-                  <a:srgbClr val="000000"/>
+                  <a:srgbClr val="6B6B6B"/>
                 </a:solidFill>
                 <a:latin typeface="Neue Haas Grotesk Text Pro"/>
               </a:rPr>
-              <a:t>So what: </a:t>
+              <a:t>Others: </a:t>
             </a:r>
             <a:r>
               <a:rPr sz="950" b="0">
                 <a:solidFill>
-                  <a:srgbClr val="000000"/>
+                  <a:srgbClr val="6B6B6B"/>
                 </a:solidFill>
                 <a:latin typeface="Neue Haas Grotesk Text Pro"/>
               </a:rPr>
-              <a:t>one-leader market; growth means taking units from Sany Palfinger.</a:t>
+              <a:t>Amco Veba 5, HIAB 5, Hyva 1.</a:t>
             </a:r>
           </a:p>
         </p:txBody>
@@ -5480,7 +5480,7 @@
                 </a:solidFill>
                 <a:latin typeface="Neue Haas Grotesk Text Pro"/>
               </a:rPr>
-              <a:t>Palfinger</a:t>
+              <a:t>3 brands = 85% of units</a:t>
             </a:r>
             <a:r>
               <a:rPr sz="950" b="0">
@@ -5489,7 +5489,7 @@
                 </a:solidFill>
                 <a:latin typeface="Neue Haas Grotesk Text Pro"/>
               </a:rPr>
-              <a:t> holds 22 of 39 units (56%).</a:t>
+              <a:t> (33 of 39) and 86% of value: Palfinger, Amco Veba and XCMG.</a:t>
             </a:r>
           </a:p>
           <a:p>
@@ -5501,7 +5501,7 @@
                 </a:solidFill>
                 <a:latin typeface="Neue Haas Grotesk Text Pro"/>
               </a:rPr>
-              <a:t>Amco Veba</a:t>
+              <a:t>Palfinger</a:t>
             </a:r>
             <a:r>
               <a:rPr sz="950" b="0">
@@ -5510,46 +5510,28 @@
                 </a:solidFill>
                 <a:latin typeface="Neue Haas Grotesk Text Pro"/>
               </a:rPr>
-              <a:t> (7) and </a:t>
-            </a:r>
+              <a:t> alone holds 22 units (56%).</a:t>
+            </a:r>
+          </a:p>
+          <a:p>
+            <a:pPr algn="l"/>
             <a:r>
               <a:rPr sz="950" b="1">
                 <a:solidFill>
-                  <a:srgbClr val="000000"/>
+                  <a:srgbClr val="6B6B6B"/>
                 </a:solidFill>
                 <a:latin typeface="Neue Haas Grotesk Text Pro"/>
               </a:rPr>
-              <a:t>XCMG</a:t>
+              <a:t>Others: </a:t>
             </a:r>
             <a:r>
               <a:rPr sz="950" b="0">
                 <a:solidFill>
-                  <a:srgbClr val="000000"/>
+                  <a:srgbClr val="6B6B6B"/>
                 </a:solidFill>
                 <a:latin typeface="Neue Haas Grotesk Text Pro"/>
               </a:rPr>
-              <a:t> (4) follow.</a:t>
-            </a:r>
-          </a:p>
-          <a:p>
-            <a:pPr algn="l"/>
-            <a:r>
-              <a:rPr sz="950" b="1">
-                <a:solidFill>
-                  <a:srgbClr val="000000"/>
-                </a:solidFill>
-                <a:latin typeface="Neue Haas Grotesk Text Pro"/>
-              </a:rPr>
-              <a:t>So what: </a:t>
-            </a:r>
-            <a:r>
-              <a:rPr sz="950" b="0">
-                <a:solidFill>
-                  <a:srgbClr val="000000"/>
-                </a:solidFill>
-                <a:latin typeface="Neue Haas Grotesk Text Pro"/>
-              </a:rPr>
-              <a:t>small in units but 42% of market value; about Rp 1,2 Bio per unit.</a:t>
+              <a:t>Hyva 3, Fassi 1, Sany Palfinger 1, Zoomlion 1.</a:t>
             </a:r>
           </a:p>
         </p:txBody>
@@ -5593,7 +5575,7 @@
                 </a:solidFill>
                 <a:latin typeface="Neue Haas Grotesk Text Pro"/>
               </a:rPr>
-              <a:t>Indonesia import records 2025, knuckle boom (folding) cranes; value converted from USD at assumed Rp 16.000/USD (Bio = billion).</a:t>
+              <a:t>Crane Market GVW Pairing v11 (Noir), sheet 8. Pivot Source, 2025 rows; value converted from USD at assumed Rp 16.000/USD (Bio = billion).</a:t>
             </a:r>
           </a:p>
         </p:txBody>
@@ -5637,7 +5619,7 @@
                 </a:solidFill>
                 <a:latin typeface="Neue Haas Grotesk Text Pro"/>
               </a:rPr>
-              <a:t>Chart numbers live in chart data (Edit Data); Others = class total minus named brands (formula); brand units from earlier data cut. Light (&lt; 8 tm) and Small (8–25 tm) excluded from focus.</a:t>
+              <a:t>Chart data = SUMIFS on 2025 database rows (Edit Data). Brands shown until 80% of class units (Pareto); Others = rest. Light (&lt; 8 tm) and Small (8–25 tm) excluded from focus.</a:t>
             </a:r>
           </a:p>
         </p:txBody>

</xml_diff>

<commit_message>
Add brand logos (from earlier F.lli Ferrari deck) to 2025 Pareto notes
Co-Authored-By: Claude Opus 5.5 <noreply@anthropic.com>
Claude-Session: https://claude.ai/code/session_01Cx9kswyecF7JAB1Rr5vVcV
</commit_message>
<xml_diff>
--- a/nedp_deck/Slide_2025_Medium_Heavy_Funnel.pptx
+++ b/nedp_deck/Slide_2025_Medium_Heavy_Funnel.pptx
@@ -5303,8 +5303,8 @@
         </p:nvSpPr>
         <p:spPr>
           <a:xfrm>
-            <a:off x="9620250" y="2914650"/>
-            <a:ext cx="2000250" cy="1257300"/>
+            <a:off x="9620250" y="2905125"/>
+            <a:ext cx="571500" cy="133350"/>
           </a:xfrm>
           <a:prstGeom prst="rect">
             <a:avLst/>
@@ -5328,10 +5328,105 @@
               <a:t>Medium</a:t>
             </a:r>
           </a:p>
+        </p:txBody>
+      </p:sp>
+      <p:pic>
+        <p:nvPicPr>
+          <p:cNvPr id="36" name="Picture 35" descr="sany_palfinger.png"/>
+          <p:cNvPicPr>
+            <a:picLocks noChangeAspect="1"/>
+          </p:cNvPicPr>
+          <p:nvPr/>
+        </p:nvPicPr>
+        <p:blipFill>
+          <a:blip r:embed="rId4"/>
+          <a:stretch>
+            <a:fillRect/>
+          </a:stretch>
+        </p:blipFill>
+        <p:spPr>
+          <a:xfrm>
+            <a:off x="9620250" y="3084393"/>
+            <a:ext cx="641958" cy="136765"/>
+          </a:xfrm>
+          <a:prstGeom prst="rect">
+            <a:avLst/>
+          </a:prstGeom>
+        </p:spPr>
+      </p:pic>
+      <p:pic>
+        <p:nvPicPr>
+          <p:cNvPr id="37" name="Picture 36" descr="xcmg.png"/>
+          <p:cNvPicPr>
+            <a:picLocks noChangeAspect="1"/>
+          </p:cNvPicPr>
+          <p:nvPr/>
+        </p:nvPicPr>
+        <p:blipFill>
+          <a:blip r:embed="rId5"/>
+          <a:stretch>
+            <a:fillRect/>
+          </a:stretch>
+        </p:blipFill>
+        <p:spPr>
+          <a:xfrm>
+            <a:off x="10319356" y="3084393"/>
+            <a:ext cx="626405" cy="136765"/>
+          </a:xfrm>
+          <a:prstGeom prst="rect">
+            <a:avLst/>
+          </a:prstGeom>
+        </p:spPr>
+      </p:pic>
+      <p:pic>
+        <p:nvPicPr>
+          <p:cNvPr id="38" name="Picture 37" descr="palfinger.png"/>
+          <p:cNvPicPr>
+            <a:picLocks noChangeAspect="1"/>
+          </p:cNvPicPr>
+          <p:nvPr/>
+        </p:nvPicPr>
+        <p:blipFill>
+          <a:blip r:embed="rId6"/>
+          <a:stretch>
+            <a:fillRect/>
+          </a:stretch>
+        </p:blipFill>
+        <p:spPr>
+          <a:xfrm>
+            <a:off x="11002909" y="3084393"/>
+            <a:ext cx="617593" cy="136765"/>
+          </a:xfrm>
+          <a:prstGeom prst="rect">
+            <a:avLst/>
+          </a:prstGeom>
+        </p:spPr>
+      </p:pic>
+      <p:sp>
+        <p:nvSpPr>
+          <p:cNvPr id="39" name="TextBox 38"/>
+          <p:cNvSpPr txBox="1"/>
+          <p:nvPr/>
+        </p:nvSpPr>
+        <p:spPr>
+          <a:xfrm>
+            <a:off x="9620250" y="3295650"/>
+            <a:ext cx="2000250" cy="895350"/>
+          </a:xfrm>
+          <a:prstGeom prst="rect">
+            <a:avLst/>
+          </a:prstGeom>
+          <a:noFill/>
+        </p:spPr>
+        <p:txBody>
+          <a:bodyPr wrap="square" anchor="t" lIns="0" rIns="0" tIns="0" bIns="0">
+            <a:spAutoFit/>
+          </a:bodyPr>
+          <a:lstStyle/>
           <a:p>
             <a:pPr algn="l"/>
             <a:r>
-              <a:rPr sz="950" b="1">
+              <a:rPr sz="900" b="1">
                 <a:solidFill>
                   <a:srgbClr val="1E9E57"/>
                 </a:solidFill>
@@ -5340,7 +5435,7 @@
               <a:t>3 brands = 82% of units</a:t>
             </a:r>
             <a:r>
-              <a:rPr sz="950" b="0">
+              <a:rPr sz="900" b="0">
                 <a:solidFill>
                   <a:srgbClr val="000000"/>
                 </a:solidFill>
@@ -5352,7 +5447,7 @@
           <a:p>
             <a:pPr algn="l"/>
             <a:r>
-              <a:rPr sz="950" b="1">
+              <a:rPr sz="900" b="1">
                 <a:solidFill>
                   <a:srgbClr val="000000"/>
                 </a:solidFill>
@@ -5361,7 +5456,7 @@
               <a:t>Sany Palfinger</a:t>
             </a:r>
             <a:r>
-              <a:rPr sz="950" b="0">
+              <a:rPr sz="900" b="0">
                 <a:solidFill>
                   <a:srgbClr val="000000"/>
                 </a:solidFill>
@@ -5373,7 +5468,7 @@
           <a:p>
             <a:pPr algn="l"/>
             <a:r>
-              <a:rPr sz="950" b="1">
+              <a:rPr sz="900" b="1">
                 <a:solidFill>
                   <a:srgbClr val="6B6B6B"/>
                 </a:solidFill>
@@ -5382,7 +5477,7 @@
               <a:t>Others: </a:t>
             </a:r>
             <a:r>
-              <a:rPr sz="950" b="0">
+              <a:rPr sz="900" b="0">
                 <a:solidFill>
                   <a:srgbClr val="6B6B6B"/>
                 </a:solidFill>
@@ -5395,7 +5490,7 @@
       </p:sp>
       <p:sp>
         <p:nvSpPr>
-          <p:cNvPr id="36" name="Rectangle 35"/>
+          <p:cNvPr id="40" name="Rectangle 39"/>
           <p:cNvSpPr/>
           <p:nvPr/>
         </p:nvSpPr>
@@ -5440,14 +5535,14 @@
       </p:sp>
       <p:sp>
         <p:nvSpPr>
-          <p:cNvPr id="37" name="TextBox 36"/>
+          <p:cNvPr id="41" name="TextBox 40"/>
           <p:cNvSpPr txBox="1"/>
           <p:nvPr/>
         </p:nvSpPr>
         <p:spPr>
           <a:xfrm>
-            <a:off x="9620250" y="4324350"/>
-            <a:ext cx="2000250" cy="1257300"/>
+            <a:off x="9620250" y="4314825"/>
+            <a:ext cx="571500" cy="133350"/>
           </a:xfrm>
           <a:prstGeom prst="rect">
             <a:avLst/>
@@ -5471,81 +5566,90 @@
               <a:t>Heavy</a:t>
             </a:r>
           </a:p>
-          <a:p>
-            <a:pPr algn="l"/>
-            <a:r>
-              <a:rPr sz="950" b="1">
-                <a:solidFill>
-                  <a:srgbClr val="1E9E57"/>
-                </a:solidFill>
-                <a:latin typeface="Neue Haas Grotesk Text Pro"/>
-              </a:rPr>
-              <a:t>3 brands = 85% of units</a:t>
-            </a:r>
-            <a:r>
-              <a:rPr sz="950" b="0">
-                <a:solidFill>
-                  <a:srgbClr val="000000"/>
-                </a:solidFill>
-                <a:latin typeface="Neue Haas Grotesk Text Pro"/>
-              </a:rPr>
-              <a:t> (33 of 39) and 86% of value: Palfinger, Amco Veba and XCMG.</a:t>
-            </a:r>
-          </a:p>
-          <a:p>
-            <a:pPr algn="l"/>
-            <a:r>
-              <a:rPr sz="950" b="1">
-                <a:solidFill>
-                  <a:srgbClr val="000000"/>
-                </a:solidFill>
-                <a:latin typeface="Neue Haas Grotesk Text Pro"/>
-              </a:rPr>
-              <a:t>Palfinger</a:t>
-            </a:r>
-            <a:r>
-              <a:rPr sz="950" b="0">
-                <a:solidFill>
-                  <a:srgbClr val="000000"/>
-                </a:solidFill>
-                <a:latin typeface="Neue Haas Grotesk Text Pro"/>
-              </a:rPr>
-              <a:t> alone holds 22 units (56%).</a:t>
-            </a:r>
-          </a:p>
-          <a:p>
-            <a:pPr algn="l"/>
-            <a:r>
-              <a:rPr sz="950" b="1">
-                <a:solidFill>
-                  <a:srgbClr val="6B6B6B"/>
-                </a:solidFill>
-                <a:latin typeface="Neue Haas Grotesk Text Pro"/>
-              </a:rPr>
-              <a:t>Others: </a:t>
-            </a:r>
-            <a:r>
-              <a:rPr sz="950" b="0">
-                <a:solidFill>
-                  <a:srgbClr val="6B6B6B"/>
-                </a:solidFill>
-                <a:latin typeface="Neue Haas Grotesk Text Pro"/>
-              </a:rPr>
-              <a:t>Hyva 3, Fassi 1, Sany Palfinger 1, Zoomlion 1.</a:t>
-            </a:r>
-          </a:p>
-        </p:txBody>
-      </p:sp>
-      <p:sp>
-        <p:nvSpPr>
-          <p:cNvPr id="38" name="TextBox 37"/>
+        </p:txBody>
+      </p:sp>
+      <p:pic>
+        <p:nvPicPr>
+          <p:cNvPr id="42" name="Picture 41" descr="palfinger.png"/>
+          <p:cNvPicPr>
+            <a:picLocks noChangeAspect="1"/>
+          </p:cNvPicPr>
+          <p:nvPr/>
+        </p:nvPicPr>
+        <p:blipFill>
+          <a:blip r:embed="rId6"/>
+          <a:stretch>
+            <a:fillRect/>
+          </a:stretch>
+        </p:blipFill>
+        <p:spPr>
+          <a:xfrm>
+            <a:off x="9620250" y="4492958"/>
+            <a:ext cx="627839" cy="139034"/>
+          </a:xfrm>
+          <a:prstGeom prst="rect">
+            <a:avLst/>
+          </a:prstGeom>
+        </p:spPr>
+      </p:pic>
+      <p:pic>
+        <p:nvPicPr>
+          <p:cNvPr id="43" name="Picture 42" descr="amco_veba.png"/>
+          <p:cNvPicPr>
+            <a:picLocks noChangeAspect="1"/>
+          </p:cNvPicPr>
+          <p:nvPr/>
+        </p:nvPicPr>
+        <p:blipFill>
+          <a:blip r:embed="rId7"/>
+          <a:stretch>
+            <a:fillRect/>
+          </a:stretch>
+        </p:blipFill>
+        <p:spPr>
+          <a:xfrm>
+            <a:off x="10305241" y="4492958"/>
+            <a:ext cx="621308" cy="139034"/>
+          </a:xfrm>
+          <a:prstGeom prst="rect">
+            <a:avLst/>
+          </a:prstGeom>
+        </p:spPr>
+      </p:pic>
+      <p:pic>
+        <p:nvPicPr>
+          <p:cNvPr id="44" name="Picture 43" descr="xcmg.png"/>
+          <p:cNvPicPr>
+            <a:picLocks noChangeAspect="1"/>
+          </p:cNvPicPr>
+          <p:nvPr/>
+        </p:nvPicPr>
+        <p:blipFill>
+          <a:blip r:embed="rId5"/>
+          <a:stretch>
+            <a:fillRect/>
+          </a:stretch>
+        </p:blipFill>
+        <p:spPr>
+          <a:xfrm>
+            <a:off x="10983701" y="4492958"/>
+            <a:ext cx="636797" cy="139034"/>
+          </a:xfrm>
+          <a:prstGeom prst="rect">
+            <a:avLst/>
+          </a:prstGeom>
+        </p:spPr>
+      </p:pic>
+      <p:sp>
+        <p:nvSpPr>
+          <p:cNvPr id="45" name="TextBox 44"/>
           <p:cNvSpPr txBox="1"/>
           <p:nvPr/>
         </p:nvSpPr>
         <p:spPr>
           <a:xfrm>
-            <a:off x="342900" y="6305550"/>
-            <a:ext cx="11506200" cy="152400"/>
+            <a:off x="9620250" y="4705350"/>
+            <a:ext cx="2000250" cy="895350"/>
           </a:xfrm>
           <a:prstGeom prst="rect">
             <a:avLst/>
@@ -5560,35 +5664,77 @@
           <a:p>
             <a:pPr algn="l"/>
             <a:r>
-              <a:rPr sz="1000" b="1">
-                <a:solidFill>
-                  <a:srgbClr val="000000"/>
+              <a:rPr sz="900" b="1">
+                <a:solidFill>
+                  <a:srgbClr val="1E9E57"/>
                 </a:solidFill>
                 <a:latin typeface="Neue Haas Grotesk Text Pro"/>
               </a:rPr>
-              <a:t>Source: </a:t>
-            </a:r>
-            <a:r>
-              <a:rPr sz="1000" b="0">
+              <a:t>3 brands = 85% of units</a:t>
+            </a:r>
+            <a:r>
+              <a:rPr sz="900" b="0">
                 <a:solidFill>
                   <a:srgbClr val="000000"/>
                 </a:solidFill>
                 <a:latin typeface="Neue Haas Grotesk Text Pro"/>
               </a:rPr>
-              <a:t>Crane Market GVW Pairing v11 (Noir), sheet 8. Pivot Source, 2025 rows; value converted from USD at assumed Rp 16.000/USD (Bio = billion).</a:t>
-            </a:r>
-          </a:p>
-        </p:txBody>
-      </p:sp>
-      <p:sp>
-        <p:nvSpPr>
-          <p:cNvPr id="39" name="TextBox 38"/>
+              <a:t> (33 of 39) and 86% of value: Palfinger, Amco Veba and XCMG.</a:t>
+            </a:r>
+          </a:p>
+          <a:p>
+            <a:pPr algn="l"/>
+            <a:r>
+              <a:rPr sz="900" b="1">
+                <a:solidFill>
+                  <a:srgbClr val="000000"/>
+                </a:solidFill>
+                <a:latin typeface="Neue Haas Grotesk Text Pro"/>
+              </a:rPr>
+              <a:t>Palfinger</a:t>
+            </a:r>
+            <a:r>
+              <a:rPr sz="900" b="0">
+                <a:solidFill>
+                  <a:srgbClr val="000000"/>
+                </a:solidFill>
+                <a:latin typeface="Neue Haas Grotesk Text Pro"/>
+              </a:rPr>
+              <a:t> alone holds 22 units (56%).</a:t>
+            </a:r>
+          </a:p>
+          <a:p>
+            <a:pPr algn="l"/>
+            <a:r>
+              <a:rPr sz="900" b="1">
+                <a:solidFill>
+                  <a:srgbClr val="6B6B6B"/>
+                </a:solidFill>
+                <a:latin typeface="Neue Haas Grotesk Text Pro"/>
+              </a:rPr>
+              <a:t>Others: </a:t>
+            </a:r>
+            <a:r>
+              <a:rPr sz="900" b="0">
+                <a:solidFill>
+                  <a:srgbClr val="6B6B6B"/>
+                </a:solidFill>
+                <a:latin typeface="Neue Haas Grotesk Text Pro"/>
+              </a:rPr>
+              <a:t>Hyva 3, Fassi 1, Sany Palfinger 1, Zoomlion 1.</a:t>
+            </a:r>
+          </a:p>
+        </p:txBody>
+      </p:sp>
+      <p:sp>
+        <p:nvSpPr>
+          <p:cNvPr id="46" name="TextBox 45"/>
           <p:cNvSpPr txBox="1"/>
           <p:nvPr/>
         </p:nvSpPr>
         <p:spPr>
           <a:xfrm>
-            <a:off x="342900" y="6477000"/>
+            <a:off x="342900" y="6305550"/>
             <a:ext cx="11506200" cy="152400"/>
           </a:xfrm>
           <a:prstGeom prst="rect">
@@ -5606,6 +5752,50 @@
             <a:r>
               <a:rPr sz="1000" b="1">
                 <a:solidFill>
+                  <a:srgbClr val="000000"/>
+                </a:solidFill>
+                <a:latin typeface="Neue Haas Grotesk Text Pro"/>
+              </a:rPr>
+              <a:t>Source: </a:t>
+            </a:r>
+            <a:r>
+              <a:rPr sz="1000" b="0">
+                <a:solidFill>
+                  <a:srgbClr val="000000"/>
+                </a:solidFill>
+                <a:latin typeface="Neue Haas Grotesk Text Pro"/>
+              </a:rPr>
+              <a:t>Crane Market GVW Pairing v11 (Noir), sheet 8. Pivot Source, 2025 rows; value converted from USD at assumed Rp 16.000/USD (Bio = billion).</a:t>
+            </a:r>
+          </a:p>
+        </p:txBody>
+      </p:sp>
+      <p:sp>
+        <p:nvSpPr>
+          <p:cNvPr id="47" name="TextBox 46"/>
+          <p:cNvSpPr txBox="1"/>
+          <p:nvPr/>
+        </p:nvSpPr>
+        <p:spPr>
+          <a:xfrm>
+            <a:off x="342900" y="6477000"/>
+            <a:ext cx="11506200" cy="152400"/>
+          </a:xfrm>
+          <a:prstGeom prst="rect">
+            <a:avLst/>
+          </a:prstGeom>
+          <a:noFill/>
+        </p:spPr>
+        <p:txBody>
+          <a:bodyPr wrap="square" anchor="t" lIns="0" rIns="0" tIns="0" bIns="0">
+            <a:spAutoFit/>
+          </a:bodyPr>
+          <a:lstStyle/>
+          <a:p>
+            <a:pPr algn="l"/>
+            <a:r>
+              <a:rPr sz="1000" b="1">
+                <a:solidFill>
                   <a:srgbClr val="6B6B6B"/>
                 </a:solidFill>
                 <a:latin typeface="Neue Haas Grotesk Text Pro"/>
@@ -5626,7 +5816,7 @@
       </p:sp>
       <p:cxnSp>
         <p:nvCxnSpPr>
-          <p:cNvPr id="40" name="Connector 39"/>
+          <p:cNvPr id="48" name="Connector 47"/>
           <p:cNvCxnSpPr/>
           <p:nvPr/>
         </p:nvCxnSpPr>

</xml_diff>

<commit_message>
Brand chart labels: brand, units and IDR value via Value From Cells formulas
Co-Authored-By: Claude Opus 5.5 <noreply@anthropic.com>
Claude-Session: https://claude.ai/code/session_01Cx9kswyecF7JAB1Rr5vVcV
</commit_message>
<xml_diff>
--- a/nedp_deck/Slide_2025_Medium_Heavy_Funnel.pptx
+++ b/nedp_deck/Slide_2025_Medium_Heavy_Funnel.pptx
@@ -574,14 +574,19 @@
               </a:p>
             </c:txPr>
             <c:showLegendKey val="0"/>
-            <c:showVal val="1"/>
+            <c:showVal val="0"/>
             <c:showCatName val="0"/>
-            <c:showSerName val="1"/>
+            <c:showSerName val="0"/>
             <c:showPercent val="0"/>
             <c:showBubbleSize val="0"/>
             <c:showLeaderLines val="1"/>
             <c:separator>
 </c:separator>
+            <c:extLst xmlns:c15="http://schemas.microsoft.com/office/drawing/2012/chart">
+              <c:ext uri="{CE6537A1-D6FC-4f65-9D91-7224C49458BB}">
+                <c15:showDataLabelsRange val="1"/>
+              </c:ext>
+            </c:extLst>
           </c:dLbls>
           <c:cat>
             <c:strRef>
@@ -612,6 +617,24 @@
               </c:numCache>
             </c:numRef>
           </c:val>
+          <c:extLst xmlns:c15="http://schemas.microsoft.com/office/drawing/2012/chart">
+            <c:ext uri="{02D57815-91ED-43cb-92C2-25804820EDAC}">
+              <c15:datalabelsRange>
+                <c15:f>Sheet1!$B$12:$B$13</c15:f>
+                <c15:dlblRangeCache>
+                  <c:ptCount val="2"/>
+                  <c:pt idx="0">
+                    <c:v>Sany Palfinger
+30 units
+Rp 11,9 Bio</c:v>
+                  </c:pt>
+                  <c:pt idx="1">
+                    <c:v/>
+                  </c:pt>
+                </c15:dlblRangeCache>
+              </c15:datalabelsRange>
+            </c:ext>
+          </c:extLst>
         </c:ser>
         <c:ser>
           <c:idx val="1"/>
@@ -654,14 +677,19 @@
               </a:p>
             </c:txPr>
             <c:showLegendKey val="0"/>
-            <c:showVal val="1"/>
+            <c:showVal val="0"/>
             <c:showCatName val="0"/>
-            <c:showSerName val="1"/>
+            <c:showSerName val="0"/>
             <c:showPercent val="0"/>
             <c:showBubbleSize val="0"/>
             <c:showLeaderLines val="1"/>
             <c:separator>
 </c:separator>
+            <c:extLst xmlns:c15="http://schemas.microsoft.com/office/drawing/2012/chart">
+              <c:ext uri="{CE6537A1-D6FC-4f65-9D91-7224C49458BB}">
+                <c15:showDataLabelsRange val="1"/>
+              </c:ext>
+            </c:extLst>
           </c:dLbls>
           <c:cat>
             <c:strRef>
@@ -692,6 +720,26 @@
               </c:numCache>
             </c:numRef>
           </c:val>
+          <c:extLst xmlns:c15="http://schemas.microsoft.com/office/drawing/2012/chart">
+            <c:ext uri="{02D57815-91ED-43cb-92C2-25804820EDAC}">
+              <c15:datalabelsRange>
+                <c15:f>Sheet1!$C$12:$C$13</c15:f>
+                <c15:dlblRangeCache>
+                  <c:ptCount val="2"/>
+                  <c:pt idx="0">
+                    <c:v>Palfinger
+5 units
+Rp 4,4 Bio</c:v>
+                  </c:pt>
+                  <c:pt idx="1">
+                    <c:v>Palfinger
+22 units
+Rp 26,7 Bio</c:v>
+                  </c:pt>
+                </c15:dlblRangeCache>
+              </c15:datalabelsRange>
+            </c:ext>
+          </c:extLst>
         </c:ser>
         <c:ser>
           <c:idx val="2"/>
@@ -738,14 +786,19 @@
               </a:p>
             </c:txPr>
             <c:showLegendKey val="0"/>
-            <c:showVal val="1"/>
+            <c:showVal val="0"/>
             <c:showCatName val="0"/>
-            <c:showSerName val="1"/>
+            <c:showSerName val="0"/>
             <c:showPercent val="0"/>
             <c:showBubbleSize val="0"/>
             <c:showLeaderLines val="1"/>
             <c:separator>
 </c:separator>
+            <c:extLst xmlns:c15="http://schemas.microsoft.com/office/drawing/2012/chart">
+              <c:ext uri="{CE6537A1-D6FC-4f65-9D91-7224C49458BB}">
+                <c15:showDataLabelsRange val="1"/>
+              </c:ext>
+            </c:extLst>
           </c:dLbls>
           <c:cat>
             <c:strRef>
@@ -776,6 +829,24 @@
               </c:numCache>
             </c:numRef>
           </c:val>
+          <c:extLst xmlns:c15="http://schemas.microsoft.com/office/drawing/2012/chart">
+            <c:ext uri="{02D57815-91ED-43cb-92C2-25804820EDAC}">
+              <c15:datalabelsRange>
+                <c15:f>Sheet1!$D$12:$D$13</c15:f>
+                <c15:dlblRangeCache>
+                  <c:ptCount val="2"/>
+                  <c:pt idx="0">
+                    <c:v/>
+                  </c:pt>
+                  <c:pt idx="1">
+                    <c:v>Amco Veba
+7 units
+Rp 9,9 Bio</c:v>
+                  </c:pt>
+                </c15:dlblRangeCache>
+              </c15:datalabelsRange>
+            </c:ext>
+          </c:extLst>
         </c:ser>
         <c:ser>
           <c:idx val="3"/>
@@ -818,14 +889,19 @@
               </a:p>
             </c:txPr>
             <c:showLegendKey val="0"/>
-            <c:showVal val="1"/>
+            <c:showVal val="0"/>
             <c:showCatName val="0"/>
-            <c:showSerName val="1"/>
+            <c:showSerName val="0"/>
             <c:showPercent val="0"/>
             <c:showBubbleSize val="0"/>
             <c:showLeaderLines val="1"/>
             <c:separator>
 </c:separator>
+            <c:extLst xmlns:c15="http://schemas.microsoft.com/office/drawing/2012/chart">
+              <c:ext uri="{CE6537A1-D6FC-4f65-9D91-7224C49458BB}">
+                <c15:showDataLabelsRange val="1"/>
+              </c:ext>
+            </c:extLst>
           </c:dLbls>
           <c:cat>
             <c:strRef>
@@ -856,6 +932,26 @@
               </c:numCache>
             </c:numRef>
           </c:val>
+          <c:extLst xmlns:c15="http://schemas.microsoft.com/office/drawing/2012/chart">
+            <c:ext uri="{02D57815-91ED-43cb-92C2-25804820EDAC}">
+              <c15:datalabelsRange>
+                <c15:f>Sheet1!$E$12:$E$13</c15:f>
+                <c15:dlblRangeCache>
+                  <c:ptCount val="2"/>
+                  <c:pt idx="0">
+                    <c:v>XCMG
+14 units
+Rp 6,5 Bio</c:v>
+                  </c:pt>
+                  <c:pt idx="1">
+                    <c:v>XCMG
+4 units
+Rp 4,2 Bio</c:v>
+                  </c:pt>
+                </c15:dlblRangeCache>
+              </c15:datalabelsRange>
+            </c:ext>
+          </c:extLst>
         </c:ser>
         <c:ser>
           <c:idx val="4"/>
@@ -898,14 +994,19 @@
               </a:p>
             </c:txPr>
             <c:showLegendKey val="0"/>
-            <c:showVal val="1"/>
+            <c:showVal val="0"/>
             <c:showCatName val="0"/>
-            <c:showSerName val="1"/>
+            <c:showSerName val="0"/>
             <c:showPercent val="0"/>
             <c:showBubbleSize val="0"/>
             <c:showLeaderLines val="1"/>
             <c:separator>
 </c:separator>
+            <c:extLst xmlns:c15="http://schemas.microsoft.com/office/drawing/2012/chart">
+              <c:ext uri="{CE6537A1-D6FC-4f65-9D91-7224C49458BB}">
+                <c15:showDataLabelsRange val="1"/>
+              </c:ext>
+            </c:extLst>
           </c:dLbls>
           <c:cat>
             <c:strRef>
@@ -936,6 +1037,26 @@
               </c:numCache>
             </c:numRef>
           </c:val>
+          <c:extLst xmlns:c15="http://schemas.microsoft.com/office/drawing/2012/chart">
+            <c:ext uri="{02D57815-91ED-43cb-92C2-25804820EDAC}">
+              <c15:datalabelsRange>
+                <c15:f>Sheet1!$F$12:$F$13</c15:f>
+                <c15:dlblRangeCache>
+                  <c:ptCount val="2"/>
+                  <c:pt idx="0">
+                    <c:v>Others
+11 units
+Rp 5,4 Bio</c:v>
+                  </c:pt>
+                  <c:pt idx="1">
+                    <c:v>Others
+6 units
+Rp 6,4 Bio</c:v>
+                  </c:pt>
+                </c15:dlblRangeCache>
+              </c15:datalabelsRange>
+            </c:ext>
+          </c:extLst>
         </c:ser>
         <c:gapWidth val="45"/>
         <c:overlap val="100"/>

</xml_diff>

<commit_message>
Split brand view into units chart and IDR value chart (native, SUMIFS-linked)
Co-Authored-By: Claude Opus 5.5 <noreply@anthropic.com>
Claude-Session: https://claude.ai/code/session_01Cx9kswyecF7JAB1Rr5vVcV
</commit_message>
<xml_diff>
--- a/nedp_deck/Slide_2025_Medium_Heavy_Funnel.pptx
+++ b/nedp_deck/Slide_2025_Medium_Heavy_Funnel.pptx
@@ -558,7 +558,7 @@
               <c:idx val="1"/>
               <c:delete val="1"/>
             </c:dLbl>
-            <c:numFmt formatCode="0&quot; units&quot;;;;" sourceLinked="0"/>
+            <c:numFmt sourceLinked="0" formatCode="0&quot; units&quot;;;;"/>
             <c:txPr>
               <a:bodyPr/>
               <a:lstStyle/>
@@ -574,19 +574,14 @@
               </a:p>
             </c:txPr>
             <c:showLegendKey val="0"/>
-            <c:showVal val="0"/>
+            <c:showVal val="1"/>
             <c:showCatName val="0"/>
-            <c:showSerName val="0"/>
+            <c:showSerName val="1"/>
             <c:showPercent val="0"/>
             <c:showBubbleSize val="0"/>
             <c:showLeaderLines val="1"/>
             <c:separator>
 </c:separator>
-            <c:extLst xmlns:c15="http://schemas.microsoft.com/office/drawing/2012/chart">
-              <c:ext uri="{CE6537A1-D6FC-4f65-9D91-7224C49458BB}">
-                <c15:showDataLabelsRange val="1"/>
-              </c:ext>
-            </c:extLst>
           </c:dLbls>
           <c:cat>
             <c:strRef>
@@ -617,24 +612,6 @@
               </c:numCache>
             </c:numRef>
           </c:val>
-          <c:extLst xmlns:c15="http://schemas.microsoft.com/office/drawing/2012/chart">
-            <c:ext uri="{02D57815-91ED-43cb-92C2-25804820EDAC}">
-              <c15:datalabelsRange>
-                <c15:f>Sheet1!$B$12:$B$13</c15:f>
-                <c15:dlblRangeCache>
-                  <c:ptCount val="2"/>
-                  <c:pt idx="0">
-                    <c:v>Sany Palfinger
-30 units
-Rp 11,9 Bio</c:v>
-                  </c:pt>
-                  <c:pt idx="1">
-                    <c:v/>
-                  </c:pt>
-                </c15:dlblRangeCache>
-              </c15:datalabelsRange>
-            </c:ext>
-          </c:extLst>
         </c:ser>
         <c:ser>
           <c:idx val="1"/>
@@ -661,7 +638,7 @@
             </a:ln>
           </c:spPr>
           <c:dLbls>
-            <c:numFmt formatCode="0&quot; units&quot;;;;" sourceLinked="0"/>
+            <c:numFmt sourceLinked="0" formatCode="0&quot; units&quot;;;;"/>
             <c:txPr>
               <a:bodyPr/>
               <a:lstStyle/>
@@ -677,19 +654,14 @@
               </a:p>
             </c:txPr>
             <c:showLegendKey val="0"/>
-            <c:showVal val="0"/>
+            <c:showVal val="1"/>
             <c:showCatName val="0"/>
-            <c:showSerName val="0"/>
+            <c:showSerName val="1"/>
             <c:showPercent val="0"/>
             <c:showBubbleSize val="0"/>
             <c:showLeaderLines val="1"/>
             <c:separator>
 </c:separator>
-            <c:extLst xmlns:c15="http://schemas.microsoft.com/office/drawing/2012/chart">
-              <c:ext uri="{CE6537A1-D6FC-4f65-9D91-7224C49458BB}">
-                <c15:showDataLabelsRange val="1"/>
-              </c:ext>
-            </c:extLst>
           </c:dLbls>
           <c:cat>
             <c:strRef>
@@ -720,26 +692,6 @@
               </c:numCache>
             </c:numRef>
           </c:val>
-          <c:extLst xmlns:c15="http://schemas.microsoft.com/office/drawing/2012/chart">
-            <c:ext uri="{02D57815-91ED-43cb-92C2-25804820EDAC}">
-              <c15:datalabelsRange>
-                <c15:f>Sheet1!$C$12:$C$13</c15:f>
-                <c15:dlblRangeCache>
-                  <c:ptCount val="2"/>
-                  <c:pt idx="0">
-                    <c:v>Palfinger
-5 units
-Rp 4,4 Bio</c:v>
-                  </c:pt>
-                  <c:pt idx="1">
-                    <c:v>Palfinger
-22 units
-Rp 26,7 Bio</c:v>
-                  </c:pt>
-                </c15:dlblRangeCache>
-              </c15:datalabelsRange>
-            </c:ext>
-          </c:extLst>
         </c:ser>
         <c:ser>
           <c:idx val="2"/>
@@ -770,7 +722,7 @@
               <c:idx val="0"/>
               <c:delete val="1"/>
             </c:dLbl>
-            <c:numFmt formatCode="0&quot; units&quot;;;;" sourceLinked="0"/>
+            <c:numFmt sourceLinked="0" formatCode="0&quot; units&quot;;;;"/>
             <c:txPr>
               <a:bodyPr/>
               <a:lstStyle/>
@@ -786,19 +738,14 @@
               </a:p>
             </c:txPr>
             <c:showLegendKey val="0"/>
-            <c:showVal val="0"/>
+            <c:showVal val="1"/>
             <c:showCatName val="0"/>
-            <c:showSerName val="0"/>
+            <c:showSerName val="1"/>
             <c:showPercent val="0"/>
             <c:showBubbleSize val="0"/>
             <c:showLeaderLines val="1"/>
             <c:separator>
 </c:separator>
-            <c:extLst xmlns:c15="http://schemas.microsoft.com/office/drawing/2012/chart">
-              <c:ext uri="{CE6537A1-D6FC-4f65-9D91-7224C49458BB}">
-                <c15:showDataLabelsRange val="1"/>
-              </c:ext>
-            </c:extLst>
           </c:dLbls>
           <c:cat>
             <c:strRef>
@@ -829,24 +776,6 @@
               </c:numCache>
             </c:numRef>
           </c:val>
-          <c:extLst xmlns:c15="http://schemas.microsoft.com/office/drawing/2012/chart">
-            <c:ext uri="{02D57815-91ED-43cb-92C2-25804820EDAC}">
-              <c15:datalabelsRange>
-                <c15:f>Sheet1!$D$12:$D$13</c15:f>
-                <c15:dlblRangeCache>
-                  <c:ptCount val="2"/>
-                  <c:pt idx="0">
-                    <c:v/>
-                  </c:pt>
-                  <c:pt idx="1">
-                    <c:v>Amco Veba
-7 units
-Rp 9,9 Bio</c:v>
-                  </c:pt>
-                </c15:dlblRangeCache>
-              </c15:datalabelsRange>
-            </c:ext>
-          </c:extLst>
         </c:ser>
         <c:ser>
           <c:idx val="3"/>
@@ -873,7 +802,7 @@
             </a:ln>
           </c:spPr>
           <c:dLbls>
-            <c:numFmt formatCode="0&quot; units&quot;;;;" sourceLinked="0"/>
+            <c:numFmt sourceLinked="0" formatCode="0&quot; units&quot;;;;"/>
             <c:txPr>
               <a:bodyPr/>
               <a:lstStyle/>
@@ -889,19 +818,14 @@
               </a:p>
             </c:txPr>
             <c:showLegendKey val="0"/>
-            <c:showVal val="0"/>
+            <c:showVal val="1"/>
             <c:showCatName val="0"/>
-            <c:showSerName val="0"/>
+            <c:showSerName val="1"/>
             <c:showPercent val="0"/>
             <c:showBubbleSize val="0"/>
             <c:showLeaderLines val="1"/>
             <c:separator>
 </c:separator>
-            <c:extLst xmlns:c15="http://schemas.microsoft.com/office/drawing/2012/chart">
-              <c:ext uri="{CE6537A1-D6FC-4f65-9D91-7224C49458BB}">
-                <c15:showDataLabelsRange val="1"/>
-              </c:ext>
-            </c:extLst>
           </c:dLbls>
           <c:cat>
             <c:strRef>
@@ -932,26 +856,6 @@
               </c:numCache>
             </c:numRef>
           </c:val>
-          <c:extLst xmlns:c15="http://schemas.microsoft.com/office/drawing/2012/chart">
-            <c:ext uri="{02D57815-91ED-43cb-92C2-25804820EDAC}">
-              <c15:datalabelsRange>
-                <c15:f>Sheet1!$E$12:$E$13</c15:f>
-                <c15:dlblRangeCache>
-                  <c:ptCount val="2"/>
-                  <c:pt idx="0">
-                    <c:v>XCMG
-14 units
-Rp 6,5 Bio</c:v>
-                  </c:pt>
-                  <c:pt idx="1">
-                    <c:v>XCMG
-4 units
-Rp 4,2 Bio</c:v>
-                  </c:pt>
-                </c15:dlblRangeCache>
-              </c15:datalabelsRange>
-            </c:ext>
-          </c:extLst>
         </c:ser>
         <c:ser>
           <c:idx val="4"/>
@@ -978,7 +882,7 @@
             </a:ln>
           </c:spPr>
           <c:dLbls>
-            <c:numFmt formatCode="0&quot; units&quot;;;;" sourceLinked="0"/>
+            <c:numFmt sourceLinked="0" formatCode="0&quot; units&quot;;;;"/>
             <c:txPr>
               <a:bodyPr/>
               <a:lstStyle/>
@@ -994,19 +898,14 @@
               </a:p>
             </c:txPr>
             <c:showLegendKey val="0"/>
-            <c:showVal val="0"/>
+            <c:showVal val="1"/>
             <c:showCatName val="0"/>
-            <c:showSerName val="0"/>
+            <c:showSerName val="1"/>
             <c:showPercent val="0"/>
             <c:showBubbleSize val="0"/>
             <c:showLeaderLines val="1"/>
             <c:separator>
 </c:separator>
-            <c:extLst xmlns:c15="http://schemas.microsoft.com/office/drawing/2012/chart">
-              <c:ext uri="{CE6537A1-D6FC-4f65-9D91-7224C49458BB}">
-                <c15:showDataLabelsRange val="1"/>
-              </c:ext>
-            </c:extLst>
           </c:dLbls>
           <c:cat>
             <c:strRef>
@@ -1037,28 +936,8 @@
               </c:numCache>
             </c:numRef>
           </c:val>
-          <c:extLst xmlns:c15="http://schemas.microsoft.com/office/drawing/2012/chart">
-            <c:ext uri="{02D57815-91ED-43cb-92C2-25804820EDAC}">
-              <c15:datalabelsRange>
-                <c15:f>Sheet1!$F$12:$F$13</c15:f>
-                <c15:dlblRangeCache>
-                  <c:ptCount val="2"/>
-                  <c:pt idx="0">
-                    <c:v>Others
-11 units
-Rp 5,4 Bio</c:v>
-                  </c:pt>
-                  <c:pt idx="1">
-                    <c:v>Others
-6 units
-Rp 6,4 Bio</c:v>
-                  </c:pt>
-                </c15:dlblRangeCache>
-              </c15:datalabelsRange>
-            </c:ext>
-          </c:extLst>
         </c:ser>
-        <c:gapWidth val="45"/>
+        <c:gapWidth val="40"/>
         <c:overlap val="100"/>
         <c:serLines>
           <c:spPr>
@@ -1094,7 +973,503 @@
           <a:lstStyle/>
           <a:p>
             <a:pPr>
-              <a:defRPr sz="1200" b="1"/>
+              <a:defRPr sz="1100" b="1"/>
+            </a:pPr>
+          </a:p>
+        </c:txPr>
+        <c:crossAx val="-2113994440"/>
+        <c:crosses val="autoZero"/>
+        <c:auto val="1"/>
+        <c:lblAlgn val="ctr"/>
+        <c:lblOffset val="100"/>
+        <c:noMultiLvlLbl val="0"/>
+      </c:catAx>
+      <c:valAx>
+        <c:axId val="-2113994440"/>
+        <c:scaling/>
+        <c:delete/>
+        <c:axPos val="b"/>
+        <c:majorTickMark val="out"/>
+        <c:minorTickMark val="none"/>
+        <c:tickLblPos val="nextTo"/>
+        <c:crossAx val="-2068027336"/>
+        <c:crosses val="autoZero"/>
+      </c:valAx>
+    </c:plotArea>
+    <c:dispBlanksAs val="gap"/>
+  </c:chart>
+  <c:txPr>
+    <a:bodyPr/>
+    <a:lstStyle/>
+    <a:p>
+      <a:pPr>
+        <a:defRPr sz="1000">
+          <a:latin typeface="Neue Haas Grotesk Text Pro"/>
+        </a:defRPr>
+      </a:pPr>
+      <a:endParaRPr lang="en-US"/>
+    </a:p>
+  </c:txPr>
+  <c:externalData r:id="rId1">
+    <c:autoUpdate val="0"/>
+  </c:externalData>
+</c:chartSpace>
+</file>
+
+<file path=ppt/charts/chart3.xml><?xml version="1.0" encoding="utf-8"?>
+<c:chartSpace xmlns:c="http://schemas.openxmlformats.org/drawingml/2006/chart" xmlns:a="http://schemas.openxmlformats.org/drawingml/2006/main" xmlns:r="http://schemas.openxmlformats.org/officeDocument/2006/relationships">
+  <c:date1904 val="0"/>
+  <c:chart>
+    <c:autoTitleDeleted val="0"/>
+    <c:plotArea>
+      <c:barChart>
+        <c:barDir val="bar"/>
+        <c:grouping val="percentStacked"/>
+        <c:ser>
+          <c:idx val="0"/>
+          <c:order val="0"/>
+          <c:tx>
+            <c:strRef>
+              <c:f>Sheet1!$B$1</c:f>
+              <c:strCache>
+                <c:ptCount val="1"/>
+                <c:pt idx="0">
+                  <c:v>Sany Palfinger</c:v>
+                </c:pt>
+              </c:strCache>
+            </c:strRef>
+          </c:tx>
+          <c:spPr>
+            <a:solidFill>
+              <a:srgbClr val="0B4D2A"/>
+            </a:solidFill>
+            <a:ln>
+              <a:solidFill>
+                <a:srgbClr val="FFFFFF"/>
+              </a:solidFill>
+            </a:ln>
+          </c:spPr>
+          <c:dLbls>
+            <c:dLbl>
+              <c:idx val="1"/>
+              <c:delete val="1"/>
+            </c:dLbl>
+            <c:numFmt sourceLinked="0" formatCode="&quot;Rp &quot;0.0&quot; Bio&quot;;;;"/>
+            <c:txPr>
+              <a:bodyPr/>
+              <a:lstStyle/>
+              <a:p>
+                <a:pPr>
+                  <a:defRPr sz="900" b="1">
+                    <a:solidFill>
+                      <a:srgbClr val="FFFFFF"/>
+                    </a:solidFill>
+                    <a:latin typeface="Neue Haas Grotesk Text Pro"/>
+                  </a:defRPr>
+                </a:pPr>
+              </a:p>
+            </c:txPr>
+            <c:showLegendKey val="0"/>
+            <c:showVal val="1"/>
+            <c:showCatName val="0"/>
+            <c:showSerName val="1"/>
+            <c:showPercent val="0"/>
+            <c:showBubbleSize val="0"/>
+            <c:showLeaderLines val="1"/>
+            <c:separator>
+</c:separator>
+          </c:dLbls>
+          <c:cat>
+            <c:strRef>
+              <c:f>Sheet1!$A$2:$A$3</c:f>
+              <c:strCache>
+                <c:ptCount val="2"/>
+                <c:pt idx="0">
+                  <c:v>Medium</c:v>
+                </c:pt>
+                <c:pt idx="1">
+                  <c:v>Heavy</c:v>
+                </c:pt>
+              </c:strCache>
+            </c:strRef>
+          </c:cat>
+          <c:val>
+            <c:numRef>
+              <c:f>Sheet1!$B$2:$B$3</c:f>
+              <c:numCache>
+                <c:formatCode>General</c:formatCode>
+                <c:ptCount val="2"/>
+                <c:pt idx="0">
+                  <c:v>11.9</c:v>
+                </c:pt>
+                <c:pt idx="1">
+                  <c:v>0</c:v>
+                </c:pt>
+              </c:numCache>
+            </c:numRef>
+          </c:val>
+        </c:ser>
+        <c:ser>
+          <c:idx val="1"/>
+          <c:order val="1"/>
+          <c:tx>
+            <c:strRef>
+              <c:f>Sheet1!$C$1</c:f>
+              <c:strCache>
+                <c:ptCount val="1"/>
+                <c:pt idx="0">
+                  <c:v>Palfinger</c:v>
+                </c:pt>
+              </c:strCache>
+            </c:strRef>
+          </c:tx>
+          <c:spPr>
+            <a:solidFill>
+              <a:srgbClr val="1E9E57"/>
+            </a:solidFill>
+            <a:ln>
+              <a:solidFill>
+                <a:srgbClr val="FFFFFF"/>
+              </a:solidFill>
+            </a:ln>
+          </c:spPr>
+          <c:dLbls>
+            <c:numFmt sourceLinked="0" formatCode="&quot;Rp &quot;0.0&quot; Bio&quot;;;;"/>
+            <c:txPr>
+              <a:bodyPr/>
+              <a:lstStyle/>
+              <a:p>
+                <a:pPr>
+                  <a:defRPr sz="900" b="1">
+                    <a:solidFill>
+                      <a:srgbClr val="FFFFFF"/>
+                    </a:solidFill>
+                    <a:latin typeface="Neue Haas Grotesk Text Pro"/>
+                  </a:defRPr>
+                </a:pPr>
+              </a:p>
+            </c:txPr>
+            <c:showLegendKey val="0"/>
+            <c:showVal val="1"/>
+            <c:showCatName val="0"/>
+            <c:showSerName val="1"/>
+            <c:showPercent val="0"/>
+            <c:showBubbleSize val="0"/>
+            <c:showLeaderLines val="1"/>
+            <c:separator>
+</c:separator>
+          </c:dLbls>
+          <c:cat>
+            <c:strRef>
+              <c:f>Sheet1!$A$2:$A$3</c:f>
+              <c:strCache>
+                <c:ptCount val="2"/>
+                <c:pt idx="0">
+                  <c:v>Medium</c:v>
+                </c:pt>
+                <c:pt idx="1">
+                  <c:v>Heavy</c:v>
+                </c:pt>
+              </c:strCache>
+            </c:strRef>
+          </c:cat>
+          <c:val>
+            <c:numRef>
+              <c:f>Sheet1!$C$2:$C$3</c:f>
+              <c:numCache>
+                <c:formatCode>General</c:formatCode>
+                <c:ptCount val="2"/>
+                <c:pt idx="0">
+                  <c:v>4.4</c:v>
+                </c:pt>
+                <c:pt idx="1">
+                  <c:v>26.7</c:v>
+                </c:pt>
+              </c:numCache>
+            </c:numRef>
+          </c:val>
+        </c:ser>
+        <c:ser>
+          <c:idx val="2"/>
+          <c:order val="2"/>
+          <c:tx>
+            <c:strRef>
+              <c:f>Sheet1!$D$1</c:f>
+              <c:strCache>
+                <c:ptCount val="1"/>
+                <c:pt idx="0">
+                  <c:v>Amco Veba</c:v>
+                </c:pt>
+              </c:strCache>
+            </c:strRef>
+          </c:tx>
+          <c:spPr>
+            <a:solidFill>
+              <a:srgbClr val="6FCF97"/>
+            </a:solidFill>
+            <a:ln>
+              <a:solidFill>
+                <a:srgbClr val="FFFFFF"/>
+              </a:solidFill>
+            </a:ln>
+          </c:spPr>
+          <c:dLbls>
+            <c:dLbl>
+              <c:idx val="0"/>
+              <c:delete val="1"/>
+            </c:dLbl>
+            <c:numFmt sourceLinked="0" formatCode="&quot;Rp &quot;0.0&quot; Bio&quot;;;;"/>
+            <c:txPr>
+              <a:bodyPr/>
+              <a:lstStyle/>
+              <a:p>
+                <a:pPr>
+                  <a:defRPr sz="900" b="1">
+                    <a:solidFill>
+                      <a:srgbClr val="000000"/>
+                    </a:solidFill>
+                    <a:latin typeface="Neue Haas Grotesk Text Pro"/>
+                  </a:defRPr>
+                </a:pPr>
+              </a:p>
+            </c:txPr>
+            <c:showLegendKey val="0"/>
+            <c:showVal val="1"/>
+            <c:showCatName val="0"/>
+            <c:showSerName val="1"/>
+            <c:showPercent val="0"/>
+            <c:showBubbleSize val="0"/>
+            <c:showLeaderLines val="1"/>
+            <c:separator>
+</c:separator>
+          </c:dLbls>
+          <c:cat>
+            <c:strRef>
+              <c:f>Sheet1!$A$2:$A$3</c:f>
+              <c:strCache>
+                <c:ptCount val="2"/>
+                <c:pt idx="0">
+                  <c:v>Medium</c:v>
+                </c:pt>
+                <c:pt idx="1">
+                  <c:v>Heavy</c:v>
+                </c:pt>
+              </c:strCache>
+            </c:strRef>
+          </c:cat>
+          <c:val>
+            <c:numRef>
+              <c:f>Sheet1!$D$2:$D$3</c:f>
+              <c:numCache>
+                <c:formatCode>General</c:formatCode>
+                <c:ptCount val="2"/>
+                <c:pt idx="0">
+                  <c:v>0</c:v>
+                </c:pt>
+                <c:pt idx="1">
+                  <c:v>9.9</c:v>
+                </c:pt>
+              </c:numCache>
+            </c:numRef>
+          </c:val>
+        </c:ser>
+        <c:ser>
+          <c:idx val="3"/>
+          <c:order val="3"/>
+          <c:tx>
+            <c:strRef>
+              <c:f>Sheet1!$E$1</c:f>
+              <c:strCache>
+                <c:ptCount val="1"/>
+                <c:pt idx="0">
+                  <c:v>XCMG</c:v>
+                </c:pt>
+              </c:strCache>
+            </c:strRef>
+          </c:tx>
+          <c:spPr>
+            <a:solidFill>
+              <a:srgbClr val="9ADBB5"/>
+            </a:solidFill>
+            <a:ln>
+              <a:solidFill>
+                <a:srgbClr val="FFFFFF"/>
+              </a:solidFill>
+            </a:ln>
+          </c:spPr>
+          <c:dLbls>
+            <c:numFmt sourceLinked="0" formatCode="&quot;Rp &quot;0.0&quot; Bio&quot;;;;"/>
+            <c:txPr>
+              <a:bodyPr/>
+              <a:lstStyle/>
+              <a:p>
+                <a:pPr>
+                  <a:defRPr sz="900" b="1">
+                    <a:solidFill>
+                      <a:srgbClr val="000000"/>
+                    </a:solidFill>
+                    <a:latin typeface="Neue Haas Grotesk Text Pro"/>
+                  </a:defRPr>
+                </a:pPr>
+              </a:p>
+            </c:txPr>
+            <c:showLegendKey val="0"/>
+            <c:showVal val="1"/>
+            <c:showCatName val="0"/>
+            <c:showSerName val="1"/>
+            <c:showPercent val="0"/>
+            <c:showBubbleSize val="0"/>
+            <c:showLeaderLines val="1"/>
+            <c:separator>
+</c:separator>
+          </c:dLbls>
+          <c:cat>
+            <c:strRef>
+              <c:f>Sheet1!$A$2:$A$3</c:f>
+              <c:strCache>
+                <c:ptCount val="2"/>
+                <c:pt idx="0">
+                  <c:v>Medium</c:v>
+                </c:pt>
+                <c:pt idx="1">
+                  <c:v>Heavy</c:v>
+                </c:pt>
+              </c:strCache>
+            </c:strRef>
+          </c:cat>
+          <c:val>
+            <c:numRef>
+              <c:f>Sheet1!$E$2:$E$3</c:f>
+              <c:numCache>
+                <c:formatCode>General</c:formatCode>
+                <c:ptCount val="2"/>
+                <c:pt idx="0">
+                  <c:v>6.5</c:v>
+                </c:pt>
+                <c:pt idx="1">
+                  <c:v>4.2</c:v>
+                </c:pt>
+              </c:numCache>
+            </c:numRef>
+          </c:val>
+        </c:ser>
+        <c:ser>
+          <c:idx val="4"/>
+          <c:order val="4"/>
+          <c:tx>
+            <c:strRef>
+              <c:f>Sheet1!$F$1</c:f>
+              <c:strCache>
+                <c:ptCount val="1"/>
+                <c:pt idx="0">
+                  <c:v>Others</c:v>
+                </c:pt>
+              </c:strCache>
+            </c:strRef>
+          </c:tx>
+          <c:spPr>
+            <a:solidFill>
+              <a:srgbClr val="D9D9D9"/>
+            </a:solidFill>
+            <a:ln>
+              <a:solidFill>
+                <a:srgbClr val="FFFFFF"/>
+              </a:solidFill>
+            </a:ln>
+          </c:spPr>
+          <c:dLbls>
+            <c:numFmt sourceLinked="0" formatCode="&quot;Rp &quot;0.0&quot; Bio&quot;;;;"/>
+            <c:txPr>
+              <a:bodyPr/>
+              <a:lstStyle/>
+              <a:p>
+                <a:pPr>
+                  <a:defRPr sz="900" b="1">
+                    <a:solidFill>
+                      <a:srgbClr val="000000"/>
+                    </a:solidFill>
+                    <a:latin typeface="Neue Haas Grotesk Text Pro"/>
+                  </a:defRPr>
+                </a:pPr>
+              </a:p>
+            </c:txPr>
+            <c:showLegendKey val="0"/>
+            <c:showVal val="1"/>
+            <c:showCatName val="0"/>
+            <c:showSerName val="1"/>
+            <c:showPercent val="0"/>
+            <c:showBubbleSize val="0"/>
+            <c:showLeaderLines val="1"/>
+            <c:separator>
+</c:separator>
+          </c:dLbls>
+          <c:cat>
+            <c:strRef>
+              <c:f>Sheet1!$A$2:$A$3</c:f>
+              <c:strCache>
+                <c:ptCount val="2"/>
+                <c:pt idx="0">
+                  <c:v>Medium</c:v>
+                </c:pt>
+                <c:pt idx="1">
+                  <c:v>Heavy</c:v>
+                </c:pt>
+              </c:strCache>
+            </c:strRef>
+          </c:cat>
+          <c:val>
+            <c:numRef>
+              <c:f>Sheet1!$F$2:$F$3</c:f>
+              <c:numCache>
+                <c:formatCode>General</c:formatCode>
+                <c:ptCount val="2"/>
+                <c:pt idx="0">
+                  <c:v>5.4</c:v>
+                </c:pt>
+                <c:pt idx="1">
+                  <c:v>6.4</c:v>
+                </c:pt>
+              </c:numCache>
+            </c:numRef>
+          </c:val>
+        </c:ser>
+        <c:gapWidth val="40"/>
+        <c:overlap val="100"/>
+        <c:serLines>
+          <c:spPr>
+            <a:ln w="6350">
+              <a:solidFill>
+                <a:srgbClr val="7F7F7F"/>
+              </a:solidFill>
+            </a:ln>
+          </c:spPr>
+        </c:serLines>
+        <c:axId val="-2068027336"/>
+        <c:axId val="-2113994440"/>
+      </c:barChart>
+      <c:catAx>
+        <c:axId val="-2068027336"/>
+        <c:scaling>
+          <c:orientation val="maxMin"/>
+        </c:scaling>
+        <c:delete val="0"/>
+        <c:axPos val="l"/>
+        <c:majorTickMark val="none"/>
+        <c:minorTickMark val="none"/>
+        <c:tickLblPos val="nextTo"/>
+        <c:spPr>
+          <a:ln>
+            <a:solidFill>
+              <a:srgbClr val="000000"/>
+            </a:solidFill>
+          </a:ln>
+        </c:spPr>
+        <c:txPr>
+          <a:bodyPr/>
+          <a:lstStyle/>
+          <a:p>
+            <a:pPr>
+              <a:defRPr sz="1100" b="1"/>
             </a:pPr>
           </a:p>
         </c:txPr>
@@ -5282,8 +5657,8 @@
         </p:nvSpPr>
         <p:spPr>
           <a:xfrm>
-            <a:off x="4438650" y="2381250"/>
-            <a:ext cx="4953000" cy="190500"/>
+            <a:off x="4438650" y="2362200"/>
+            <a:ext cx="4953000" cy="171450"/>
           </a:xfrm>
           <a:prstGeom prst="rect">
             <a:avLst/>
@@ -5298,72 +5673,37 @@
           <a:p>
             <a:pPr algn="l"/>
             <a:r>
-              <a:rPr sz="1200" b="1">
+              <a:rPr sz="1100" b="1">
                 <a:solidFill>
                   <a:srgbClr val="000000"/>
                 </a:solidFill>
                 <a:latin typeface="Neue Haas Grotesk Text Pro"/>
               </a:rPr>
-              <a:t>Brand share of units, Medium vs Heavy, 2025, </a:t>
-            </a:r>
-            <a:r>
-              <a:rPr sz="1200" b="0">
+              <a:t>Units by brand, </a:t>
+            </a:r>
+            <a:r>
+              <a:rPr sz="1100" b="0">
                 <a:solidFill>
                   <a:srgbClr val="000000"/>
                 </a:solidFill>
                 <a:latin typeface="Neue Haas Grotesk Text Pro"/>
               </a:rPr>
-              <a:t>% of class units</a:t>
-            </a:r>
-          </a:p>
-        </p:txBody>
-      </p:sp>
-      <p:sp>
-        <p:nvSpPr>
-          <p:cNvPr id="32" name="TextBox 31"/>
-          <p:cNvSpPr txBox="1"/>
-          <p:nvPr/>
-        </p:nvSpPr>
-        <p:spPr>
-          <a:xfrm>
-            <a:off x="4438650" y="2571750"/>
-            <a:ext cx="4953000" cy="171450"/>
-          </a:xfrm>
-          <a:prstGeom prst="rect">
-            <a:avLst/>
-          </a:prstGeom>
-          <a:noFill/>
-        </p:spPr>
-        <p:txBody>
-          <a:bodyPr wrap="square" anchor="t" lIns="0" rIns="0" tIns="0" bIns="0">
-            <a:spAutoFit/>
-          </a:bodyPr>
-          <a:lstStyle/>
-          <a:p>
-            <a:pPr algn="l"/>
-            <a:r>
-              <a:rPr sz="1000" b="1">
-                <a:solidFill>
-                  <a:srgbClr val="6B6B6B"/>
-                </a:solidFill>
-                <a:latin typeface="Neue Haas Grotesk Text Pro"/>
-              </a:rPr>
-              <a:t>Medium = 60 units (Rp 28,2 Bio)  ·  Heavy = 39 units (Rp 47,2 Bio)</a:t>
+              <a:t>% of class units (Medium 60, Heavy 39)</a:t>
             </a:r>
           </a:p>
         </p:txBody>
       </p:sp>
       <p:graphicFrame>
         <p:nvGraphicFramePr>
-          <p:cNvPr id="33" name="Chart 32"/>
+          <p:cNvPr id="32" name="Chart 31"/>
           <p:cNvGraphicFramePr>
             <a:graphicFrameLocks noGrp="1"/>
           </p:cNvGraphicFramePr>
           <p:nvPr/>
         </p:nvGraphicFramePr>
         <p:xfrm>
-          <a:off x="4381500" y="2781300"/>
-          <a:ext cx="5048250" cy="3143250"/>
+          <a:off x="4381500" y="2533650"/>
+          <a:ext cx="5048250" cy="1638300"/>
         </p:xfrm>
         <a:graphic>
           <a:graphicData uri="http://schemas.openxmlformats.org/drawingml/2006/chart">
@@ -5371,9 +5711,106 @@
           </a:graphicData>
         </a:graphic>
       </p:graphicFrame>
-      <p:sp>
-        <p:nvSpPr>
-          <p:cNvPr id="34" name="Rectangle 33"/>
+      <p:cxnSp>
+        <p:nvCxnSpPr>
+          <p:cNvPr id="33" name="Connector 32"/>
+          <p:cNvCxnSpPr/>
+          <p:nvPr/>
+        </p:nvCxnSpPr>
+        <p:spPr>
+          <a:xfrm>
+            <a:off x="4438650" y="4229100"/>
+            <a:ext cx="4953000" cy="0"/>
+          </a:xfrm>
+          <a:prstGeom prst="line">
+            <a:avLst/>
+          </a:prstGeom>
+          <a:ln w="9525">
+            <a:solidFill>
+              <a:srgbClr val="BFBFBF"/>
+            </a:solidFill>
+          </a:ln>
+        </p:spPr>
+        <p:style>
+          <a:lnRef idx="2">
+            <a:schemeClr val="accent1"/>
+          </a:lnRef>
+          <a:fillRef idx="0">
+            <a:schemeClr val="accent1"/>
+          </a:fillRef>
+          <a:effectRef idx="1">
+            <a:schemeClr val="accent1"/>
+          </a:effectRef>
+          <a:fontRef idx="minor">
+            <a:schemeClr val="tx1"/>
+          </a:fontRef>
+        </p:style>
+      </p:cxnSp>
+      <p:sp>
+        <p:nvSpPr>
+          <p:cNvPr id="34" name="TextBox 33"/>
+          <p:cNvSpPr txBox="1"/>
+          <p:nvPr/>
+        </p:nvSpPr>
+        <p:spPr>
+          <a:xfrm>
+            <a:off x="4438650" y="4286250"/>
+            <a:ext cx="4953000" cy="171450"/>
+          </a:xfrm>
+          <a:prstGeom prst="rect">
+            <a:avLst/>
+          </a:prstGeom>
+          <a:noFill/>
+        </p:spPr>
+        <p:txBody>
+          <a:bodyPr wrap="square" anchor="t" lIns="0" rIns="0" tIns="0" bIns="0">
+            <a:spAutoFit/>
+          </a:bodyPr>
+          <a:lstStyle/>
+          <a:p>
+            <a:pPr algn="l"/>
+            <a:r>
+              <a:rPr sz="1100" b="1">
+                <a:solidFill>
+                  <a:srgbClr val="000000"/>
+                </a:solidFill>
+                <a:latin typeface="Neue Haas Grotesk Text Pro"/>
+              </a:rPr>
+              <a:t>Value by brand, </a:t>
+            </a:r>
+            <a:r>
+              <a:rPr sz="1100" b="0">
+                <a:solidFill>
+                  <a:srgbClr val="000000"/>
+                </a:solidFill>
+                <a:latin typeface="Neue Haas Grotesk Text Pro"/>
+              </a:rPr>
+              <a:t>% of class value (Medium Rp 28,2 Bio, Heavy Rp 47,2 Bio)</a:t>
+            </a:r>
+          </a:p>
+        </p:txBody>
+      </p:sp>
+      <p:graphicFrame>
+        <p:nvGraphicFramePr>
+          <p:cNvPr id="35" name="Chart 34"/>
+          <p:cNvGraphicFramePr>
+            <a:graphicFrameLocks noGrp="1"/>
+          </p:cNvGraphicFramePr>
+          <p:nvPr/>
+        </p:nvGraphicFramePr>
+        <p:xfrm>
+          <a:off x="4381500" y="4457700"/>
+          <a:ext cx="5048250" cy="1733550"/>
+        </p:xfrm>
+        <a:graphic>
+          <a:graphicData uri="http://schemas.openxmlformats.org/drawingml/2006/chart">
+            <c:chart xmlns:c="http://schemas.openxmlformats.org/drawingml/2006/chart" r:id="rId4"/>
+          </a:graphicData>
+        </a:graphic>
+      </p:graphicFrame>
+      <p:sp>
+        <p:nvSpPr>
+          <p:cNvPr id="36" name="Rectangle 35"/>
           <p:cNvSpPr/>
           <p:nvPr/>
         </p:nvSpPr>
@@ -5418,7 +5855,7 @@
       </p:sp>
       <p:sp>
         <p:nvSpPr>
-          <p:cNvPr id="35" name="TextBox 34"/>
+          <p:cNvPr id="37" name="TextBox 36"/>
           <p:cNvSpPr txBox="1"/>
           <p:nvPr/>
         </p:nvSpPr>
@@ -5453,31 +5890,7 @@
       </p:sp>
       <p:pic>
         <p:nvPicPr>
-          <p:cNvPr id="36" name="Picture 35" descr="sany_palfinger.png"/>
-          <p:cNvPicPr>
-            <a:picLocks noChangeAspect="1"/>
-          </p:cNvPicPr>
-          <p:nvPr/>
-        </p:nvPicPr>
-        <p:blipFill>
-          <a:blip r:embed="rId4"/>
-          <a:stretch>
-            <a:fillRect/>
-          </a:stretch>
-        </p:blipFill>
-        <p:spPr>
-          <a:xfrm>
-            <a:off x="9620250" y="3084393"/>
-            <a:ext cx="641958" cy="136765"/>
-          </a:xfrm>
-          <a:prstGeom prst="rect">
-            <a:avLst/>
-          </a:prstGeom>
-        </p:spPr>
-      </p:pic>
-      <p:pic>
-        <p:nvPicPr>
-          <p:cNvPr id="37" name="Picture 36" descr="xcmg.png"/>
+          <p:cNvPr id="38" name="Picture 37" descr="sany_palfinger.png"/>
           <p:cNvPicPr>
             <a:picLocks noChangeAspect="1"/>
           </p:cNvPicPr>
@@ -5491,8 +5904,8 @@
         </p:blipFill>
         <p:spPr>
           <a:xfrm>
-            <a:off x="10319356" y="3084393"/>
-            <a:ext cx="626405" cy="136765"/>
+            <a:off x="9620250" y="3084393"/>
+            <a:ext cx="641958" cy="136765"/>
           </a:xfrm>
           <a:prstGeom prst="rect">
             <a:avLst/>
@@ -5501,7 +5914,7 @@
       </p:pic>
       <p:pic>
         <p:nvPicPr>
-          <p:cNvPr id="38" name="Picture 37" descr="palfinger.png"/>
+          <p:cNvPr id="39" name="Picture 38" descr="xcmg.png"/>
           <p:cNvPicPr>
             <a:picLocks noChangeAspect="1"/>
           </p:cNvPicPr>
@@ -5515,17 +5928,41 @@
         </p:blipFill>
         <p:spPr>
           <a:xfrm>
-            <a:off x="11002909" y="3084393"/>
-            <a:ext cx="617593" cy="136765"/>
+            <a:off x="10319356" y="3084393"/>
+            <a:ext cx="626405" cy="136765"/>
           </a:xfrm>
           <a:prstGeom prst="rect">
             <a:avLst/>
           </a:prstGeom>
         </p:spPr>
       </p:pic>
-      <p:sp>
-        <p:nvSpPr>
-          <p:cNvPr id="39" name="TextBox 38"/>
+      <p:pic>
+        <p:nvPicPr>
+          <p:cNvPr id="40" name="Picture 39" descr="palfinger.png"/>
+          <p:cNvPicPr>
+            <a:picLocks noChangeAspect="1"/>
+          </p:cNvPicPr>
+          <p:nvPr/>
+        </p:nvPicPr>
+        <p:blipFill>
+          <a:blip r:embed="rId7"/>
+          <a:stretch>
+            <a:fillRect/>
+          </a:stretch>
+        </p:blipFill>
+        <p:spPr>
+          <a:xfrm>
+            <a:off x="11002909" y="3084393"/>
+            <a:ext cx="617593" cy="136765"/>
+          </a:xfrm>
+          <a:prstGeom prst="rect">
+            <a:avLst/>
+          </a:prstGeom>
+        </p:spPr>
+      </p:pic>
+      <p:sp>
+        <p:nvSpPr>
+          <p:cNvPr id="41" name="TextBox 40"/>
           <p:cNvSpPr txBox="1"/>
           <p:nvPr/>
         </p:nvSpPr>
@@ -5611,7 +6048,7 @@
       </p:sp>
       <p:sp>
         <p:nvSpPr>
-          <p:cNvPr id="40" name="Rectangle 39"/>
+          <p:cNvPr id="42" name="Rectangle 41"/>
           <p:cNvSpPr/>
           <p:nvPr/>
         </p:nvSpPr>
@@ -5656,7 +6093,7 @@
       </p:sp>
       <p:sp>
         <p:nvSpPr>
-          <p:cNvPr id="41" name="TextBox 40"/>
+          <p:cNvPr id="43" name="TextBox 42"/>
           <p:cNvSpPr txBox="1"/>
           <p:nvPr/>
         </p:nvSpPr>
@@ -5691,7 +6128,55 @@
       </p:sp>
       <p:pic>
         <p:nvPicPr>
-          <p:cNvPr id="42" name="Picture 41" descr="palfinger.png"/>
+          <p:cNvPr id="44" name="Picture 43" descr="palfinger.png"/>
+          <p:cNvPicPr>
+            <a:picLocks noChangeAspect="1"/>
+          </p:cNvPicPr>
+          <p:nvPr/>
+        </p:nvPicPr>
+        <p:blipFill>
+          <a:blip r:embed="rId7"/>
+          <a:stretch>
+            <a:fillRect/>
+          </a:stretch>
+        </p:blipFill>
+        <p:spPr>
+          <a:xfrm>
+            <a:off x="9620250" y="4492958"/>
+            <a:ext cx="627839" cy="139034"/>
+          </a:xfrm>
+          <a:prstGeom prst="rect">
+            <a:avLst/>
+          </a:prstGeom>
+        </p:spPr>
+      </p:pic>
+      <p:pic>
+        <p:nvPicPr>
+          <p:cNvPr id="45" name="Picture 44" descr="amco_veba.png"/>
+          <p:cNvPicPr>
+            <a:picLocks noChangeAspect="1"/>
+          </p:cNvPicPr>
+          <p:nvPr/>
+        </p:nvPicPr>
+        <p:blipFill>
+          <a:blip r:embed="rId8"/>
+          <a:stretch>
+            <a:fillRect/>
+          </a:stretch>
+        </p:blipFill>
+        <p:spPr>
+          <a:xfrm>
+            <a:off x="10305241" y="4492958"/>
+            <a:ext cx="621308" cy="139034"/>
+          </a:xfrm>
+          <a:prstGeom prst="rect">
+            <a:avLst/>
+          </a:prstGeom>
+        </p:spPr>
+      </p:pic>
+      <p:pic>
+        <p:nvPicPr>
+          <p:cNvPr id="46" name="Picture 45" descr="xcmg.png"/>
           <p:cNvPicPr>
             <a:picLocks noChangeAspect="1"/>
           </p:cNvPicPr>
@@ -5705,65 +6190,17 @@
         </p:blipFill>
         <p:spPr>
           <a:xfrm>
-            <a:off x="9620250" y="4492958"/>
-            <a:ext cx="627839" cy="139034"/>
+            <a:off x="10983701" y="4492958"/>
+            <a:ext cx="636797" cy="139034"/>
           </a:xfrm>
           <a:prstGeom prst="rect">
             <a:avLst/>
           </a:prstGeom>
         </p:spPr>
       </p:pic>
-      <p:pic>
-        <p:nvPicPr>
-          <p:cNvPr id="43" name="Picture 42" descr="amco_veba.png"/>
-          <p:cNvPicPr>
-            <a:picLocks noChangeAspect="1"/>
-          </p:cNvPicPr>
-          <p:nvPr/>
-        </p:nvPicPr>
-        <p:blipFill>
-          <a:blip r:embed="rId7"/>
-          <a:stretch>
-            <a:fillRect/>
-          </a:stretch>
-        </p:blipFill>
-        <p:spPr>
-          <a:xfrm>
-            <a:off x="10305241" y="4492958"/>
-            <a:ext cx="621308" cy="139034"/>
-          </a:xfrm>
-          <a:prstGeom prst="rect">
-            <a:avLst/>
-          </a:prstGeom>
-        </p:spPr>
-      </p:pic>
-      <p:pic>
-        <p:nvPicPr>
-          <p:cNvPr id="44" name="Picture 43" descr="xcmg.png"/>
-          <p:cNvPicPr>
-            <a:picLocks noChangeAspect="1"/>
-          </p:cNvPicPr>
-          <p:nvPr/>
-        </p:nvPicPr>
-        <p:blipFill>
-          <a:blip r:embed="rId5"/>
-          <a:stretch>
-            <a:fillRect/>
-          </a:stretch>
-        </p:blipFill>
-        <p:spPr>
-          <a:xfrm>
-            <a:off x="10983701" y="4492958"/>
-            <a:ext cx="636797" cy="139034"/>
-          </a:xfrm>
-          <a:prstGeom prst="rect">
-            <a:avLst/>
-          </a:prstGeom>
-        </p:spPr>
-      </p:pic>
-      <p:sp>
-        <p:nvSpPr>
-          <p:cNvPr id="45" name="TextBox 44"/>
+      <p:sp>
+        <p:nvSpPr>
+          <p:cNvPr id="47" name="TextBox 46"/>
           <p:cNvSpPr txBox="1"/>
           <p:nvPr/>
         </p:nvSpPr>
@@ -5849,7 +6286,7 @@
       </p:sp>
       <p:sp>
         <p:nvSpPr>
-          <p:cNvPr id="46" name="TextBox 45"/>
+          <p:cNvPr id="48" name="TextBox 47"/>
           <p:cNvSpPr txBox="1"/>
           <p:nvPr/>
         </p:nvSpPr>
@@ -5893,7 +6330,7 @@
       </p:sp>
       <p:sp>
         <p:nvSpPr>
-          <p:cNvPr id="47" name="TextBox 46"/>
+          <p:cNvPr id="49" name="TextBox 48"/>
           <p:cNvSpPr txBox="1"/>
           <p:nvPr/>
         </p:nvSpPr>
@@ -5937,7 +6374,7 @@
       </p:sp>
       <p:cxnSp>
         <p:nvCxnSpPr>
-          <p:cNvPr id="48" name="Connector 47"/>
+          <p:cNvPr id="50" name="Connector 49"/>
           <p:cNvCxnSpPr/>
           <p:nvPr/>
         </p:nvCxnSpPr>

</xml_diff>

<commit_message>
Add McKinsey-style braces (Pareto share and Others) to brand units and value charts
Co-Authored-By: Claude Opus 5.5 <noreply@anthropic.com>
Claude-Session: https://claude.ai/code/session_01Cx9kswyecF7JAB1Rr5vVcV
</commit_message>
<xml_diff>
--- a/nedp_deck/Slide_2025_Medium_Heavy_Funnel.pptx
+++ b/nedp_deck/Slide_2025_Medium_Heavy_Funnel.pptx
@@ -526,6 +526,17 @@
   <c:chart>
     <c:autoTitleDeleted val="0"/>
     <c:plotArea>
+      <c:layout>
+        <c:manualLayout>
+          <c:layoutTarget val="inner"/>
+          <c:xMode val="edge"/>
+          <c:yMode val="edge"/>
+          <c:x val="0.12"/>
+          <c:y val="0.17"/>
+          <c:w val="0.86"/>
+          <c:h val="0.66"/>
+        </c:manualLayout>
+      </c:layout>
       <c:barChart>
         <c:barDir val="bar"/>
         <c:grouping val="percentStacked"/>
@@ -1022,6 +1033,17 @@
   <c:chart>
     <c:autoTitleDeleted val="0"/>
     <c:plotArea>
+      <c:layout>
+        <c:manualLayout>
+          <c:layoutTarget val="inner"/>
+          <c:xMode val="edge"/>
+          <c:yMode val="edge"/>
+          <c:x val="0.12"/>
+          <c:y val="0.17"/>
+          <c:w val="0.86"/>
+          <c:h val="0.66"/>
+        </c:manualLayout>
+      </c:layout>
       <c:barChart>
         <c:barDir val="bar"/>
         <c:grouping val="percentStacked"/>
@@ -1060,7 +1082,7 @@
               <a:lstStyle/>
               <a:p>
                 <a:pPr>
-                  <a:defRPr sz="900" b="1">
+                  <a:defRPr sz="800" b="1">
                     <a:solidFill>
                       <a:srgbClr val="FFFFFF"/>
                     </a:solidFill>
@@ -1140,7 +1162,7 @@
               <a:lstStyle/>
               <a:p>
                 <a:pPr>
-                  <a:defRPr sz="900" b="1">
+                  <a:defRPr sz="800" b="1">
                     <a:solidFill>
                       <a:srgbClr val="FFFFFF"/>
                     </a:solidFill>
@@ -1224,7 +1246,7 @@
               <a:lstStyle/>
               <a:p>
                 <a:pPr>
-                  <a:defRPr sz="900" b="1">
+                  <a:defRPr sz="800" b="1">
                     <a:solidFill>
                       <a:srgbClr val="000000"/>
                     </a:solidFill>
@@ -1304,7 +1326,7 @@
               <a:lstStyle/>
               <a:p>
                 <a:pPr>
-                  <a:defRPr sz="900" b="1">
+                  <a:defRPr sz="800" b="1">
                     <a:solidFill>
                       <a:srgbClr val="000000"/>
                     </a:solidFill>
@@ -1384,7 +1406,7 @@
               <a:lstStyle/>
               <a:p>
                 <a:pPr>
-                  <a:defRPr sz="900" b="1">
+                  <a:defRPr sz="800" b="1">
                     <a:solidFill>
                       <a:srgbClr val="000000"/>
                     </a:solidFill>
@@ -5808,9 +5830,1409 @@
           </a:graphicData>
         </a:graphic>
       </p:graphicFrame>
-      <p:sp>
-        <p:nvSpPr>
-          <p:cNvPr id="36" name="Rectangle 35"/>
+      <p:cxnSp>
+        <p:nvCxnSpPr>
+          <p:cNvPr id="36" name="Connector 35"/>
+          <p:cNvCxnSpPr/>
+          <p:nvPr/>
+        </p:nvCxnSpPr>
+        <p:spPr>
+          <a:xfrm>
+            <a:off x="4996815" y="2832245"/>
+            <a:ext cx="3526504" cy="0"/>
+          </a:xfrm>
+          <a:prstGeom prst="line">
+            <a:avLst/>
+          </a:prstGeom>
+          <a:ln w="12700">
+            <a:solidFill>
+              <a:srgbClr val="1E9E57"/>
+            </a:solidFill>
+          </a:ln>
+        </p:spPr>
+        <p:style>
+          <a:lnRef idx="2">
+            <a:schemeClr val="accent1"/>
+          </a:lnRef>
+          <a:fillRef idx="0">
+            <a:schemeClr val="accent1"/>
+          </a:fillRef>
+          <a:effectRef idx="1">
+            <a:schemeClr val="accent1"/>
+          </a:effectRef>
+          <a:fontRef idx="minor">
+            <a:schemeClr val="tx1"/>
+          </a:fontRef>
+        </p:style>
+      </p:cxnSp>
+      <p:cxnSp>
+        <p:nvCxnSpPr>
+          <p:cNvPr id="37" name="Connector 36"/>
+          <p:cNvCxnSpPr/>
+          <p:nvPr/>
+        </p:nvCxnSpPr>
+        <p:spPr>
+          <a:xfrm>
+            <a:off x="4996815" y="2832245"/>
+            <a:ext cx="0" cy="47625"/>
+          </a:xfrm>
+          <a:prstGeom prst="line">
+            <a:avLst/>
+          </a:prstGeom>
+          <a:ln w="12700">
+            <a:solidFill>
+              <a:srgbClr val="1E9E57"/>
+            </a:solidFill>
+          </a:ln>
+        </p:spPr>
+        <p:style>
+          <a:lnRef idx="2">
+            <a:schemeClr val="accent1"/>
+          </a:lnRef>
+          <a:fillRef idx="0">
+            <a:schemeClr val="accent1"/>
+          </a:fillRef>
+          <a:effectRef idx="1">
+            <a:schemeClr val="accent1"/>
+          </a:effectRef>
+          <a:fontRef idx="minor">
+            <a:schemeClr val="tx1"/>
+          </a:fontRef>
+        </p:style>
+      </p:cxnSp>
+      <p:cxnSp>
+        <p:nvCxnSpPr>
+          <p:cNvPr id="38" name="Connector 37"/>
+          <p:cNvCxnSpPr/>
+          <p:nvPr/>
+        </p:nvCxnSpPr>
+        <p:spPr>
+          <a:xfrm>
+            <a:off x="8523319" y="2832245"/>
+            <a:ext cx="0" cy="47625"/>
+          </a:xfrm>
+          <a:prstGeom prst="line">
+            <a:avLst/>
+          </a:prstGeom>
+          <a:ln w="12700">
+            <a:solidFill>
+              <a:srgbClr val="1E9E57"/>
+            </a:solidFill>
+          </a:ln>
+        </p:spPr>
+        <p:style>
+          <a:lnRef idx="2">
+            <a:schemeClr val="accent1"/>
+          </a:lnRef>
+          <a:fillRef idx="0">
+            <a:schemeClr val="accent1"/>
+          </a:fillRef>
+          <a:effectRef idx="1">
+            <a:schemeClr val="accent1"/>
+          </a:effectRef>
+          <a:fontRef idx="minor">
+            <a:schemeClr val="tx1"/>
+          </a:fontRef>
+        </p:style>
+      </p:cxnSp>
+      <p:cxnSp>
+        <p:nvCxnSpPr>
+          <p:cNvPr id="39" name="Connector 38"/>
+          <p:cNvCxnSpPr/>
+          <p:nvPr/>
+        </p:nvCxnSpPr>
+        <p:spPr>
+          <a:xfrm flipV="1">
+            <a:off x="6760067" y="2784620"/>
+            <a:ext cx="0" cy="47625"/>
+          </a:xfrm>
+          <a:prstGeom prst="line">
+            <a:avLst/>
+          </a:prstGeom>
+          <a:ln w="12700">
+            <a:solidFill>
+              <a:srgbClr val="1E9E57"/>
+            </a:solidFill>
+          </a:ln>
+        </p:spPr>
+        <p:style>
+          <a:lnRef idx="2">
+            <a:schemeClr val="accent1"/>
+          </a:lnRef>
+          <a:fillRef idx="0">
+            <a:schemeClr val="accent1"/>
+          </a:fillRef>
+          <a:effectRef idx="1">
+            <a:schemeClr val="accent1"/>
+          </a:effectRef>
+          <a:fontRef idx="minor">
+            <a:schemeClr val="tx1"/>
+          </a:fontRef>
+        </p:style>
+      </p:cxnSp>
+      <p:sp>
+        <p:nvSpPr>
+          <p:cNvPr id="40" name="TextBox 39"/>
+          <p:cNvSpPr txBox="1"/>
+          <p:nvPr/>
+        </p:nvSpPr>
+        <p:spPr>
+          <a:xfrm>
+            <a:off x="5712317" y="2651270"/>
+            <a:ext cx="2095500" cy="123825"/>
+          </a:xfrm>
+          <a:prstGeom prst="rect">
+            <a:avLst/>
+          </a:prstGeom>
+          <a:noFill/>
+        </p:spPr>
+        <p:txBody>
+          <a:bodyPr wrap="square" anchor="t" lIns="0" rIns="0" tIns="0" bIns="0">
+            <a:spAutoFit/>
+          </a:bodyPr>
+          <a:lstStyle/>
+          <a:p>
+            <a:pPr algn="ctr"/>
+            <a:r>
+              <a:rPr sz="900" b="1">
+                <a:solidFill>
+                  <a:srgbClr val="1E9E57"/>
+                </a:solidFill>
+                <a:latin typeface="Neue Haas Grotesk Text Pro"/>
+              </a:rPr>
+              <a:t>3 brands = 82% of units</a:t>
+            </a:r>
+          </a:p>
+        </p:txBody>
+      </p:sp>
+      <p:cxnSp>
+        <p:nvCxnSpPr>
+          <p:cNvPr id="41" name="Connector 40"/>
+          <p:cNvCxnSpPr/>
+          <p:nvPr/>
+        </p:nvCxnSpPr>
+        <p:spPr>
+          <a:xfrm>
+            <a:off x="8542369" y="2832245"/>
+            <a:ext cx="776891" cy="0"/>
+          </a:xfrm>
+          <a:prstGeom prst="line">
+            <a:avLst/>
+          </a:prstGeom>
+          <a:ln w="12700">
+            <a:solidFill>
+              <a:srgbClr val="6B6B6B"/>
+            </a:solidFill>
+          </a:ln>
+        </p:spPr>
+        <p:style>
+          <a:lnRef idx="2">
+            <a:schemeClr val="accent1"/>
+          </a:lnRef>
+          <a:fillRef idx="0">
+            <a:schemeClr val="accent1"/>
+          </a:fillRef>
+          <a:effectRef idx="1">
+            <a:schemeClr val="accent1"/>
+          </a:effectRef>
+          <a:fontRef idx="minor">
+            <a:schemeClr val="tx1"/>
+          </a:fontRef>
+        </p:style>
+      </p:cxnSp>
+      <p:cxnSp>
+        <p:nvCxnSpPr>
+          <p:cNvPr id="42" name="Connector 41"/>
+          <p:cNvCxnSpPr/>
+          <p:nvPr/>
+        </p:nvCxnSpPr>
+        <p:spPr>
+          <a:xfrm>
+            <a:off x="8542369" y="2832245"/>
+            <a:ext cx="0" cy="47625"/>
+          </a:xfrm>
+          <a:prstGeom prst="line">
+            <a:avLst/>
+          </a:prstGeom>
+          <a:ln w="12700">
+            <a:solidFill>
+              <a:srgbClr val="6B6B6B"/>
+            </a:solidFill>
+          </a:ln>
+        </p:spPr>
+        <p:style>
+          <a:lnRef idx="2">
+            <a:schemeClr val="accent1"/>
+          </a:lnRef>
+          <a:fillRef idx="0">
+            <a:schemeClr val="accent1"/>
+          </a:fillRef>
+          <a:effectRef idx="1">
+            <a:schemeClr val="accent1"/>
+          </a:effectRef>
+          <a:fontRef idx="minor">
+            <a:schemeClr val="tx1"/>
+          </a:fontRef>
+        </p:style>
+      </p:cxnSp>
+      <p:cxnSp>
+        <p:nvCxnSpPr>
+          <p:cNvPr id="43" name="Connector 42"/>
+          <p:cNvCxnSpPr/>
+          <p:nvPr/>
+        </p:nvCxnSpPr>
+        <p:spPr>
+          <a:xfrm>
+            <a:off x="9319260" y="2832245"/>
+            <a:ext cx="0" cy="47625"/>
+          </a:xfrm>
+          <a:prstGeom prst="line">
+            <a:avLst/>
+          </a:prstGeom>
+          <a:ln w="12700">
+            <a:solidFill>
+              <a:srgbClr val="6B6B6B"/>
+            </a:solidFill>
+          </a:ln>
+        </p:spPr>
+        <p:style>
+          <a:lnRef idx="2">
+            <a:schemeClr val="accent1"/>
+          </a:lnRef>
+          <a:fillRef idx="0">
+            <a:schemeClr val="accent1"/>
+          </a:fillRef>
+          <a:effectRef idx="1">
+            <a:schemeClr val="accent1"/>
+          </a:effectRef>
+          <a:fontRef idx="minor">
+            <a:schemeClr val="tx1"/>
+          </a:fontRef>
+        </p:style>
+      </p:cxnSp>
+      <p:cxnSp>
+        <p:nvCxnSpPr>
+          <p:cNvPr id="44" name="Connector 43"/>
+          <p:cNvCxnSpPr/>
+          <p:nvPr/>
+        </p:nvCxnSpPr>
+        <p:spPr>
+          <a:xfrm flipV="1">
+            <a:off x="8930815" y="2784620"/>
+            <a:ext cx="0" cy="47625"/>
+          </a:xfrm>
+          <a:prstGeom prst="line">
+            <a:avLst/>
+          </a:prstGeom>
+          <a:ln w="12700">
+            <a:solidFill>
+              <a:srgbClr val="6B6B6B"/>
+            </a:solidFill>
+          </a:ln>
+        </p:spPr>
+        <p:style>
+          <a:lnRef idx="2">
+            <a:schemeClr val="accent1"/>
+          </a:lnRef>
+          <a:fillRef idx="0">
+            <a:schemeClr val="accent1"/>
+          </a:fillRef>
+          <a:effectRef idx="1">
+            <a:schemeClr val="accent1"/>
+          </a:effectRef>
+          <a:fontRef idx="minor">
+            <a:schemeClr val="tx1"/>
+          </a:fontRef>
+        </p:style>
+      </p:cxnSp>
+      <p:sp>
+        <p:nvSpPr>
+          <p:cNvPr id="45" name="TextBox 44"/>
+          <p:cNvSpPr txBox="1"/>
+          <p:nvPr/>
+        </p:nvSpPr>
+        <p:spPr>
+          <a:xfrm>
+            <a:off x="7883065" y="2651270"/>
+            <a:ext cx="2095500" cy="123825"/>
+          </a:xfrm>
+          <a:prstGeom prst="rect">
+            <a:avLst/>
+          </a:prstGeom>
+          <a:noFill/>
+        </p:spPr>
+        <p:txBody>
+          <a:bodyPr wrap="square" anchor="t" lIns="0" rIns="0" tIns="0" bIns="0">
+            <a:spAutoFit/>
+          </a:bodyPr>
+          <a:lstStyle/>
+          <a:p>
+            <a:pPr algn="ctr"/>
+            <a:r>
+              <a:rPr sz="900" b="1">
+                <a:solidFill>
+                  <a:srgbClr val="6B6B6B"/>
+                </a:solidFill>
+                <a:latin typeface="Neue Haas Grotesk Text Pro"/>
+              </a:rPr>
+              <a:t>Others 18%</a:t>
+            </a:r>
+          </a:p>
+        </p:txBody>
+      </p:sp>
+      <p:cxnSp>
+        <p:nvCxnSpPr>
+          <p:cNvPr id="46" name="Connector 45"/>
+          <p:cNvCxnSpPr/>
+          <p:nvPr/>
+        </p:nvCxnSpPr>
+        <p:spPr>
+          <a:xfrm>
+            <a:off x="4996815" y="3873355"/>
+            <a:ext cx="3654523" cy="0"/>
+          </a:xfrm>
+          <a:prstGeom prst="line">
+            <a:avLst/>
+          </a:prstGeom>
+          <a:ln w="12700">
+            <a:solidFill>
+              <a:srgbClr val="1E9E57"/>
+            </a:solidFill>
+          </a:ln>
+        </p:spPr>
+        <p:style>
+          <a:lnRef idx="2">
+            <a:schemeClr val="accent1"/>
+          </a:lnRef>
+          <a:fillRef idx="0">
+            <a:schemeClr val="accent1"/>
+          </a:fillRef>
+          <a:effectRef idx="1">
+            <a:schemeClr val="accent1"/>
+          </a:effectRef>
+          <a:fontRef idx="minor">
+            <a:schemeClr val="tx1"/>
+          </a:fontRef>
+        </p:style>
+      </p:cxnSp>
+      <p:cxnSp>
+        <p:nvCxnSpPr>
+          <p:cNvPr id="47" name="Connector 46"/>
+          <p:cNvCxnSpPr/>
+          <p:nvPr/>
+        </p:nvCxnSpPr>
+        <p:spPr>
+          <a:xfrm flipV="1">
+            <a:off x="4996815" y="3825730"/>
+            <a:ext cx="0" cy="47625"/>
+          </a:xfrm>
+          <a:prstGeom prst="line">
+            <a:avLst/>
+          </a:prstGeom>
+          <a:ln w="12700">
+            <a:solidFill>
+              <a:srgbClr val="1E9E57"/>
+            </a:solidFill>
+          </a:ln>
+        </p:spPr>
+        <p:style>
+          <a:lnRef idx="2">
+            <a:schemeClr val="accent1"/>
+          </a:lnRef>
+          <a:fillRef idx="0">
+            <a:schemeClr val="accent1"/>
+          </a:fillRef>
+          <a:effectRef idx="1">
+            <a:schemeClr val="accent1"/>
+          </a:effectRef>
+          <a:fontRef idx="minor">
+            <a:schemeClr val="tx1"/>
+          </a:fontRef>
+        </p:style>
+      </p:cxnSp>
+      <p:cxnSp>
+        <p:nvCxnSpPr>
+          <p:cNvPr id="48" name="Connector 47"/>
+          <p:cNvCxnSpPr/>
+          <p:nvPr/>
+        </p:nvCxnSpPr>
+        <p:spPr>
+          <a:xfrm flipV="1">
+            <a:off x="8651338" y="3825730"/>
+            <a:ext cx="0" cy="47625"/>
+          </a:xfrm>
+          <a:prstGeom prst="line">
+            <a:avLst/>
+          </a:prstGeom>
+          <a:ln w="12700">
+            <a:solidFill>
+              <a:srgbClr val="1E9E57"/>
+            </a:solidFill>
+          </a:ln>
+        </p:spPr>
+        <p:style>
+          <a:lnRef idx="2">
+            <a:schemeClr val="accent1"/>
+          </a:lnRef>
+          <a:fillRef idx="0">
+            <a:schemeClr val="accent1"/>
+          </a:fillRef>
+          <a:effectRef idx="1">
+            <a:schemeClr val="accent1"/>
+          </a:effectRef>
+          <a:fontRef idx="minor">
+            <a:schemeClr val="tx1"/>
+          </a:fontRef>
+        </p:style>
+      </p:cxnSp>
+      <p:cxnSp>
+        <p:nvCxnSpPr>
+          <p:cNvPr id="49" name="Connector 48"/>
+          <p:cNvCxnSpPr/>
+          <p:nvPr/>
+        </p:nvCxnSpPr>
+        <p:spPr>
+          <a:xfrm>
+            <a:off x="6824076" y="3873355"/>
+            <a:ext cx="0" cy="47625"/>
+          </a:xfrm>
+          <a:prstGeom prst="line">
+            <a:avLst/>
+          </a:prstGeom>
+          <a:ln w="12700">
+            <a:solidFill>
+              <a:srgbClr val="1E9E57"/>
+            </a:solidFill>
+          </a:ln>
+        </p:spPr>
+        <p:style>
+          <a:lnRef idx="2">
+            <a:schemeClr val="accent1"/>
+          </a:lnRef>
+          <a:fillRef idx="0">
+            <a:schemeClr val="accent1"/>
+          </a:fillRef>
+          <a:effectRef idx="1">
+            <a:schemeClr val="accent1"/>
+          </a:effectRef>
+          <a:fontRef idx="minor">
+            <a:schemeClr val="tx1"/>
+          </a:fontRef>
+        </p:style>
+      </p:cxnSp>
+      <p:sp>
+        <p:nvSpPr>
+          <p:cNvPr id="50" name="TextBox 49"/>
+          <p:cNvSpPr txBox="1"/>
+          <p:nvPr/>
+        </p:nvSpPr>
+        <p:spPr>
+          <a:xfrm>
+            <a:off x="5776326" y="3930505"/>
+            <a:ext cx="2095500" cy="123825"/>
+          </a:xfrm>
+          <a:prstGeom prst="rect">
+            <a:avLst/>
+          </a:prstGeom>
+          <a:noFill/>
+        </p:spPr>
+        <p:txBody>
+          <a:bodyPr wrap="square" anchor="t" lIns="0" rIns="0" tIns="0" bIns="0">
+            <a:spAutoFit/>
+          </a:bodyPr>
+          <a:lstStyle/>
+          <a:p>
+            <a:pPr algn="ctr"/>
+            <a:r>
+              <a:rPr sz="900" b="1">
+                <a:solidFill>
+                  <a:srgbClr val="1E9E57"/>
+                </a:solidFill>
+                <a:latin typeface="Neue Haas Grotesk Text Pro"/>
+              </a:rPr>
+              <a:t>3 brands = 85% of units</a:t>
+            </a:r>
+          </a:p>
+        </p:txBody>
+      </p:sp>
+      <p:cxnSp>
+        <p:nvCxnSpPr>
+          <p:cNvPr id="51" name="Connector 50"/>
+          <p:cNvCxnSpPr/>
+          <p:nvPr/>
+        </p:nvCxnSpPr>
+        <p:spPr>
+          <a:xfrm>
+            <a:off x="8670388" y="3873355"/>
+            <a:ext cx="648872" cy="0"/>
+          </a:xfrm>
+          <a:prstGeom prst="line">
+            <a:avLst/>
+          </a:prstGeom>
+          <a:ln w="12700">
+            <a:solidFill>
+              <a:srgbClr val="6B6B6B"/>
+            </a:solidFill>
+          </a:ln>
+        </p:spPr>
+        <p:style>
+          <a:lnRef idx="2">
+            <a:schemeClr val="accent1"/>
+          </a:lnRef>
+          <a:fillRef idx="0">
+            <a:schemeClr val="accent1"/>
+          </a:fillRef>
+          <a:effectRef idx="1">
+            <a:schemeClr val="accent1"/>
+          </a:effectRef>
+          <a:fontRef idx="minor">
+            <a:schemeClr val="tx1"/>
+          </a:fontRef>
+        </p:style>
+      </p:cxnSp>
+      <p:cxnSp>
+        <p:nvCxnSpPr>
+          <p:cNvPr id="52" name="Connector 51"/>
+          <p:cNvCxnSpPr/>
+          <p:nvPr/>
+        </p:nvCxnSpPr>
+        <p:spPr>
+          <a:xfrm flipV="1">
+            <a:off x="8670388" y="3825730"/>
+            <a:ext cx="0" cy="47625"/>
+          </a:xfrm>
+          <a:prstGeom prst="line">
+            <a:avLst/>
+          </a:prstGeom>
+          <a:ln w="12700">
+            <a:solidFill>
+              <a:srgbClr val="6B6B6B"/>
+            </a:solidFill>
+          </a:ln>
+        </p:spPr>
+        <p:style>
+          <a:lnRef idx="2">
+            <a:schemeClr val="accent1"/>
+          </a:lnRef>
+          <a:fillRef idx="0">
+            <a:schemeClr val="accent1"/>
+          </a:fillRef>
+          <a:effectRef idx="1">
+            <a:schemeClr val="accent1"/>
+          </a:effectRef>
+          <a:fontRef idx="minor">
+            <a:schemeClr val="tx1"/>
+          </a:fontRef>
+        </p:style>
+      </p:cxnSp>
+      <p:cxnSp>
+        <p:nvCxnSpPr>
+          <p:cNvPr id="53" name="Connector 52"/>
+          <p:cNvCxnSpPr/>
+          <p:nvPr/>
+        </p:nvCxnSpPr>
+        <p:spPr>
+          <a:xfrm flipV="1">
+            <a:off x="9319260" y="3825730"/>
+            <a:ext cx="0" cy="47625"/>
+          </a:xfrm>
+          <a:prstGeom prst="line">
+            <a:avLst/>
+          </a:prstGeom>
+          <a:ln w="12700">
+            <a:solidFill>
+              <a:srgbClr val="6B6B6B"/>
+            </a:solidFill>
+          </a:ln>
+        </p:spPr>
+        <p:style>
+          <a:lnRef idx="2">
+            <a:schemeClr val="accent1"/>
+          </a:lnRef>
+          <a:fillRef idx="0">
+            <a:schemeClr val="accent1"/>
+          </a:fillRef>
+          <a:effectRef idx="1">
+            <a:schemeClr val="accent1"/>
+          </a:effectRef>
+          <a:fontRef idx="minor">
+            <a:schemeClr val="tx1"/>
+          </a:fontRef>
+        </p:style>
+      </p:cxnSp>
+      <p:cxnSp>
+        <p:nvCxnSpPr>
+          <p:cNvPr id="54" name="Connector 53"/>
+          <p:cNvCxnSpPr/>
+          <p:nvPr/>
+        </p:nvCxnSpPr>
+        <p:spPr>
+          <a:xfrm>
+            <a:off x="8994824" y="3873355"/>
+            <a:ext cx="0" cy="47625"/>
+          </a:xfrm>
+          <a:prstGeom prst="line">
+            <a:avLst/>
+          </a:prstGeom>
+          <a:ln w="12700">
+            <a:solidFill>
+              <a:srgbClr val="6B6B6B"/>
+            </a:solidFill>
+          </a:ln>
+        </p:spPr>
+        <p:style>
+          <a:lnRef idx="2">
+            <a:schemeClr val="accent1"/>
+          </a:lnRef>
+          <a:fillRef idx="0">
+            <a:schemeClr val="accent1"/>
+          </a:fillRef>
+          <a:effectRef idx="1">
+            <a:schemeClr val="accent1"/>
+          </a:effectRef>
+          <a:fontRef idx="minor">
+            <a:schemeClr val="tx1"/>
+          </a:fontRef>
+        </p:style>
+      </p:cxnSp>
+      <p:sp>
+        <p:nvSpPr>
+          <p:cNvPr id="55" name="TextBox 54"/>
+          <p:cNvSpPr txBox="1"/>
+          <p:nvPr/>
+        </p:nvSpPr>
+        <p:spPr>
+          <a:xfrm>
+            <a:off x="7947074" y="3930505"/>
+            <a:ext cx="2095500" cy="123825"/>
+          </a:xfrm>
+          <a:prstGeom prst="rect">
+            <a:avLst/>
+          </a:prstGeom>
+          <a:noFill/>
+        </p:spPr>
+        <p:txBody>
+          <a:bodyPr wrap="square" anchor="t" lIns="0" rIns="0" tIns="0" bIns="0">
+            <a:spAutoFit/>
+          </a:bodyPr>
+          <a:lstStyle/>
+          <a:p>
+            <a:pPr algn="ctr"/>
+            <a:r>
+              <a:rPr sz="900" b="1">
+                <a:solidFill>
+                  <a:srgbClr val="6B6B6B"/>
+                </a:solidFill>
+                <a:latin typeface="Neue Haas Grotesk Text Pro"/>
+              </a:rPr>
+              <a:t>Others 15%</a:t>
+            </a:r>
+          </a:p>
+        </p:txBody>
+      </p:sp>
+      <p:cxnSp>
+        <p:nvCxnSpPr>
+          <p:cNvPr id="56" name="Connector 55"/>
+          <p:cNvCxnSpPr/>
+          <p:nvPr/>
+        </p:nvCxnSpPr>
+        <p:spPr>
+          <a:xfrm>
+            <a:off x="4996815" y="4776978"/>
+            <a:ext cx="3486525" cy="0"/>
+          </a:xfrm>
+          <a:prstGeom prst="line">
+            <a:avLst/>
+          </a:prstGeom>
+          <a:ln w="12700">
+            <a:solidFill>
+              <a:srgbClr val="1E9E57"/>
+            </a:solidFill>
+          </a:ln>
+        </p:spPr>
+        <p:style>
+          <a:lnRef idx="2">
+            <a:schemeClr val="accent1"/>
+          </a:lnRef>
+          <a:fillRef idx="0">
+            <a:schemeClr val="accent1"/>
+          </a:fillRef>
+          <a:effectRef idx="1">
+            <a:schemeClr val="accent1"/>
+          </a:effectRef>
+          <a:fontRef idx="minor">
+            <a:schemeClr val="tx1"/>
+          </a:fontRef>
+        </p:style>
+      </p:cxnSp>
+      <p:cxnSp>
+        <p:nvCxnSpPr>
+          <p:cNvPr id="57" name="Connector 56"/>
+          <p:cNvCxnSpPr/>
+          <p:nvPr/>
+        </p:nvCxnSpPr>
+        <p:spPr>
+          <a:xfrm>
+            <a:off x="4996815" y="4776978"/>
+            <a:ext cx="0" cy="47625"/>
+          </a:xfrm>
+          <a:prstGeom prst="line">
+            <a:avLst/>
+          </a:prstGeom>
+          <a:ln w="12700">
+            <a:solidFill>
+              <a:srgbClr val="1E9E57"/>
+            </a:solidFill>
+          </a:ln>
+        </p:spPr>
+        <p:style>
+          <a:lnRef idx="2">
+            <a:schemeClr val="accent1"/>
+          </a:lnRef>
+          <a:fillRef idx="0">
+            <a:schemeClr val="accent1"/>
+          </a:fillRef>
+          <a:effectRef idx="1">
+            <a:schemeClr val="accent1"/>
+          </a:effectRef>
+          <a:fontRef idx="minor">
+            <a:schemeClr val="tx1"/>
+          </a:fontRef>
+        </p:style>
+      </p:cxnSp>
+      <p:cxnSp>
+        <p:nvCxnSpPr>
+          <p:cNvPr id="58" name="Connector 57"/>
+          <p:cNvCxnSpPr/>
+          <p:nvPr/>
+        </p:nvCxnSpPr>
+        <p:spPr>
+          <a:xfrm>
+            <a:off x="8483340" y="4776978"/>
+            <a:ext cx="0" cy="47625"/>
+          </a:xfrm>
+          <a:prstGeom prst="line">
+            <a:avLst/>
+          </a:prstGeom>
+          <a:ln w="12700">
+            <a:solidFill>
+              <a:srgbClr val="1E9E57"/>
+            </a:solidFill>
+          </a:ln>
+        </p:spPr>
+        <p:style>
+          <a:lnRef idx="2">
+            <a:schemeClr val="accent1"/>
+          </a:lnRef>
+          <a:fillRef idx="0">
+            <a:schemeClr val="accent1"/>
+          </a:fillRef>
+          <a:effectRef idx="1">
+            <a:schemeClr val="accent1"/>
+          </a:effectRef>
+          <a:fontRef idx="minor">
+            <a:schemeClr val="tx1"/>
+          </a:fontRef>
+        </p:style>
+      </p:cxnSp>
+      <p:cxnSp>
+        <p:nvCxnSpPr>
+          <p:cNvPr id="59" name="Connector 58"/>
+          <p:cNvCxnSpPr/>
+          <p:nvPr/>
+        </p:nvCxnSpPr>
+        <p:spPr>
+          <a:xfrm flipV="1">
+            <a:off x="6740077" y="4729353"/>
+            <a:ext cx="0" cy="47625"/>
+          </a:xfrm>
+          <a:prstGeom prst="line">
+            <a:avLst/>
+          </a:prstGeom>
+          <a:ln w="12700">
+            <a:solidFill>
+              <a:srgbClr val="1E9E57"/>
+            </a:solidFill>
+          </a:ln>
+        </p:spPr>
+        <p:style>
+          <a:lnRef idx="2">
+            <a:schemeClr val="accent1"/>
+          </a:lnRef>
+          <a:fillRef idx="0">
+            <a:schemeClr val="accent1"/>
+          </a:fillRef>
+          <a:effectRef idx="1">
+            <a:schemeClr val="accent1"/>
+          </a:effectRef>
+          <a:fontRef idx="minor">
+            <a:schemeClr val="tx1"/>
+          </a:fontRef>
+        </p:style>
+      </p:cxnSp>
+      <p:sp>
+        <p:nvSpPr>
+          <p:cNvPr id="60" name="TextBox 59"/>
+          <p:cNvSpPr txBox="1"/>
+          <p:nvPr/>
+        </p:nvSpPr>
+        <p:spPr>
+          <a:xfrm>
+            <a:off x="5692327" y="4596003"/>
+            <a:ext cx="2095500" cy="123825"/>
+          </a:xfrm>
+          <a:prstGeom prst="rect">
+            <a:avLst/>
+          </a:prstGeom>
+          <a:noFill/>
+        </p:spPr>
+        <p:txBody>
+          <a:bodyPr wrap="square" anchor="t" lIns="0" rIns="0" tIns="0" bIns="0">
+            <a:spAutoFit/>
+          </a:bodyPr>
+          <a:lstStyle/>
+          <a:p>
+            <a:pPr algn="ctr"/>
+            <a:r>
+              <a:rPr sz="900" b="1">
+                <a:solidFill>
+                  <a:srgbClr val="1E9E57"/>
+                </a:solidFill>
+                <a:latin typeface="Neue Haas Grotesk Text Pro"/>
+              </a:rPr>
+              <a:t>3 brands = 81% of value</a:t>
+            </a:r>
+          </a:p>
+        </p:txBody>
+      </p:sp>
+      <p:cxnSp>
+        <p:nvCxnSpPr>
+          <p:cNvPr id="61" name="Connector 60"/>
+          <p:cNvCxnSpPr/>
+          <p:nvPr/>
+        </p:nvCxnSpPr>
+        <p:spPr>
+          <a:xfrm>
+            <a:off x="8502390" y="4776978"/>
+            <a:ext cx="816870" cy="0"/>
+          </a:xfrm>
+          <a:prstGeom prst="line">
+            <a:avLst/>
+          </a:prstGeom>
+          <a:ln w="12700">
+            <a:solidFill>
+              <a:srgbClr val="6B6B6B"/>
+            </a:solidFill>
+          </a:ln>
+        </p:spPr>
+        <p:style>
+          <a:lnRef idx="2">
+            <a:schemeClr val="accent1"/>
+          </a:lnRef>
+          <a:fillRef idx="0">
+            <a:schemeClr val="accent1"/>
+          </a:fillRef>
+          <a:effectRef idx="1">
+            <a:schemeClr val="accent1"/>
+          </a:effectRef>
+          <a:fontRef idx="minor">
+            <a:schemeClr val="tx1"/>
+          </a:fontRef>
+        </p:style>
+      </p:cxnSp>
+      <p:cxnSp>
+        <p:nvCxnSpPr>
+          <p:cNvPr id="62" name="Connector 61"/>
+          <p:cNvCxnSpPr/>
+          <p:nvPr/>
+        </p:nvCxnSpPr>
+        <p:spPr>
+          <a:xfrm>
+            <a:off x="8502390" y="4776978"/>
+            <a:ext cx="0" cy="47625"/>
+          </a:xfrm>
+          <a:prstGeom prst="line">
+            <a:avLst/>
+          </a:prstGeom>
+          <a:ln w="12700">
+            <a:solidFill>
+              <a:srgbClr val="6B6B6B"/>
+            </a:solidFill>
+          </a:ln>
+        </p:spPr>
+        <p:style>
+          <a:lnRef idx="2">
+            <a:schemeClr val="accent1"/>
+          </a:lnRef>
+          <a:fillRef idx="0">
+            <a:schemeClr val="accent1"/>
+          </a:fillRef>
+          <a:effectRef idx="1">
+            <a:schemeClr val="accent1"/>
+          </a:effectRef>
+          <a:fontRef idx="minor">
+            <a:schemeClr val="tx1"/>
+          </a:fontRef>
+        </p:style>
+      </p:cxnSp>
+      <p:cxnSp>
+        <p:nvCxnSpPr>
+          <p:cNvPr id="63" name="Connector 62"/>
+          <p:cNvCxnSpPr/>
+          <p:nvPr/>
+        </p:nvCxnSpPr>
+        <p:spPr>
+          <a:xfrm>
+            <a:off x="9319260" y="4776978"/>
+            <a:ext cx="0" cy="47625"/>
+          </a:xfrm>
+          <a:prstGeom prst="line">
+            <a:avLst/>
+          </a:prstGeom>
+          <a:ln w="12700">
+            <a:solidFill>
+              <a:srgbClr val="6B6B6B"/>
+            </a:solidFill>
+          </a:ln>
+        </p:spPr>
+        <p:style>
+          <a:lnRef idx="2">
+            <a:schemeClr val="accent1"/>
+          </a:lnRef>
+          <a:fillRef idx="0">
+            <a:schemeClr val="accent1"/>
+          </a:fillRef>
+          <a:effectRef idx="1">
+            <a:schemeClr val="accent1"/>
+          </a:effectRef>
+          <a:fontRef idx="minor">
+            <a:schemeClr val="tx1"/>
+          </a:fontRef>
+        </p:style>
+      </p:cxnSp>
+      <p:cxnSp>
+        <p:nvCxnSpPr>
+          <p:cNvPr id="64" name="Connector 63"/>
+          <p:cNvCxnSpPr/>
+          <p:nvPr/>
+        </p:nvCxnSpPr>
+        <p:spPr>
+          <a:xfrm flipV="1">
+            <a:off x="8910825" y="4729353"/>
+            <a:ext cx="0" cy="47625"/>
+          </a:xfrm>
+          <a:prstGeom prst="line">
+            <a:avLst/>
+          </a:prstGeom>
+          <a:ln w="12700">
+            <a:solidFill>
+              <a:srgbClr val="6B6B6B"/>
+            </a:solidFill>
+          </a:ln>
+        </p:spPr>
+        <p:style>
+          <a:lnRef idx="2">
+            <a:schemeClr val="accent1"/>
+          </a:lnRef>
+          <a:fillRef idx="0">
+            <a:schemeClr val="accent1"/>
+          </a:fillRef>
+          <a:effectRef idx="1">
+            <a:schemeClr val="accent1"/>
+          </a:effectRef>
+          <a:fontRef idx="minor">
+            <a:schemeClr val="tx1"/>
+          </a:fontRef>
+        </p:style>
+      </p:cxnSp>
+      <p:sp>
+        <p:nvSpPr>
+          <p:cNvPr id="65" name="TextBox 64"/>
+          <p:cNvSpPr txBox="1"/>
+          <p:nvPr/>
+        </p:nvSpPr>
+        <p:spPr>
+          <a:xfrm>
+            <a:off x="7863075" y="4596003"/>
+            <a:ext cx="2095500" cy="123825"/>
+          </a:xfrm>
+          <a:prstGeom prst="rect">
+            <a:avLst/>
+          </a:prstGeom>
+          <a:noFill/>
+        </p:spPr>
+        <p:txBody>
+          <a:bodyPr wrap="square" anchor="t" lIns="0" rIns="0" tIns="0" bIns="0">
+            <a:spAutoFit/>
+          </a:bodyPr>
+          <a:lstStyle/>
+          <a:p>
+            <a:pPr algn="ctr"/>
+            <a:r>
+              <a:rPr sz="900" b="1">
+                <a:solidFill>
+                  <a:srgbClr val="6B6B6B"/>
+                </a:solidFill>
+                <a:latin typeface="Neue Haas Grotesk Text Pro"/>
+              </a:rPr>
+              <a:t>Others 19%</a:t>
+            </a:r>
+          </a:p>
+        </p:txBody>
+      </p:sp>
+      <p:cxnSp>
+        <p:nvCxnSpPr>
+          <p:cNvPr id="66" name="Connector 65"/>
+          <p:cNvCxnSpPr/>
+          <p:nvPr/>
+        </p:nvCxnSpPr>
+        <p:spPr>
+          <a:xfrm>
+            <a:off x="4996815" y="5871972"/>
+            <a:ext cx="3735843" cy="0"/>
+          </a:xfrm>
+          <a:prstGeom prst="line">
+            <a:avLst/>
+          </a:prstGeom>
+          <a:ln w="12700">
+            <a:solidFill>
+              <a:srgbClr val="1E9E57"/>
+            </a:solidFill>
+          </a:ln>
+        </p:spPr>
+        <p:style>
+          <a:lnRef idx="2">
+            <a:schemeClr val="accent1"/>
+          </a:lnRef>
+          <a:fillRef idx="0">
+            <a:schemeClr val="accent1"/>
+          </a:fillRef>
+          <a:effectRef idx="1">
+            <a:schemeClr val="accent1"/>
+          </a:effectRef>
+          <a:fontRef idx="minor">
+            <a:schemeClr val="tx1"/>
+          </a:fontRef>
+        </p:style>
+      </p:cxnSp>
+      <p:cxnSp>
+        <p:nvCxnSpPr>
+          <p:cNvPr id="67" name="Connector 66"/>
+          <p:cNvCxnSpPr/>
+          <p:nvPr/>
+        </p:nvCxnSpPr>
+        <p:spPr>
+          <a:xfrm flipV="1">
+            <a:off x="4996815" y="5824347"/>
+            <a:ext cx="0" cy="47625"/>
+          </a:xfrm>
+          <a:prstGeom prst="line">
+            <a:avLst/>
+          </a:prstGeom>
+          <a:ln w="12700">
+            <a:solidFill>
+              <a:srgbClr val="1E9E57"/>
+            </a:solidFill>
+          </a:ln>
+        </p:spPr>
+        <p:style>
+          <a:lnRef idx="2">
+            <a:schemeClr val="accent1"/>
+          </a:lnRef>
+          <a:fillRef idx="0">
+            <a:schemeClr val="accent1"/>
+          </a:fillRef>
+          <a:effectRef idx="1">
+            <a:schemeClr val="accent1"/>
+          </a:effectRef>
+          <a:fontRef idx="minor">
+            <a:schemeClr val="tx1"/>
+          </a:fontRef>
+        </p:style>
+      </p:cxnSp>
+      <p:cxnSp>
+        <p:nvCxnSpPr>
+          <p:cNvPr id="68" name="Connector 67"/>
+          <p:cNvCxnSpPr/>
+          <p:nvPr/>
+        </p:nvCxnSpPr>
+        <p:spPr>
+          <a:xfrm flipV="1">
+            <a:off x="8732658" y="5824347"/>
+            <a:ext cx="0" cy="47625"/>
+          </a:xfrm>
+          <a:prstGeom prst="line">
+            <a:avLst/>
+          </a:prstGeom>
+          <a:ln w="12700">
+            <a:solidFill>
+              <a:srgbClr val="1E9E57"/>
+            </a:solidFill>
+          </a:ln>
+        </p:spPr>
+        <p:style>
+          <a:lnRef idx="2">
+            <a:schemeClr val="accent1"/>
+          </a:lnRef>
+          <a:fillRef idx="0">
+            <a:schemeClr val="accent1"/>
+          </a:fillRef>
+          <a:effectRef idx="1">
+            <a:schemeClr val="accent1"/>
+          </a:effectRef>
+          <a:fontRef idx="minor">
+            <a:schemeClr val="tx1"/>
+          </a:fontRef>
+        </p:style>
+      </p:cxnSp>
+      <p:cxnSp>
+        <p:nvCxnSpPr>
+          <p:cNvPr id="69" name="Connector 68"/>
+          <p:cNvCxnSpPr/>
+          <p:nvPr/>
+        </p:nvCxnSpPr>
+        <p:spPr>
+          <a:xfrm>
+            <a:off x="6864736" y="5871972"/>
+            <a:ext cx="0" cy="47625"/>
+          </a:xfrm>
+          <a:prstGeom prst="line">
+            <a:avLst/>
+          </a:prstGeom>
+          <a:ln w="12700">
+            <a:solidFill>
+              <a:srgbClr val="1E9E57"/>
+            </a:solidFill>
+          </a:ln>
+        </p:spPr>
+        <p:style>
+          <a:lnRef idx="2">
+            <a:schemeClr val="accent1"/>
+          </a:lnRef>
+          <a:fillRef idx="0">
+            <a:schemeClr val="accent1"/>
+          </a:fillRef>
+          <a:effectRef idx="1">
+            <a:schemeClr val="accent1"/>
+          </a:effectRef>
+          <a:fontRef idx="minor">
+            <a:schemeClr val="tx1"/>
+          </a:fontRef>
+        </p:style>
+      </p:cxnSp>
+      <p:sp>
+        <p:nvSpPr>
+          <p:cNvPr id="70" name="TextBox 69"/>
+          <p:cNvSpPr txBox="1"/>
+          <p:nvPr/>
+        </p:nvSpPr>
+        <p:spPr>
+          <a:xfrm>
+            <a:off x="5816986" y="5929122"/>
+            <a:ext cx="2095500" cy="123825"/>
+          </a:xfrm>
+          <a:prstGeom prst="rect">
+            <a:avLst/>
+          </a:prstGeom>
+          <a:noFill/>
+        </p:spPr>
+        <p:txBody>
+          <a:bodyPr wrap="square" anchor="t" lIns="0" rIns="0" tIns="0" bIns="0">
+            <a:spAutoFit/>
+          </a:bodyPr>
+          <a:lstStyle/>
+          <a:p>
+            <a:pPr algn="ctr"/>
+            <a:r>
+              <a:rPr sz="900" b="1">
+                <a:solidFill>
+                  <a:srgbClr val="1E9E57"/>
+                </a:solidFill>
+                <a:latin typeface="Neue Haas Grotesk Text Pro"/>
+              </a:rPr>
+              <a:t>3 brands = 86% of value</a:t>
+            </a:r>
+          </a:p>
+        </p:txBody>
+      </p:sp>
+      <p:cxnSp>
+        <p:nvCxnSpPr>
+          <p:cNvPr id="71" name="Connector 70"/>
+          <p:cNvCxnSpPr/>
+          <p:nvPr/>
+        </p:nvCxnSpPr>
+        <p:spPr>
+          <a:xfrm>
+            <a:off x="8751708" y="5871972"/>
+            <a:ext cx="567552" cy="0"/>
+          </a:xfrm>
+          <a:prstGeom prst="line">
+            <a:avLst/>
+          </a:prstGeom>
+          <a:ln w="12700">
+            <a:solidFill>
+              <a:srgbClr val="6B6B6B"/>
+            </a:solidFill>
+          </a:ln>
+        </p:spPr>
+        <p:style>
+          <a:lnRef idx="2">
+            <a:schemeClr val="accent1"/>
+          </a:lnRef>
+          <a:fillRef idx="0">
+            <a:schemeClr val="accent1"/>
+          </a:fillRef>
+          <a:effectRef idx="1">
+            <a:schemeClr val="accent1"/>
+          </a:effectRef>
+          <a:fontRef idx="minor">
+            <a:schemeClr val="tx1"/>
+          </a:fontRef>
+        </p:style>
+      </p:cxnSp>
+      <p:cxnSp>
+        <p:nvCxnSpPr>
+          <p:cNvPr id="72" name="Connector 71"/>
+          <p:cNvCxnSpPr/>
+          <p:nvPr/>
+        </p:nvCxnSpPr>
+        <p:spPr>
+          <a:xfrm flipV="1">
+            <a:off x="8751708" y="5824347"/>
+            <a:ext cx="0" cy="47625"/>
+          </a:xfrm>
+          <a:prstGeom prst="line">
+            <a:avLst/>
+          </a:prstGeom>
+          <a:ln w="12700">
+            <a:solidFill>
+              <a:srgbClr val="6B6B6B"/>
+            </a:solidFill>
+          </a:ln>
+        </p:spPr>
+        <p:style>
+          <a:lnRef idx="2">
+            <a:schemeClr val="accent1"/>
+          </a:lnRef>
+          <a:fillRef idx="0">
+            <a:schemeClr val="accent1"/>
+          </a:fillRef>
+          <a:effectRef idx="1">
+            <a:schemeClr val="accent1"/>
+          </a:effectRef>
+          <a:fontRef idx="minor">
+            <a:schemeClr val="tx1"/>
+          </a:fontRef>
+        </p:style>
+      </p:cxnSp>
+      <p:cxnSp>
+        <p:nvCxnSpPr>
+          <p:cNvPr id="73" name="Connector 72"/>
+          <p:cNvCxnSpPr/>
+          <p:nvPr/>
+        </p:nvCxnSpPr>
+        <p:spPr>
+          <a:xfrm flipV="1">
+            <a:off x="9319260" y="5824347"/>
+            <a:ext cx="0" cy="47625"/>
+          </a:xfrm>
+          <a:prstGeom prst="line">
+            <a:avLst/>
+          </a:prstGeom>
+          <a:ln w="12700">
+            <a:solidFill>
+              <a:srgbClr val="6B6B6B"/>
+            </a:solidFill>
+          </a:ln>
+        </p:spPr>
+        <p:style>
+          <a:lnRef idx="2">
+            <a:schemeClr val="accent1"/>
+          </a:lnRef>
+          <a:fillRef idx="0">
+            <a:schemeClr val="accent1"/>
+          </a:fillRef>
+          <a:effectRef idx="1">
+            <a:schemeClr val="accent1"/>
+          </a:effectRef>
+          <a:fontRef idx="minor">
+            <a:schemeClr val="tx1"/>
+          </a:fontRef>
+        </p:style>
+      </p:cxnSp>
+      <p:cxnSp>
+        <p:nvCxnSpPr>
+          <p:cNvPr id="74" name="Connector 73"/>
+          <p:cNvCxnSpPr/>
+          <p:nvPr/>
+        </p:nvCxnSpPr>
+        <p:spPr>
+          <a:xfrm>
+            <a:off x="9035484" y="5871972"/>
+            <a:ext cx="0" cy="47625"/>
+          </a:xfrm>
+          <a:prstGeom prst="line">
+            <a:avLst/>
+          </a:prstGeom>
+          <a:ln w="12700">
+            <a:solidFill>
+              <a:srgbClr val="6B6B6B"/>
+            </a:solidFill>
+          </a:ln>
+        </p:spPr>
+        <p:style>
+          <a:lnRef idx="2">
+            <a:schemeClr val="accent1"/>
+          </a:lnRef>
+          <a:fillRef idx="0">
+            <a:schemeClr val="accent1"/>
+          </a:fillRef>
+          <a:effectRef idx="1">
+            <a:schemeClr val="accent1"/>
+          </a:effectRef>
+          <a:fontRef idx="minor">
+            <a:schemeClr val="tx1"/>
+          </a:fontRef>
+        </p:style>
+      </p:cxnSp>
+      <p:sp>
+        <p:nvSpPr>
+          <p:cNvPr id="75" name="TextBox 74"/>
+          <p:cNvSpPr txBox="1"/>
+          <p:nvPr/>
+        </p:nvSpPr>
+        <p:spPr>
+          <a:xfrm>
+            <a:off x="7987734" y="5929122"/>
+            <a:ext cx="2095500" cy="123825"/>
+          </a:xfrm>
+          <a:prstGeom prst="rect">
+            <a:avLst/>
+          </a:prstGeom>
+          <a:noFill/>
+        </p:spPr>
+        <p:txBody>
+          <a:bodyPr wrap="square" anchor="t" lIns="0" rIns="0" tIns="0" bIns="0">
+            <a:spAutoFit/>
+          </a:bodyPr>
+          <a:lstStyle/>
+          <a:p>
+            <a:pPr algn="ctr"/>
+            <a:r>
+              <a:rPr sz="900" b="1">
+                <a:solidFill>
+                  <a:srgbClr val="6B6B6B"/>
+                </a:solidFill>
+                <a:latin typeface="Neue Haas Grotesk Text Pro"/>
+              </a:rPr>
+              <a:t>Others 14%</a:t>
+            </a:r>
+          </a:p>
+        </p:txBody>
+      </p:sp>
+      <p:sp>
+        <p:nvSpPr>
+          <p:cNvPr id="76" name="Rectangle 75"/>
           <p:cNvSpPr/>
           <p:nvPr/>
         </p:nvSpPr>
@@ -5855,7 +7277,7 @@
       </p:sp>
       <p:sp>
         <p:nvSpPr>
-          <p:cNvPr id="37" name="TextBox 36"/>
+          <p:cNvPr id="77" name="TextBox 76"/>
           <p:cNvSpPr txBox="1"/>
           <p:nvPr/>
         </p:nvSpPr>
@@ -5890,7 +7312,7 @@
       </p:sp>
       <p:pic>
         <p:nvPicPr>
-          <p:cNvPr id="38" name="Picture 37" descr="sany_palfinger.png"/>
+          <p:cNvPr id="78" name="Picture 77" descr="sany_palfinger.png"/>
           <p:cNvPicPr>
             <a:picLocks noChangeAspect="1"/>
           </p:cNvPicPr>
@@ -5914,7 +7336,7 @@
       </p:pic>
       <p:pic>
         <p:nvPicPr>
-          <p:cNvPr id="39" name="Picture 38" descr="xcmg.png"/>
+          <p:cNvPr id="79" name="Picture 78" descr="xcmg.png"/>
           <p:cNvPicPr>
             <a:picLocks noChangeAspect="1"/>
           </p:cNvPicPr>
@@ -5938,7 +7360,7 @@
       </p:pic>
       <p:pic>
         <p:nvPicPr>
-          <p:cNvPr id="40" name="Picture 39" descr="palfinger.png"/>
+          <p:cNvPr id="80" name="Picture 79" descr="palfinger.png"/>
           <p:cNvPicPr>
             <a:picLocks noChangeAspect="1"/>
           </p:cNvPicPr>
@@ -5962,7 +7384,7 @@
       </p:pic>
       <p:sp>
         <p:nvSpPr>
-          <p:cNvPr id="41" name="TextBox 40"/>
+          <p:cNvPr id="81" name="TextBox 80"/>
           <p:cNvSpPr txBox="1"/>
           <p:nvPr/>
         </p:nvSpPr>
@@ -6048,7 +7470,7 @@
       </p:sp>
       <p:sp>
         <p:nvSpPr>
-          <p:cNvPr id="42" name="Rectangle 41"/>
+          <p:cNvPr id="82" name="Rectangle 81"/>
           <p:cNvSpPr/>
           <p:nvPr/>
         </p:nvSpPr>
@@ -6093,7 +7515,7 @@
       </p:sp>
       <p:sp>
         <p:nvSpPr>
-          <p:cNvPr id="43" name="TextBox 42"/>
+          <p:cNvPr id="83" name="TextBox 82"/>
           <p:cNvSpPr txBox="1"/>
           <p:nvPr/>
         </p:nvSpPr>
@@ -6128,7 +7550,7 @@
       </p:sp>
       <p:pic>
         <p:nvPicPr>
-          <p:cNvPr id="44" name="Picture 43" descr="palfinger.png"/>
+          <p:cNvPr id="84" name="Picture 83" descr="palfinger.png"/>
           <p:cNvPicPr>
             <a:picLocks noChangeAspect="1"/>
           </p:cNvPicPr>
@@ -6152,7 +7574,7 @@
       </p:pic>
       <p:pic>
         <p:nvPicPr>
-          <p:cNvPr id="45" name="Picture 44" descr="amco_veba.png"/>
+          <p:cNvPr id="85" name="Picture 84" descr="amco_veba.png"/>
           <p:cNvPicPr>
             <a:picLocks noChangeAspect="1"/>
           </p:cNvPicPr>
@@ -6176,7 +7598,7 @@
       </p:pic>
       <p:pic>
         <p:nvPicPr>
-          <p:cNvPr id="46" name="Picture 45" descr="xcmg.png"/>
+          <p:cNvPr id="86" name="Picture 85" descr="xcmg.png"/>
           <p:cNvPicPr>
             <a:picLocks noChangeAspect="1"/>
           </p:cNvPicPr>
@@ -6200,7 +7622,7 @@
       </p:pic>
       <p:sp>
         <p:nvSpPr>
-          <p:cNvPr id="47" name="TextBox 46"/>
+          <p:cNvPr id="87" name="TextBox 86"/>
           <p:cNvSpPr txBox="1"/>
           <p:nvPr/>
         </p:nvSpPr>
@@ -6286,7 +7708,7 @@
       </p:sp>
       <p:sp>
         <p:nvSpPr>
-          <p:cNvPr id="48" name="TextBox 47"/>
+          <p:cNvPr id="88" name="TextBox 87"/>
           <p:cNvSpPr txBox="1"/>
           <p:nvPr/>
         </p:nvSpPr>
@@ -6330,7 +7752,7 @@
       </p:sp>
       <p:sp>
         <p:nvSpPr>
-          <p:cNvPr id="49" name="TextBox 48"/>
+          <p:cNvPr id="89" name="TextBox 88"/>
           <p:cNvSpPr txBox="1"/>
           <p:nvPr/>
         </p:nvSpPr>
@@ -6374,7 +7796,7 @@
       </p:sp>
       <p:cxnSp>
         <p:nvCxnSpPr>
-          <p:cNvPr id="50" name="Connector 49"/>
+          <p:cNvPr id="90" name="Connector 89"/>
           <p:cNvCxnSpPr/>
           <p:nvPr/>
         </p:nvCxnSpPr>

</xml_diff>